<commit_message>
Update winnercom.pptx - NG option note
</commit_message>
<xml_diff>
--- a/winnercom.pptx
+++ b/winnercom.pptx
@@ -13407,11 +13407,11 @@
         <p:spPr>
           <a:xfrm>
             <a:off x="7150608" y="2633472"/>
-            <a:ext cx="1554480" cy="621792"/>
+            <a:ext cx="1554480" cy="804672"/>
           </a:xfrm>
           <a:prstGeom prst="roundRect">
             <a:avLst>
-              <a:gd name="adj" fmla="val 8824"/>
+              <a:gd name="adj" fmla="val 6818"/>
             </a:avLst>
           </a:prstGeom>
           <a:solidFill>
@@ -13433,8 +13433,8 @@
         </p:nvSpPr>
         <p:spPr>
           <a:xfrm>
-            <a:off x="7150608" y="2670048"/>
-            <a:ext cx="1554480" cy="256032"/>
+            <a:off x="7150608" y="2651760"/>
+            <a:ext cx="1554480" cy="237744"/>
           </a:xfrm>
           <a:prstGeom prst="rect">
             <a:avLst/>
@@ -13472,8 +13472,8 @@
         </p:nvSpPr>
         <p:spPr>
           <a:xfrm>
-            <a:off x="7150608" y="2907792"/>
-            <a:ext cx="1554480" cy="329184"/>
+            <a:off x="7150608" y="2871216"/>
+            <a:ext cx="1554480" cy="292608"/>
           </a:xfrm>
           <a:prstGeom prst="rect">
             <a:avLst/>
@@ -13529,6 +13529,75 @@
       <p:sp>
         <p:nvSpPr>
           <p:cNvPr id="50" name="Shape 48"/>
+          <p:cNvSpPr/>
+          <p:nvPr/>
+        </p:nvSpPr>
+        <p:spPr>
+          <a:xfrm>
+            <a:off x="7205472" y="3163824"/>
+            <a:ext cx="1444752" cy="237744"/>
+          </a:xfrm>
+          <a:prstGeom prst="roundRect">
+            <a:avLst>
+              <a:gd name="adj" fmla="val 11538"/>
+            </a:avLst>
+          </a:prstGeom>
+          <a:solidFill>
+            <a:srgbClr val="FECACA"/>
+          </a:solidFill>
+          <a:ln w="12700">
+            <a:solidFill>
+              <a:srgbClr val="FECACA"/>
+            </a:solidFill>
+            <a:prstDash val="solid"/>
+          </a:ln>
+        </p:spPr>
+      </p:sp>
+      <p:sp>
+        <p:nvSpPr>
+          <p:cNvPr id="51" name="Text 49"/>
+          <p:cNvSpPr/>
+          <p:nvPr/>
+        </p:nvSpPr>
+        <p:spPr>
+          <a:xfrm>
+            <a:off x="7205472" y="3163824"/>
+            <a:ext cx="1444752" cy="237744"/>
+          </a:xfrm>
+          <a:prstGeom prst="rect">
+            <a:avLst/>
+          </a:prstGeom>
+          <a:noFill/>
+          <a:ln/>
+        </p:spPr>
+        <p:txBody>
+          <a:bodyPr wrap="square" lIns="0" tIns="0" rIns="0" bIns="0" rtlCol="0" anchor="ctr"/>
+          <a:lstStyle/>
+          <a:p>
+            <a:pPr algn="ctr" indent="0" marL="0">
+              <a:lnSpc>
+                <a:spcPct val="105000"/>
+              </a:lnSpc>
+              <a:buNone/>
+            </a:pPr>
+            <a:r>
+              <a:rPr lang="en-US" sz="650" dirty="0">
+                <a:solidFill>
+                  <a:srgbClr val="7F1D1D"/>
+                </a:solidFill>
+                <a:latin typeface="Noto Sans KR" pitchFamily="34" charset="0"/>
+                <a:ea typeface="Noto Sans KR" pitchFamily="34" charset="-122"/>
+                <a:cs typeface="Noto Sans KR" pitchFamily="34" charset="-120"/>
+              </a:rPr>
+              <a:t>※ 추후 옵션 — 독립 검사기 구조 시 가능</a:t>
+            </a:r>
+            <a:endParaRPr lang="en-US" sz="650" dirty="0"/>
+          </a:p>
+        </p:txBody>
+      </p:sp>
+      <p:sp>
+        <p:nvSpPr>
+          <p:cNvPr id="52" name="Shape 50"/>
           <p:cNvSpPr/>
           <p:nvPr/>
         </p:nvSpPr>
@@ -13562,7 +13631,7 @@
       </p:sp>
       <p:sp>
         <p:nvSpPr>
-          <p:cNvPr id="51" name="Text 49"/>
+          <p:cNvPr id="53" name="Text 51"/>
           <p:cNvSpPr/>
           <p:nvPr/>
         </p:nvSpPr>
@@ -13624,7 +13693,7 @@
       </p:sp>
       <p:sp>
         <p:nvSpPr>
-          <p:cNvPr id="52" name="Shape 50"/>
+          <p:cNvPr id="54" name="Shape 52"/>
           <p:cNvSpPr/>
           <p:nvPr/>
         </p:nvSpPr>
@@ -13658,7 +13727,7 @@
       </p:sp>
       <p:sp>
         <p:nvSpPr>
-          <p:cNvPr id="53" name="Text 51"/>
+          <p:cNvPr id="55" name="Text 53"/>
           <p:cNvSpPr/>
           <p:nvPr/>
         </p:nvSpPr>
@@ -13697,7 +13766,7 @@
       </p:sp>
       <p:sp>
         <p:nvSpPr>
-          <p:cNvPr id="54" name="Shape 52"/>
+          <p:cNvPr id="56" name="Shape 54"/>
           <p:cNvSpPr/>
           <p:nvPr/>
         </p:nvSpPr>
@@ -13731,7 +13800,7 @@
       </p:sp>
       <p:sp>
         <p:nvSpPr>
-          <p:cNvPr id="55" name="Shape 53"/>
+          <p:cNvPr id="57" name="Shape 55"/>
           <p:cNvSpPr/>
           <p:nvPr/>
         </p:nvSpPr>
@@ -13756,7 +13825,7 @@
       </p:sp>
       <p:sp>
         <p:nvSpPr>
-          <p:cNvPr id="56" name="Shape 54"/>
+          <p:cNvPr id="58" name="Shape 56"/>
           <p:cNvSpPr/>
           <p:nvPr/>
         </p:nvSpPr>
@@ -13781,7 +13850,7 @@
       </p:sp>
       <p:sp>
         <p:nvSpPr>
-          <p:cNvPr id="57" name="Text 55"/>
+          <p:cNvPr id="59" name="Text 57"/>
           <p:cNvSpPr/>
           <p:nvPr/>
         </p:nvSpPr>
@@ -13820,7 +13889,7 @@
       </p:sp>
       <p:sp>
         <p:nvSpPr>
-          <p:cNvPr id="58" name="Text 56"/>
+          <p:cNvPr id="60" name="Text 58"/>
           <p:cNvSpPr/>
           <p:nvPr/>
         </p:nvSpPr>
@@ -13859,7 +13928,7 @@
       </p:sp>
       <p:sp>
         <p:nvSpPr>
-          <p:cNvPr id="59" name="Text 57"/>
+          <p:cNvPr id="61" name="Text 59"/>
           <p:cNvSpPr/>
           <p:nvPr/>
         </p:nvSpPr>
@@ -13921,7 +13990,7 @@
       </p:sp>
       <p:sp>
         <p:nvSpPr>
-          <p:cNvPr id="60" name="Shape 58"/>
+          <p:cNvPr id="62" name="Shape 60"/>
           <p:cNvSpPr/>
           <p:nvPr/>
         </p:nvSpPr>
@@ -13955,7 +14024,7 @@
       </p:sp>
       <p:sp>
         <p:nvSpPr>
-          <p:cNvPr id="61" name="Text 59"/>
+          <p:cNvPr id="63" name="Text 61"/>
           <p:cNvSpPr/>
           <p:nvPr/>
         </p:nvSpPr>
@@ -13994,7 +14063,7 @@
       </p:sp>
       <p:sp>
         <p:nvSpPr>
-          <p:cNvPr id="62" name="Text 60"/>
+          <p:cNvPr id="64" name="Text 62"/>
           <p:cNvSpPr/>
           <p:nvPr/>
         </p:nvSpPr>

</xml_diff>

<commit_message>
Update winnercom.pptx - slide6 title with independent inspector note
</commit_message>
<xml_diff>
--- a/winnercom.pptx
+++ b/winnercom.pptx
@@ -8153,7 +8153,7 @@
                 <a:ea typeface="Noto Sans KR" pitchFamily="34" charset="-122"/>
                 <a:cs typeface="Noto Sans KR" pitchFamily="34" charset="-120"/>
               </a:rPr>
-              <a:t>설비 컨셉트 이미지</a:t>
+              <a:t>설비 컨셉트 이미지 (독립 검사기 예시)</a:t>
             </a:r>
             <a:endParaRPr lang="en-US" sz="1150" dirty="0"/>
           </a:p>
@@ -14251,7 +14251,7 @@
                 <a:ea typeface="Noto Sans KR" pitchFamily="34" charset="-122"/>
                 <a:cs typeface="Noto Sans KR" pitchFamily="34" charset="-120"/>
               </a:rPr>
-              <a:t>설비 컨셉트 이미지</a:t>
+              <a:t>설비 컨셉트 이미지  —  독립적인 검사기 예시</a:t>
             </a:r>
             <a:endParaRPr lang="en-US" sz="1800" dirty="0"/>
           </a:p>

</xml_diff>

<commit_message>
Update winnercom.pptx - slide7 title
</commit_message>
<xml_diff>
--- a/winnercom.pptx
+++ b/winnercom.pptx
@@ -8265,7 +8265,7 @@
                 <a:ea typeface="Noto Sans KR" pitchFamily="34" charset="-122"/>
                 <a:cs typeface="Noto Sans KR" pitchFamily="34" charset="-120"/>
               </a:rPr>
-              <a:t>시스템 구성 &amp; MES 데이터 연계</a:t>
+              <a:t>시스템 구성 &amp; MES 연계 (딥러닝 검사 확인 후)</a:t>
             </a:r>
             <a:endParaRPr lang="en-US" sz="1150" dirty="0"/>
           </a:p>
@@ -14388,7 +14388,7 @@
                 <a:ea typeface="Noto Sans KR" pitchFamily="34" charset="-122"/>
                 <a:cs typeface="Noto Sans KR" pitchFamily="34" charset="-120"/>
               </a:rPr>
-              <a:t>시스템 구성 &amp; MES 데이터 연계</a:t>
+              <a:t>시스템 구성 &amp; MES 데이터 연계 (딥러닝 검사 확인 후)</a:t>
             </a:r>
             <a:endParaRPr lang="en-US" sz="2200" dirty="0"/>
           </a:p>

</xml_diff>

<commit_message>
Update winnercom.pptx - phased rollout strategy
</commit_message>
<xml_diff>
--- a/winnercom.pptx
+++ b/winnercom.pptx
@@ -2276,7 +2276,7 @@
                 <a:ea typeface="Noto Sans KR" pitchFamily="34" charset="-122"/>
                 <a:cs typeface="Noto Sans KR" pitchFamily="34" charset="-120"/>
               </a:rPr>
-              <a:t>진행 절차 &amp; 개발 일정</a:t>
+              <a:t>진행 절차 — 단계별 도입 전략</a:t>
             </a:r>
             <a:endParaRPr lang="en-US" sz="2200" dirty="0"/>
           </a:p>
@@ -2315,7 +2315,7 @@
                 <a:ea typeface="Noto Sans KR" pitchFamily="34" charset="-122"/>
                 <a:cs typeface="Noto Sans KR" pitchFamily="34" charset="-120"/>
               </a:rPr>
-              <a:t>샘플 입수부터 현장 가동까지</a:t>
+              <a:t>1호기는 딥러닝 검출력 검증에 집중, 자동화 기능은 효과 확인 후 협의</a:t>
             </a:r>
             <a:endParaRPr lang="en-US" sz="1050" dirty="0"/>
           </a:p>
@@ -2329,20 +2329,20 @@
         </p:nvSpPr>
         <p:spPr>
           <a:xfrm>
-            <a:off x="365760" y="1060704"/>
-            <a:ext cx="1139081" cy="1005840"/>
+            <a:off x="365760" y="1024128"/>
+            <a:ext cx="8412480" cy="402336"/>
           </a:xfrm>
           <a:prstGeom prst="roundRect">
             <a:avLst>
-              <a:gd name="adj" fmla="val 6364"/>
+              <a:gd name="adj" fmla="val 15909"/>
             </a:avLst>
           </a:prstGeom>
           <a:solidFill>
-            <a:srgbClr val="FFFFFF"/>
-          </a:solidFill>
-          <a:ln w="19050">
-            <a:solidFill>
-              <a:srgbClr val="E2E8F0"/>
+            <a:srgbClr val="1B3A6B"/>
+          </a:solidFill>
+          <a:ln w="12700">
+            <a:solidFill>
+              <a:srgbClr val="2E5EA8"/>
             </a:solidFill>
             <a:prstDash val="solid"/>
           </a:ln>
@@ -2357,175 +2357,65 @@
       </p:sp>
       <p:sp>
         <p:nvSpPr>
-          <p:cNvPr id="7" name="Shape 5"/>
-          <p:cNvSpPr/>
-          <p:nvPr/>
-        </p:nvSpPr>
-        <p:spPr>
-          <a:xfrm>
-            <a:off x="697557" y="1152144"/>
-            <a:ext cx="475488" cy="475488"/>
-          </a:xfrm>
-          <a:prstGeom prst="ellipse">
-            <a:avLst/>
-          </a:prstGeom>
-          <a:solidFill>
-            <a:srgbClr val="DBEAFE"/>
-          </a:solidFill>
-          <a:ln w="12700">
-            <a:solidFill>
-              <a:srgbClr val="DBEAFE"/>
-            </a:solidFill>
-            <a:prstDash val="solid"/>
-          </a:ln>
-        </p:spPr>
-      </p:sp>
-      <p:sp>
-        <p:nvSpPr>
-          <p:cNvPr id="8" name="Text 6"/>
-          <p:cNvSpPr/>
-          <p:nvPr/>
-        </p:nvSpPr>
-        <p:spPr>
-          <a:xfrm>
-            <a:off x="697557" y="1152144"/>
-            <a:ext cx="475488" cy="475488"/>
-          </a:xfrm>
-          <a:prstGeom prst="rect">
-            <a:avLst/>
-          </a:prstGeom>
-          <a:noFill/>
-          <a:ln/>
-        </p:spPr>
-        <p:txBody>
-          <a:bodyPr wrap="square" lIns="0" tIns="0" rIns="0" bIns="0" rtlCol="0" anchor="ctr"/>
-          <a:lstStyle/>
-          <a:p>
-            <a:pPr algn="ctr" indent="0" marL="0">
-              <a:buNone/>
-            </a:pPr>
-            <a:r>
-              <a:rPr lang="en-US" sz="1000" b="1" dirty="0">
-                <a:solidFill>
-                  <a:srgbClr val="2563EB"/>
-                </a:solidFill>
-                <a:latin typeface="Noto Sans KR" pitchFamily="34" charset="0"/>
-                <a:ea typeface="Noto Sans KR" pitchFamily="34" charset="-122"/>
-                <a:cs typeface="Noto Sans KR" pitchFamily="34" charset="-120"/>
-              </a:rPr>
-              <a:t>01</a:t>
-            </a:r>
-            <a:endParaRPr lang="en-US" sz="1000" dirty="0"/>
-          </a:p>
-        </p:txBody>
-      </p:sp>
-      <p:sp>
-        <p:nvSpPr>
-          <p:cNvPr id="9" name="Text 7"/>
-          <p:cNvSpPr/>
-          <p:nvPr/>
-        </p:nvSpPr>
-        <p:spPr>
-          <a:xfrm>
-            <a:off x="402336" y="1700784"/>
-            <a:ext cx="1065929" cy="256032"/>
-          </a:xfrm>
-          <a:prstGeom prst="rect">
-            <a:avLst/>
-          </a:prstGeom>
-          <a:noFill/>
-          <a:ln/>
-        </p:spPr>
-        <p:txBody>
-          <a:bodyPr wrap="square" lIns="0" tIns="0" rIns="0" bIns="0" rtlCol="0" anchor="ctr"/>
-          <a:lstStyle/>
-          <a:p>
-            <a:pPr algn="ctr" indent="0" marL="0">
-              <a:lnSpc>
-                <a:spcPct val="110000"/>
-              </a:lnSpc>
-              <a:buNone/>
-            </a:pPr>
-            <a:r>
-              <a:rPr lang="en-US" sz="900" b="1" dirty="0">
-                <a:solidFill>
-                  <a:srgbClr val="1B2F5E"/>
-                </a:solidFill>
-                <a:latin typeface="Noto Sans KR" pitchFamily="34" charset="0"/>
-                <a:ea typeface="Noto Sans KR" pitchFamily="34" charset="-122"/>
-                <a:cs typeface="Noto Sans KR" pitchFamily="34" charset="-120"/>
-              </a:rPr>
-              <a:t>샘플</a:t>
-            </a:r>
-            <a:endParaRPr lang="en-US" sz="900" dirty="0"/>
-          </a:p>
-          <a:p>
-            <a:pPr algn="ctr" indent="0" marL="0">
-              <a:lnSpc>
-                <a:spcPct val="110000"/>
-              </a:lnSpc>
-              <a:buNone/>
-            </a:pPr>
-            <a:r>
-              <a:rPr lang="en-US" sz="900" b="1" dirty="0">
-                <a:solidFill>
-                  <a:srgbClr val="1B2F5E"/>
-                </a:solidFill>
-                <a:latin typeface="Noto Sans KR" pitchFamily="34" charset="0"/>
-                <a:ea typeface="Noto Sans KR" pitchFamily="34" charset="-122"/>
-                <a:cs typeface="Noto Sans KR" pitchFamily="34" charset="-120"/>
-              </a:rPr>
-              <a:t>입수</a:t>
-            </a:r>
-            <a:endParaRPr lang="en-US" sz="900" dirty="0"/>
-          </a:p>
-        </p:txBody>
-      </p:sp>
-      <p:sp>
-        <p:nvSpPr>
-          <p:cNvPr id="10" name="Shape 8"/>
-          <p:cNvSpPr/>
-          <p:nvPr/>
-        </p:nvSpPr>
-        <p:spPr>
-          <a:xfrm>
-            <a:off x="1504841" y="1563624"/>
-            <a:ext cx="73152" cy="0"/>
-          </a:xfrm>
-          <a:prstGeom prst="line">
-            <a:avLst/>
-          </a:prstGeom>
-          <a:noFill/>
-          <a:ln w="15240">
-            <a:solidFill>
-              <a:srgbClr val="94A3B8"/>
-            </a:solidFill>
-            <a:prstDash val="solid"/>
-          </a:ln>
-        </p:spPr>
-      </p:sp>
-      <p:sp>
-        <p:nvSpPr>
-          <p:cNvPr id="11" name="Shape 9"/>
-          <p:cNvSpPr/>
-          <p:nvPr/>
-        </p:nvSpPr>
-        <p:spPr>
-          <a:xfrm>
-            <a:off x="1577993" y="1060704"/>
-            <a:ext cx="1139081" cy="1005840"/>
+          <p:cNvPr id="7" name="Text 5"/>
+          <p:cNvSpPr/>
+          <p:nvPr/>
+        </p:nvSpPr>
+        <p:spPr>
+          <a:xfrm>
+            <a:off x="548640" y="1024128"/>
+            <a:ext cx="8046720" cy="402336"/>
+          </a:xfrm>
+          <a:prstGeom prst="rect">
+            <a:avLst/>
+          </a:prstGeom>
+          <a:noFill/>
+          <a:ln/>
+        </p:spPr>
+        <p:txBody>
+          <a:bodyPr wrap="square" lIns="0" tIns="0" rIns="0" bIns="0" rtlCol="0" anchor="ctr"/>
+          <a:lstStyle/>
+          <a:p>
+            <a:pPr indent="0" marL="0">
+              <a:buNone/>
+            </a:pPr>
+            <a:r>
+              <a:rPr lang="en-US" sz="950" dirty="0">
+                <a:solidFill>
+                  <a:srgbClr val="A5C4F3"/>
+                </a:solidFill>
+                <a:latin typeface="Noto Sans KR" pitchFamily="34" charset="0"/>
+                <a:ea typeface="Noto Sans KR" pitchFamily="34" charset="-122"/>
+                <a:cs typeface="Noto Sans KR" pitchFamily="34" charset="-120"/>
+              </a:rPr>
+              <a:t>💡  상호 비용·시간 부담을 최소화하고 빠른 효과 검증을 위해, 1호기는 딥러닝 양불 판정 검증 전용으로 제작합니다.</a:t>
+            </a:r>
+            <a:endParaRPr lang="en-US" sz="950" dirty="0"/>
+          </a:p>
+        </p:txBody>
+      </p:sp>
+      <p:sp>
+        <p:nvSpPr>
+          <p:cNvPr id="8" name="Shape 6"/>
+          <p:cNvSpPr/>
+          <p:nvPr/>
+        </p:nvSpPr>
+        <p:spPr>
+          <a:xfrm>
+            <a:off x="365760" y="1517904"/>
+            <a:ext cx="4114800" cy="1645920"/>
           </a:xfrm>
           <a:prstGeom prst="roundRect">
             <a:avLst>
-              <a:gd name="adj" fmla="val 6364"/>
+              <a:gd name="adj" fmla="val 3889"/>
             </a:avLst>
           </a:prstGeom>
           <a:solidFill>
-            <a:srgbClr val="1B2F5E"/>
-          </a:solidFill>
-          <a:ln w="19050">
-            <a:solidFill>
-              <a:srgbClr val="1B2F5E"/>
+            <a:srgbClr val="FFFFFF"/>
+          </a:solidFill>
+          <a:ln w="25400">
+            <a:solidFill>
+              <a:srgbClr val="2563EB"/>
             </a:solidFill>
             <a:prstDash val="solid"/>
           </a:ln>
@@ -2540,175 +2430,92 @@
       </p:sp>
       <p:sp>
         <p:nvSpPr>
-          <p:cNvPr id="12" name="Shape 10"/>
-          <p:cNvSpPr/>
-          <p:nvPr/>
-        </p:nvSpPr>
-        <p:spPr>
-          <a:xfrm>
-            <a:off x="1909790" y="1152144"/>
-            <a:ext cx="475488" cy="475488"/>
-          </a:xfrm>
-          <a:prstGeom prst="ellipse">
-            <a:avLst/>
-          </a:prstGeom>
-          <a:solidFill>
-            <a:srgbClr val="F59E0B"/>
-          </a:solidFill>
-          <a:ln w="12700">
-            <a:solidFill>
-              <a:srgbClr val="F59E0B"/>
-            </a:solidFill>
-            <a:prstDash val="solid"/>
-          </a:ln>
-        </p:spPr>
-      </p:sp>
-      <p:sp>
-        <p:nvSpPr>
-          <p:cNvPr id="13" name="Text 11"/>
-          <p:cNvSpPr/>
-          <p:nvPr/>
-        </p:nvSpPr>
-        <p:spPr>
-          <a:xfrm>
-            <a:off x="1909790" y="1152144"/>
-            <a:ext cx="475488" cy="475488"/>
-          </a:xfrm>
-          <a:prstGeom prst="rect">
-            <a:avLst/>
-          </a:prstGeom>
-          <a:noFill/>
-          <a:ln/>
-        </p:spPr>
-        <p:txBody>
-          <a:bodyPr wrap="square" lIns="0" tIns="0" rIns="0" bIns="0" rtlCol="0" anchor="ctr"/>
-          <a:lstStyle/>
-          <a:p>
-            <a:pPr algn="ctr" indent="0" marL="0">
-              <a:buNone/>
-            </a:pPr>
-            <a:r>
-              <a:rPr lang="en-US" sz="1000" b="1" dirty="0">
-                <a:solidFill>
-                  <a:srgbClr val="1B2F5E"/>
-                </a:solidFill>
-                <a:latin typeface="Noto Sans KR" pitchFamily="34" charset="0"/>
-                <a:ea typeface="Noto Sans KR" pitchFamily="34" charset="-122"/>
-                <a:cs typeface="Noto Sans KR" pitchFamily="34" charset="-120"/>
-              </a:rPr>
-              <a:t>02</a:t>
-            </a:r>
-            <a:endParaRPr lang="en-US" sz="1000" dirty="0"/>
-          </a:p>
-        </p:txBody>
-      </p:sp>
-      <p:sp>
-        <p:nvSpPr>
-          <p:cNvPr id="14" name="Text 12"/>
-          <p:cNvSpPr/>
-          <p:nvPr/>
-        </p:nvSpPr>
-        <p:spPr>
-          <a:xfrm>
-            <a:off x="1614569" y="1700784"/>
-            <a:ext cx="1065929" cy="256032"/>
-          </a:xfrm>
-          <a:prstGeom prst="rect">
-            <a:avLst/>
-          </a:prstGeom>
-          <a:noFill/>
-          <a:ln/>
-        </p:spPr>
-        <p:txBody>
-          <a:bodyPr wrap="square" lIns="0" tIns="0" rIns="0" bIns="0" rtlCol="0" anchor="ctr"/>
-          <a:lstStyle/>
-          <a:p>
-            <a:pPr algn="ctr" indent="0" marL="0">
-              <a:lnSpc>
-                <a:spcPct val="110000"/>
-              </a:lnSpc>
-              <a:buNone/>
-            </a:pPr>
-            <a:r>
-              <a:rPr lang="en-US" sz="900" b="1" dirty="0">
-                <a:solidFill>
-                  <a:srgbClr val="FFFFFF"/>
-                </a:solidFill>
-                <a:latin typeface="Noto Sans KR" pitchFamily="34" charset="0"/>
-                <a:ea typeface="Noto Sans KR" pitchFamily="34" charset="-122"/>
-                <a:cs typeface="Noto Sans KR" pitchFamily="34" charset="-120"/>
-              </a:rPr>
-              <a:t>검토</a:t>
-            </a:r>
-            <a:endParaRPr lang="en-US" sz="900" dirty="0"/>
-          </a:p>
-          <a:p>
-            <a:pPr algn="ctr" indent="0" marL="0">
-              <a:lnSpc>
-                <a:spcPct val="110000"/>
-              </a:lnSpc>
-              <a:buNone/>
-            </a:pPr>
-            <a:r>
-              <a:rPr lang="en-US" sz="900" b="1" dirty="0">
-                <a:solidFill>
-                  <a:srgbClr val="FFFFFF"/>
-                </a:solidFill>
-                <a:latin typeface="Noto Sans KR" pitchFamily="34" charset="0"/>
-                <a:ea typeface="Noto Sans KR" pitchFamily="34" charset="-122"/>
-                <a:cs typeface="Noto Sans KR" pitchFamily="34" charset="-120"/>
-              </a:rPr>
-              <a:t>리포트</a:t>
-            </a:r>
-            <a:endParaRPr lang="en-US" sz="900" dirty="0"/>
-          </a:p>
-        </p:txBody>
-      </p:sp>
-      <p:sp>
-        <p:nvSpPr>
-          <p:cNvPr id="15" name="Shape 13"/>
-          <p:cNvSpPr/>
-          <p:nvPr/>
-        </p:nvSpPr>
-        <p:spPr>
-          <a:xfrm>
-            <a:off x="2717074" y="1563624"/>
-            <a:ext cx="73152" cy="0"/>
-          </a:xfrm>
-          <a:prstGeom prst="line">
-            <a:avLst/>
-          </a:prstGeom>
-          <a:noFill/>
-          <a:ln w="15240">
-            <a:solidFill>
-              <a:srgbClr val="94A3B8"/>
-            </a:solidFill>
-            <a:prstDash val="solid"/>
-          </a:ln>
-        </p:spPr>
-      </p:sp>
-      <p:sp>
-        <p:nvSpPr>
-          <p:cNvPr id="16" name="Shape 14"/>
-          <p:cNvSpPr/>
-          <p:nvPr/>
-        </p:nvSpPr>
-        <p:spPr>
-          <a:xfrm>
-            <a:off x="2790226" y="1060704"/>
-            <a:ext cx="1139081" cy="1005840"/>
+          <p:cNvPr id="9" name="Shape 7"/>
+          <p:cNvSpPr/>
+          <p:nvPr/>
+        </p:nvSpPr>
+        <p:spPr>
+          <a:xfrm>
+            <a:off x="365760" y="1517904"/>
+            <a:ext cx="4114800" cy="365760"/>
           </a:xfrm>
           <a:prstGeom prst="roundRect">
             <a:avLst>
-              <a:gd name="adj" fmla="val 6364"/>
+              <a:gd name="adj" fmla="val 17500"/>
             </a:avLst>
           </a:prstGeom>
           <a:solidFill>
-            <a:srgbClr val="FFFFFF"/>
-          </a:solidFill>
-          <a:ln w="19050">
-            <a:solidFill>
-              <a:srgbClr val="E2E8F0"/>
+            <a:srgbClr val="2563EB"/>
+          </a:solidFill>
+          <a:ln w="12700">
+            <a:solidFill>
+              <a:srgbClr val="2563EB"/>
+            </a:solidFill>
+            <a:prstDash val="solid"/>
+          </a:ln>
+        </p:spPr>
+      </p:sp>
+      <p:sp>
+        <p:nvSpPr>
+          <p:cNvPr id="10" name="Text 8"/>
+          <p:cNvSpPr/>
+          <p:nvPr/>
+        </p:nvSpPr>
+        <p:spPr>
+          <a:xfrm>
+            <a:off x="365760" y="1517904"/>
+            <a:ext cx="4114800" cy="365760"/>
+          </a:xfrm>
+          <a:prstGeom prst="rect">
+            <a:avLst/>
+          </a:prstGeom>
+          <a:noFill/>
+          <a:ln/>
+        </p:spPr>
+        <p:txBody>
+          <a:bodyPr wrap="square" lIns="0" tIns="0" rIns="0" bIns="0" rtlCol="0" anchor="ctr"/>
+          <a:lstStyle/>
+          <a:p>
+            <a:pPr algn="ctr" indent="0" marL="0">
+              <a:buNone/>
+            </a:pPr>
+            <a:r>
+              <a:rPr lang="en-US" sz="1100" b="1" dirty="0">
+                <a:solidFill>
+                  <a:srgbClr val="FFFFFF"/>
+                </a:solidFill>
+                <a:latin typeface="Noto Sans KR" pitchFamily="34" charset="0"/>
+                <a:ea typeface="Noto Sans KR" pitchFamily="34" charset="-122"/>
+                <a:cs typeface="Noto Sans KR" pitchFamily="34" charset="-120"/>
+              </a:rPr>
+              <a:t>STEP 1  —  1호기 (검증 전용)</a:t>
+            </a:r>
+            <a:endParaRPr lang="en-US" sz="1100" dirty="0"/>
+          </a:p>
+        </p:txBody>
+      </p:sp>
+      <p:sp>
+        <p:nvSpPr>
+          <p:cNvPr id="11" name="Shape 9"/>
+          <p:cNvSpPr/>
+          <p:nvPr/>
+        </p:nvSpPr>
+        <p:spPr>
+          <a:xfrm>
+            <a:off x="475488" y="1938528"/>
+            <a:ext cx="3895344" cy="274320"/>
+          </a:xfrm>
+          <a:prstGeom prst="roundRect">
+            <a:avLst>
+              <a:gd name="adj" fmla="val 23333"/>
+            </a:avLst>
+          </a:prstGeom>
+          <a:solidFill>
+            <a:srgbClr val="DBEAFE"/>
+          </a:solidFill>
+          <a:ln w="12700">
+            <a:solidFill>
+              <a:srgbClr val="DBEAFE"/>
             </a:solidFill>
             <a:prstDash val="solid"/>
           </a:ln>
@@ -2723,97 +2530,30 @@
       </p:sp>
       <p:sp>
         <p:nvSpPr>
-          <p:cNvPr id="17" name="Shape 15"/>
-          <p:cNvSpPr/>
-          <p:nvPr/>
-        </p:nvSpPr>
-        <p:spPr>
-          <a:xfrm>
-            <a:off x="3122023" y="1152144"/>
-            <a:ext cx="475488" cy="475488"/>
-          </a:xfrm>
-          <a:prstGeom prst="ellipse">
-            <a:avLst/>
-          </a:prstGeom>
-          <a:solidFill>
-            <a:srgbClr val="DBEAFE"/>
-          </a:solidFill>
-          <a:ln w="12700">
-            <a:solidFill>
-              <a:srgbClr val="DBEAFE"/>
-            </a:solidFill>
-            <a:prstDash val="solid"/>
-          </a:ln>
-        </p:spPr>
-      </p:sp>
-      <p:sp>
-        <p:nvSpPr>
-          <p:cNvPr id="18" name="Text 16"/>
-          <p:cNvSpPr/>
-          <p:nvPr/>
-        </p:nvSpPr>
-        <p:spPr>
-          <a:xfrm>
-            <a:off x="3122023" y="1152144"/>
-            <a:ext cx="475488" cy="475488"/>
-          </a:xfrm>
-          <a:prstGeom prst="rect">
-            <a:avLst/>
-          </a:prstGeom>
-          <a:noFill/>
-          <a:ln/>
-        </p:spPr>
-        <p:txBody>
-          <a:bodyPr wrap="square" lIns="0" tIns="0" rIns="0" bIns="0" rtlCol="0" anchor="ctr"/>
-          <a:lstStyle/>
-          <a:p>
-            <a:pPr algn="ctr" indent="0" marL="0">
-              <a:buNone/>
-            </a:pPr>
-            <a:r>
-              <a:rPr lang="en-US" sz="1000" b="1" dirty="0">
-                <a:solidFill>
-                  <a:srgbClr val="2563EB"/>
-                </a:solidFill>
-                <a:latin typeface="Noto Sans KR" pitchFamily="34" charset="0"/>
-                <a:ea typeface="Noto Sans KR" pitchFamily="34" charset="-122"/>
-                <a:cs typeface="Noto Sans KR" pitchFamily="34" charset="-120"/>
-              </a:rPr>
-              <a:t>03</a:t>
-            </a:r>
-            <a:endParaRPr lang="en-US" sz="1000" dirty="0"/>
-          </a:p>
-        </p:txBody>
-      </p:sp>
-      <p:sp>
-        <p:nvSpPr>
-          <p:cNvPr id="19" name="Text 17"/>
-          <p:cNvSpPr/>
-          <p:nvPr/>
-        </p:nvSpPr>
-        <p:spPr>
-          <a:xfrm>
-            <a:off x="2826802" y="1700784"/>
-            <a:ext cx="1065929" cy="256032"/>
-          </a:xfrm>
-          <a:prstGeom prst="rect">
-            <a:avLst/>
-          </a:prstGeom>
-          <a:noFill/>
-          <a:ln/>
-        </p:spPr>
-        <p:txBody>
-          <a:bodyPr wrap="square" lIns="0" tIns="0" rIns="0" bIns="0" rtlCol="0" anchor="ctr"/>
-          <a:lstStyle/>
-          <a:p>
-            <a:pPr algn="ctr" indent="0" marL="0">
-              <a:lnSpc>
-                <a:spcPct val="110000"/>
-              </a:lnSpc>
-              <a:buNone/>
-            </a:pPr>
-            <a:r>
-              <a:rPr lang="en-US" sz="900" b="1" dirty="0">
+          <p:cNvPr id="12" name="Text 10"/>
+          <p:cNvSpPr/>
+          <p:nvPr/>
+        </p:nvSpPr>
+        <p:spPr>
+          <a:xfrm>
+            <a:off x="548640" y="1956816"/>
+            <a:ext cx="1325880" cy="237744"/>
+          </a:xfrm>
+          <a:prstGeom prst="rect">
+            <a:avLst/>
+          </a:prstGeom>
+          <a:noFill/>
+          <a:ln/>
+        </p:spPr>
+        <p:txBody>
+          <a:bodyPr wrap="square" lIns="0" tIns="0" rIns="0" bIns="0" rtlCol="0" anchor="ctr"/>
+          <a:lstStyle/>
+          <a:p>
+            <a:pPr indent="0" marL="0">
+              <a:buNone/>
+            </a:pPr>
+            <a:r>
+              <a:rPr lang="en-US" sz="850" b="1" dirty="0">
                 <a:solidFill>
                   <a:srgbClr val="1B2F5E"/>
                 </a:solidFill>
@@ -2821,77 +2561,73 @@
                 <a:ea typeface="Noto Sans KR" pitchFamily="34" charset="-122"/>
                 <a:cs typeface="Noto Sans KR" pitchFamily="34" charset="-120"/>
               </a:rPr>
-              <a:t>현장</a:t>
-            </a:r>
-            <a:endParaRPr lang="en-US" sz="900" dirty="0"/>
-          </a:p>
-          <a:p>
-            <a:pPr algn="ctr" indent="0" marL="0">
-              <a:lnSpc>
-                <a:spcPct val="110000"/>
-              </a:lnSpc>
-              <a:buNone/>
-            </a:pPr>
-            <a:r>
-              <a:rPr lang="en-US" sz="900" b="1" dirty="0">
-                <a:solidFill>
-                  <a:srgbClr val="1B2F5E"/>
-                </a:solidFill>
-                <a:latin typeface="Noto Sans KR" pitchFamily="34" charset="0"/>
-                <a:ea typeface="Noto Sans KR" pitchFamily="34" charset="-122"/>
-                <a:cs typeface="Noto Sans KR" pitchFamily="34" charset="-120"/>
-              </a:rPr>
-              <a:t>실사</a:t>
-            </a:r>
-            <a:endParaRPr lang="en-US" sz="900" dirty="0"/>
-          </a:p>
-        </p:txBody>
-      </p:sp>
-      <p:sp>
-        <p:nvSpPr>
-          <p:cNvPr id="20" name="Shape 18"/>
-          <p:cNvSpPr/>
-          <p:nvPr/>
-        </p:nvSpPr>
-        <p:spPr>
-          <a:xfrm>
-            <a:off x="3929307" y="1563624"/>
-            <a:ext cx="73152" cy="0"/>
-          </a:xfrm>
-          <a:prstGeom prst="line">
-            <a:avLst/>
-          </a:prstGeom>
-          <a:noFill/>
-          <a:ln w="15240">
-            <a:solidFill>
-              <a:srgbClr val="94A3B8"/>
-            </a:solidFill>
-            <a:prstDash val="solid"/>
-          </a:ln>
-        </p:spPr>
-      </p:sp>
-      <p:sp>
-        <p:nvSpPr>
-          <p:cNvPr id="21" name="Shape 19"/>
-          <p:cNvSpPr/>
-          <p:nvPr/>
-        </p:nvSpPr>
-        <p:spPr>
-          <a:xfrm>
-            <a:off x="4002459" y="1060704"/>
-            <a:ext cx="1139081" cy="1005840"/>
+              <a:t>투입·배출·스캔</a:t>
+            </a:r>
+            <a:endParaRPr lang="en-US" sz="850" dirty="0"/>
+          </a:p>
+        </p:txBody>
+      </p:sp>
+      <p:sp>
+        <p:nvSpPr>
+          <p:cNvPr id="13" name="Text 11"/>
+          <p:cNvSpPr/>
+          <p:nvPr/>
+        </p:nvSpPr>
+        <p:spPr>
+          <a:xfrm>
+            <a:off x="1901952" y="1956816"/>
+            <a:ext cx="2468880" cy="237744"/>
+          </a:xfrm>
+          <a:prstGeom prst="rect">
+            <a:avLst/>
+          </a:prstGeom>
+          <a:noFill/>
+          <a:ln/>
+        </p:spPr>
+        <p:txBody>
+          <a:bodyPr wrap="square" lIns="0" tIns="0" rIns="0" bIns="0" rtlCol="0" anchor="ctr"/>
+          <a:lstStyle/>
+          <a:p>
+            <a:pPr indent="0" marL="0">
+              <a:buNone/>
+            </a:pPr>
+            <a:r>
+              <a:rPr lang="en-US" sz="850" dirty="0">
+                <a:solidFill>
+                  <a:srgbClr val="475569"/>
+                </a:solidFill>
+                <a:latin typeface="Noto Sans KR" pitchFamily="34" charset="0"/>
+                <a:ea typeface="Noto Sans KR" pitchFamily="34" charset="-122"/>
+                <a:cs typeface="Noto Sans KR" pitchFamily="34" charset="-120"/>
+              </a:rPr>
+              <a:t>수작업 진행 (자동화 미적용)</a:t>
+            </a:r>
+            <a:endParaRPr lang="en-US" sz="850" dirty="0"/>
+          </a:p>
+        </p:txBody>
+      </p:sp>
+      <p:sp>
+        <p:nvSpPr>
+          <p:cNvPr id="14" name="Shape 12"/>
+          <p:cNvSpPr/>
+          <p:nvPr/>
+        </p:nvSpPr>
+        <p:spPr>
+          <a:xfrm>
+            <a:off x="475488" y="2249424"/>
+            <a:ext cx="3895344" cy="274320"/>
           </a:xfrm>
           <a:prstGeom prst="roundRect">
             <a:avLst>
-              <a:gd name="adj" fmla="val 6364"/>
+              <a:gd name="adj" fmla="val 23333"/>
             </a:avLst>
           </a:prstGeom>
           <a:solidFill>
-            <a:srgbClr val="FFFFFF"/>
-          </a:solidFill>
-          <a:ln w="19050">
-            <a:solidFill>
-              <a:srgbClr val="E2E8F0"/>
+            <a:srgbClr val="DBEAFE"/>
+          </a:solidFill>
+          <a:ln w="12700">
+            <a:solidFill>
+              <a:srgbClr val="DBEAFE"/>
             </a:solidFill>
             <a:prstDash val="solid"/>
           </a:ln>
@@ -2906,97 +2642,30 @@
       </p:sp>
       <p:sp>
         <p:nvSpPr>
-          <p:cNvPr id="22" name="Shape 20"/>
-          <p:cNvSpPr/>
-          <p:nvPr/>
-        </p:nvSpPr>
-        <p:spPr>
-          <a:xfrm>
-            <a:off x="4334256" y="1152144"/>
-            <a:ext cx="475488" cy="475488"/>
-          </a:xfrm>
-          <a:prstGeom prst="ellipse">
-            <a:avLst/>
-          </a:prstGeom>
-          <a:solidFill>
-            <a:srgbClr val="DBEAFE"/>
-          </a:solidFill>
-          <a:ln w="12700">
-            <a:solidFill>
-              <a:srgbClr val="DBEAFE"/>
-            </a:solidFill>
-            <a:prstDash val="solid"/>
-          </a:ln>
-        </p:spPr>
-      </p:sp>
-      <p:sp>
-        <p:nvSpPr>
-          <p:cNvPr id="23" name="Text 21"/>
-          <p:cNvSpPr/>
-          <p:nvPr/>
-        </p:nvSpPr>
-        <p:spPr>
-          <a:xfrm>
-            <a:off x="4334256" y="1152144"/>
-            <a:ext cx="475488" cy="475488"/>
-          </a:xfrm>
-          <a:prstGeom prst="rect">
-            <a:avLst/>
-          </a:prstGeom>
-          <a:noFill/>
-          <a:ln/>
-        </p:spPr>
-        <p:txBody>
-          <a:bodyPr wrap="square" lIns="0" tIns="0" rIns="0" bIns="0" rtlCol="0" anchor="ctr"/>
-          <a:lstStyle/>
-          <a:p>
-            <a:pPr algn="ctr" indent="0" marL="0">
-              <a:buNone/>
-            </a:pPr>
-            <a:r>
-              <a:rPr lang="en-US" sz="1000" b="1" dirty="0">
-                <a:solidFill>
-                  <a:srgbClr val="2563EB"/>
-                </a:solidFill>
-                <a:latin typeface="Noto Sans KR" pitchFamily="34" charset="0"/>
-                <a:ea typeface="Noto Sans KR" pitchFamily="34" charset="-122"/>
-                <a:cs typeface="Noto Sans KR" pitchFamily="34" charset="-120"/>
-              </a:rPr>
-              <a:t>04</a:t>
-            </a:r>
-            <a:endParaRPr lang="en-US" sz="1000" dirty="0"/>
-          </a:p>
-        </p:txBody>
-      </p:sp>
-      <p:sp>
-        <p:nvSpPr>
-          <p:cNvPr id="24" name="Text 22"/>
-          <p:cNvSpPr/>
-          <p:nvPr/>
-        </p:nvSpPr>
-        <p:spPr>
-          <a:xfrm>
-            <a:off x="4039035" y="1700784"/>
-            <a:ext cx="1065929" cy="256032"/>
-          </a:xfrm>
-          <a:prstGeom prst="rect">
-            <a:avLst/>
-          </a:prstGeom>
-          <a:noFill/>
-          <a:ln/>
-        </p:spPr>
-        <p:txBody>
-          <a:bodyPr wrap="square" lIns="0" tIns="0" rIns="0" bIns="0" rtlCol="0" anchor="ctr"/>
-          <a:lstStyle/>
-          <a:p>
-            <a:pPr algn="ctr" indent="0" marL="0">
-              <a:lnSpc>
-                <a:spcPct val="110000"/>
-              </a:lnSpc>
-              <a:buNone/>
-            </a:pPr>
-            <a:r>
-              <a:rPr lang="en-US" sz="900" b="1" dirty="0">
+          <p:cNvPr id="15" name="Text 13"/>
+          <p:cNvSpPr/>
+          <p:nvPr/>
+        </p:nvSpPr>
+        <p:spPr>
+          <a:xfrm>
+            <a:off x="548640" y="2267712"/>
+            <a:ext cx="1325880" cy="237744"/>
+          </a:xfrm>
+          <a:prstGeom prst="rect">
+            <a:avLst/>
+          </a:prstGeom>
+          <a:noFill/>
+          <a:ln/>
+        </p:spPr>
+        <p:txBody>
+          <a:bodyPr wrap="square" lIns="0" tIns="0" rIns="0" bIns="0" rtlCol="0" anchor="ctr"/>
+          <a:lstStyle/>
+          <a:p>
+            <a:pPr indent="0" marL="0">
+              <a:buNone/>
+            </a:pPr>
+            <a:r>
+              <a:rPr lang="en-US" sz="850" b="1" dirty="0">
                 <a:solidFill>
                   <a:srgbClr val="1B2F5E"/>
                 </a:solidFill>
@@ -3004,77 +2673,73 @@
                 <a:ea typeface="Noto Sans KR" pitchFamily="34" charset="-122"/>
                 <a:cs typeface="Noto Sans KR" pitchFamily="34" charset="-120"/>
               </a:rPr>
-              <a:t>사양</a:t>
-            </a:r>
-            <a:endParaRPr lang="en-US" sz="900" dirty="0"/>
-          </a:p>
-          <a:p>
-            <a:pPr algn="ctr" indent="0" marL="0">
-              <a:lnSpc>
-                <a:spcPct val="110000"/>
-              </a:lnSpc>
-              <a:buNone/>
-            </a:pPr>
-            <a:r>
-              <a:rPr lang="en-US" sz="900" b="1" dirty="0">
-                <a:solidFill>
-                  <a:srgbClr val="1B2F5E"/>
-                </a:solidFill>
-                <a:latin typeface="Noto Sans KR" pitchFamily="34" charset="0"/>
-                <a:ea typeface="Noto Sans KR" pitchFamily="34" charset="-122"/>
-                <a:cs typeface="Noto Sans KR" pitchFamily="34" charset="-120"/>
-              </a:rPr>
-              <a:t>확정</a:t>
-            </a:r>
-            <a:endParaRPr lang="en-US" sz="900" dirty="0"/>
-          </a:p>
-        </p:txBody>
-      </p:sp>
-      <p:sp>
-        <p:nvSpPr>
-          <p:cNvPr id="25" name="Shape 23"/>
-          <p:cNvSpPr/>
-          <p:nvPr/>
-        </p:nvSpPr>
-        <p:spPr>
-          <a:xfrm>
-            <a:off x="5141541" y="1563624"/>
-            <a:ext cx="73152" cy="0"/>
-          </a:xfrm>
-          <a:prstGeom prst="line">
-            <a:avLst/>
-          </a:prstGeom>
-          <a:noFill/>
-          <a:ln w="15240">
-            <a:solidFill>
-              <a:srgbClr val="94A3B8"/>
-            </a:solidFill>
-            <a:prstDash val="solid"/>
-          </a:ln>
-        </p:spPr>
-      </p:sp>
-      <p:sp>
-        <p:nvSpPr>
-          <p:cNvPr id="26" name="Shape 24"/>
-          <p:cNvSpPr/>
-          <p:nvPr/>
-        </p:nvSpPr>
-        <p:spPr>
-          <a:xfrm>
-            <a:off x="5214693" y="1060704"/>
-            <a:ext cx="1139081" cy="1005840"/>
+              <a:t>검사기 구현 범위</a:t>
+            </a:r>
+            <a:endParaRPr lang="en-US" sz="850" dirty="0"/>
+          </a:p>
+        </p:txBody>
+      </p:sp>
+      <p:sp>
+        <p:nvSpPr>
+          <p:cNvPr id="16" name="Text 14"/>
+          <p:cNvSpPr/>
+          <p:nvPr/>
+        </p:nvSpPr>
+        <p:spPr>
+          <a:xfrm>
+            <a:off x="1901952" y="2267712"/>
+            <a:ext cx="2468880" cy="237744"/>
+          </a:xfrm>
+          <a:prstGeom prst="rect">
+            <a:avLst/>
+          </a:prstGeom>
+          <a:noFill/>
+          <a:ln/>
+        </p:spPr>
+        <p:txBody>
+          <a:bodyPr wrap="square" lIns="0" tIns="0" rIns="0" bIns="0" rtlCol="0" anchor="ctr"/>
+          <a:lstStyle/>
+          <a:p>
+            <a:pPr indent="0" marL="0">
+              <a:buNone/>
+            </a:pPr>
+            <a:r>
+              <a:rPr lang="en-US" sz="850" dirty="0">
+                <a:solidFill>
+                  <a:srgbClr val="475569"/>
+                </a:solidFill>
+                <a:latin typeface="Noto Sans KR" pitchFamily="34" charset="0"/>
+                <a:ea typeface="Noto Sans KR" pitchFamily="34" charset="-122"/>
+                <a:cs typeface="Noto Sans KR" pitchFamily="34" charset="-120"/>
+              </a:rPr>
+              <a:t>딥러닝 양불 판정 기능만</a:t>
+            </a:r>
+            <a:endParaRPr lang="en-US" sz="850" dirty="0"/>
+          </a:p>
+        </p:txBody>
+      </p:sp>
+      <p:sp>
+        <p:nvSpPr>
+          <p:cNvPr id="17" name="Shape 15"/>
+          <p:cNvSpPr/>
+          <p:nvPr/>
+        </p:nvSpPr>
+        <p:spPr>
+          <a:xfrm>
+            <a:off x="475488" y="2560320"/>
+            <a:ext cx="3895344" cy="274320"/>
           </a:xfrm>
           <a:prstGeom prst="roundRect">
             <a:avLst>
-              <a:gd name="adj" fmla="val 6364"/>
+              <a:gd name="adj" fmla="val 23333"/>
             </a:avLst>
           </a:prstGeom>
           <a:solidFill>
-            <a:srgbClr val="1B2F5E"/>
-          </a:solidFill>
-          <a:ln w="19050">
-            <a:solidFill>
-              <a:srgbClr val="1B2F5E"/>
+            <a:srgbClr val="DBEAFE"/>
+          </a:solidFill>
+          <a:ln w="12700">
+            <a:solidFill>
+              <a:srgbClr val="DBEAFE"/>
             </a:solidFill>
             <a:prstDash val="solid"/>
           </a:ln>
@@ -3089,55 +2754,30 @@
       </p:sp>
       <p:sp>
         <p:nvSpPr>
-          <p:cNvPr id="27" name="Shape 25"/>
-          <p:cNvSpPr/>
-          <p:nvPr/>
-        </p:nvSpPr>
-        <p:spPr>
-          <a:xfrm>
-            <a:off x="5546489" y="1152144"/>
-            <a:ext cx="475488" cy="475488"/>
-          </a:xfrm>
-          <a:prstGeom prst="ellipse">
-            <a:avLst/>
-          </a:prstGeom>
-          <a:solidFill>
-            <a:srgbClr val="F59E0B"/>
-          </a:solidFill>
-          <a:ln w="12700">
-            <a:solidFill>
-              <a:srgbClr val="F59E0B"/>
-            </a:solidFill>
-            <a:prstDash val="solid"/>
-          </a:ln>
-        </p:spPr>
-      </p:sp>
-      <p:sp>
-        <p:nvSpPr>
-          <p:cNvPr id="28" name="Text 26"/>
-          <p:cNvSpPr/>
-          <p:nvPr/>
-        </p:nvSpPr>
-        <p:spPr>
-          <a:xfrm>
-            <a:off x="5546489" y="1152144"/>
-            <a:ext cx="475488" cy="475488"/>
-          </a:xfrm>
-          <a:prstGeom prst="rect">
-            <a:avLst/>
-          </a:prstGeom>
-          <a:noFill/>
-          <a:ln/>
-        </p:spPr>
-        <p:txBody>
-          <a:bodyPr wrap="square" lIns="0" tIns="0" rIns="0" bIns="0" rtlCol="0" anchor="ctr"/>
-          <a:lstStyle/>
-          <a:p>
-            <a:pPr algn="ctr" indent="0" marL="0">
-              <a:buNone/>
-            </a:pPr>
-            <a:r>
-              <a:rPr lang="en-US" sz="1000" b="1" dirty="0">
+          <p:cNvPr id="18" name="Text 16"/>
+          <p:cNvSpPr/>
+          <p:nvPr/>
+        </p:nvSpPr>
+        <p:spPr>
+          <a:xfrm>
+            <a:off x="548640" y="2578608"/>
+            <a:ext cx="1325880" cy="237744"/>
+          </a:xfrm>
+          <a:prstGeom prst="rect">
+            <a:avLst/>
+          </a:prstGeom>
+          <a:noFill/>
+          <a:ln/>
+        </p:spPr>
+        <p:txBody>
+          <a:bodyPr wrap="square" lIns="0" tIns="0" rIns="0" bIns="0" rtlCol="0" anchor="ctr"/>
+          <a:lstStyle/>
+          <a:p>
+            <a:pPr indent="0" marL="0">
+              <a:buNone/>
+            </a:pPr>
+            <a:r>
+              <a:rPr lang="en-US" sz="850" b="1" dirty="0">
                 <a:solidFill>
                   <a:srgbClr val="1B2F5E"/>
                 </a:solidFill>
@@ -3145,119 +2785,73 @@
                 <a:ea typeface="Noto Sans KR" pitchFamily="34" charset="-122"/>
                 <a:cs typeface="Noto Sans KR" pitchFamily="34" charset="-120"/>
               </a:rPr>
-              <a:t>05</a:t>
-            </a:r>
-            <a:endParaRPr lang="en-US" sz="1000" dirty="0"/>
-          </a:p>
-        </p:txBody>
-      </p:sp>
-      <p:sp>
-        <p:nvSpPr>
-          <p:cNvPr id="29" name="Text 27"/>
-          <p:cNvSpPr/>
-          <p:nvPr/>
-        </p:nvSpPr>
-        <p:spPr>
-          <a:xfrm>
-            <a:off x="5251269" y="1700784"/>
-            <a:ext cx="1065929" cy="256032"/>
-          </a:xfrm>
-          <a:prstGeom prst="rect">
-            <a:avLst/>
-          </a:prstGeom>
-          <a:noFill/>
-          <a:ln/>
-        </p:spPr>
-        <p:txBody>
-          <a:bodyPr wrap="square" lIns="0" tIns="0" rIns="0" bIns="0" rtlCol="0" anchor="ctr"/>
-          <a:lstStyle/>
-          <a:p>
-            <a:pPr algn="ctr" indent="0" marL="0">
-              <a:lnSpc>
-                <a:spcPct val="110000"/>
-              </a:lnSpc>
-              <a:buNone/>
-            </a:pPr>
-            <a:r>
-              <a:rPr lang="en-US" sz="900" b="1" dirty="0">
-                <a:solidFill>
-                  <a:srgbClr val="FFFFFF"/>
-                </a:solidFill>
-                <a:latin typeface="Noto Sans KR" pitchFamily="34" charset="0"/>
-                <a:ea typeface="Noto Sans KR" pitchFamily="34" charset="-122"/>
-                <a:cs typeface="Noto Sans KR" pitchFamily="34" charset="-120"/>
-              </a:rPr>
-              <a:t>개발·</a:t>
-            </a:r>
-            <a:endParaRPr lang="en-US" sz="900" dirty="0"/>
-          </a:p>
-          <a:p>
-            <a:pPr algn="ctr" indent="0" marL="0">
-              <a:lnSpc>
-                <a:spcPct val="110000"/>
-              </a:lnSpc>
-              <a:buNone/>
-            </a:pPr>
-            <a:r>
-              <a:rPr lang="en-US" sz="900" b="1" dirty="0">
-                <a:solidFill>
-                  <a:srgbClr val="FFFFFF"/>
-                </a:solidFill>
-                <a:latin typeface="Noto Sans KR" pitchFamily="34" charset="0"/>
-                <a:ea typeface="Noto Sans KR" pitchFamily="34" charset="-122"/>
-                <a:cs typeface="Noto Sans KR" pitchFamily="34" charset="-120"/>
-              </a:rPr>
-              <a:t>제작</a:t>
-            </a:r>
-            <a:endParaRPr lang="en-US" sz="900" dirty="0"/>
-          </a:p>
-        </p:txBody>
-      </p:sp>
-      <p:sp>
-        <p:nvSpPr>
-          <p:cNvPr id="30" name="Shape 28"/>
-          <p:cNvSpPr/>
-          <p:nvPr/>
-        </p:nvSpPr>
-        <p:spPr>
-          <a:xfrm>
-            <a:off x="6353774" y="1563624"/>
-            <a:ext cx="73152" cy="0"/>
-          </a:xfrm>
-          <a:prstGeom prst="line">
-            <a:avLst/>
-          </a:prstGeom>
-          <a:noFill/>
-          <a:ln w="15240">
-            <a:solidFill>
-              <a:srgbClr val="94A3B8"/>
-            </a:solidFill>
-            <a:prstDash val="solid"/>
-          </a:ln>
-        </p:spPr>
-      </p:sp>
-      <p:sp>
-        <p:nvSpPr>
-          <p:cNvPr id="31" name="Shape 29"/>
-          <p:cNvSpPr/>
-          <p:nvPr/>
-        </p:nvSpPr>
-        <p:spPr>
-          <a:xfrm>
-            <a:off x="6426926" y="1060704"/>
-            <a:ext cx="1139081" cy="1005840"/>
+              <a:t>검증 목표</a:t>
+            </a:r>
+            <a:endParaRPr lang="en-US" sz="850" dirty="0"/>
+          </a:p>
+        </p:txBody>
+      </p:sp>
+      <p:sp>
+        <p:nvSpPr>
+          <p:cNvPr id="19" name="Text 17"/>
+          <p:cNvSpPr/>
+          <p:nvPr/>
+        </p:nvSpPr>
+        <p:spPr>
+          <a:xfrm>
+            <a:off x="1901952" y="2578608"/>
+            <a:ext cx="2468880" cy="237744"/>
+          </a:xfrm>
+          <a:prstGeom prst="rect">
+            <a:avLst/>
+          </a:prstGeom>
+          <a:noFill/>
+          <a:ln/>
+        </p:spPr>
+        <p:txBody>
+          <a:bodyPr wrap="square" lIns="0" tIns="0" rIns="0" bIns="0" rtlCol="0" anchor="ctr"/>
+          <a:lstStyle/>
+          <a:p>
+            <a:pPr indent="0" marL="0">
+              <a:buNone/>
+            </a:pPr>
+            <a:r>
+              <a:rPr lang="en-US" sz="850" dirty="0">
+                <a:solidFill>
+                  <a:srgbClr val="475569"/>
+                </a:solidFill>
+                <a:latin typeface="Noto Sans KR" pitchFamily="34" charset="0"/>
+                <a:ea typeface="Noto Sans KR" pitchFamily="34" charset="-122"/>
+                <a:cs typeface="Noto Sans KR" pitchFamily="34" charset="-120"/>
+              </a:rPr>
+              <a:t>검사원 이상의 검출력 확인</a:t>
+            </a:r>
+            <a:endParaRPr lang="en-US" sz="850" dirty="0"/>
+          </a:p>
+        </p:txBody>
+      </p:sp>
+      <p:sp>
+        <p:nvSpPr>
+          <p:cNvPr id="20" name="Shape 18"/>
+          <p:cNvSpPr/>
+          <p:nvPr/>
+        </p:nvSpPr>
+        <p:spPr>
+          <a:xfrm>
+            <a:off x="475488" y="2871216"/>
+            <a:ext cx="3895344" cy="237744"/>
           </a:xfrm>
           <a:prstGeom prst="roundRect">
             <a:avLst>
-              <a:gd name="adj" fmla="val 6364"/>
+              <a:gd name="adj" fmla="val 26923"/>
             </a:avLst>
           </a:prstGeom>
           <a:solidFill>
-            <a:srgbClr val="1B2F5E"/>
-          </a:solidFill>
-          <a:ln w="19050">
-            <a:solidFill>
-              <a:srgbClr val="1B2F5E"/>
+            <a:srgbClr val="DBEAFE"/>
+          </a:solidFill>
+          <a:ln w="12700">
+            <a:solidFill>
+              <a:srgbClr val="2563EB"/>
             </a:solidFill>
             <a:prstDash val="solid"/>
           </a:ln>
@@ -3272,39 +2866,14 @@
       </p:sp>
       <p:sp>
         <p:nvSpPr>
-          <p:cNvPr id="32" name="Shape 30"/>
-          <p:cNvSpPr/>
-          <p:nvPr/>
-        </p:nvSpPr>
-        <p:spPr>
-          <a:xfrm>
-            <a:off x="6758722" y="1152144"/>
-            <a:ext cx="475488" cy="475488"/>
-          </a:xfrm>
-          <a:prstGeom prst="ellipse">
-            <a:avLst/>
-          </a:prstGeom>
-          <a:solidFill>
-            <a:srgbClr val="F59E0B"/>
-          </a:solidFill>
-          <a:ln w="12700">
-            <a:solidFill>
-              <a:srgbClr val="F59E0B"/>
-            </a:solidFill>
-            <a:prstDash val="solid"/>
-          </a:ln>
-        </p:spPr>
-      </p:sp>
-      <p:sp>
-        <p:nvSpPr>
-          <p:cNvPr id="33" name="Text 31"/>
-          <p:cNvSpPr/>
-          <p:nvPr/>
-        </p:nvSpPr>
-        <p:spPr>
-          <a:xfrm>
-            <a:off x="6758722" y="1152144"/>
-            <a:ext cx="475488" cy="475488"/>
+          <p:cNvPr id="21" name="Text 19"/>
+          <p:cNvSpPr/>
+          <p:nvPr/>
+        </p:nvSpPr>
+        <p:spPr>
+          <a:xfrm>
+            <a:off x="475488" y="2871216"/>
+            <a:ext cx="3895344" cy="237744"/>
           </a:xfrm>
           <a:prstGeom prst="rect">
             <a:avLst/>
@@ -3320,7 +2889,7 @@
               <a:buNone/>
             </a:pPr>
             <a:r>
-              <a:rPr lang="en-US" sz="1000" b="1" dirty="0">
+              <a:rPr lang="en-US" sz="800" b="1" dirty="0">
                 <a:solidFill>
                   <a:srgbClr val="1B2F5E"/>
                 </a:solidFill>
@@ -3328,119 +2897,34 @@
                 <a:ea typeface="Noto Sans KR" pitchFamily="34" charset="-122"/>
                 <a:cs typeface="Noto Sans KR" pitchFamily="34" charset="-120"/>
               </a:rPr>
-              <a:t>06</a:t>
-            </a:r>
-            <a:endParaRPr lang="en-US" sz="1000" dirty="0"/>
-          </a:p>
-        </p:txBody>
-      </p:sp>
-      <p:sp>
-        <p:nvSpPr>
-          <p:cNvPr id="34" name="Text 32"/>
-          <p:cNvSpPr/>
-          <p:nvPr/>
-        </p:nvSpPr>
-        <p:spPr>
-          <a:xfrm>
-            <a:off x="6463502" y="1700784"/>
-            <a:ext cx="1065929" cy="256032"/>
-          </a:xfrm>
-          <a:prstGeom prst="rect">
-            <a:avLst/>
-          </a:prstGeom>
-          <a:noFill/>
-          <a:ln/>
-        </p:spPr>
-        <p:txBody>
-          <a:bodyPr wrap="square" lIns="0" tIns="0" rIns="0" bIns="0" rtlCol="0" anchor="ctr"/>
-          <a:lstStyle/>
-          <a:p>
-            <a:pPr algn="ctr" indent="0" marL="0">
-              <a:lnSpc>
-                <a:spcPct val="110000"/>
-              </a:lnSpc>
-              <a:buNone/>
-            </a:pPr>
-            <a:r>
-              <a:rPr lang="en-US" sz="900" b="1" dirty="0">
-                <a:solidFill>
-                  <a:srgbClr val="FFFFFF"/>
-                </a:solidFill>
-                <a:latin typeface="Noto Sans KR" pitchFamily="34" charset="0"/>
-                <a:ea typeface="Noto Sans KR" pitchFamily="34" charset="-122"/>
-                <a:cs typeface="Noto Sans KR" pitchFamily="34" charset="-120"/>
-              </a:rPr>
-              <a:t>설치·</a:t>
-            </a:r>
-            <a:endParaRPr lang="en-US" sz="900" dirty="0"/>
-          </a:p>
-          <a:p>
-            <a:pPr algn="ctr" indent="0" marL="0">
-              <a:lnSpc>
-                <a:spcPct val="110000"/>
-              </a:lnSpc>
-              <a:buNone/>
-            </a:pPr>
-            <a:r>
-              <a:rPr lang="en-US" sz="900" b="1" dirty="0">
-                <a:solidFill>
-                  <a:srgbClr val="FFFFFF"/>
-                </a:solidFill>
-                <a:latin typeface="Noto Sans KR" pitchFamily="34" charset="0"/>
-                <a:ea typeface="Noto Sans KR" pitchFamily="34" charset="-122"/>
-                <a:cs typeface="Noto Sans KR" pitchFamily="34" charset="-120"/>
-              </a:rPr>
-              <a:t>테스트</a:t>
-            </a:r>
-            <a:endParaRPr lang="en-US" sz="900" dirty="0"/>
-          </a:p>
-        </p:txBody>
-      </p:sp>
-      <p:sp>
-        <p:nvSpPr>
-          <p:cNvPr id="35" name="Shape 33"/>
-          <p:cNvSpPr/>
-          <p:nvPr/>
-        </p:nvSpPr>
-        <p:spPr>
-          <a:xfrm>
-            <a:off x="7566007" y="1563624"/>
-            <a:ext cx="73152" cy="0"/>
-          </a:xfrm>
-          <a:prstGeom prst="line">
-            <a:avLst/>
-          </a:prstGeom>
-          <a:noFill/>
-          <a:ln w="15240">
-            <a:solidFill>
-              <a:srgbClr val="94A3B8"/>
-            </a:solidFill>
-            <a:prstDash val="solid"/>
-          </a:ln>
-        </p:spPr>
-      </p:sp>
-      <p:sp>
-        <p:nvSpPr>
-          <p:cNvPr id="36" name="Shape 34"/>
-          <p:cNvSpPr/>
-          <p:nvPr/>
-        </p:nvSpPr>
-        <p:spPr>
-          <a:xfrm>
-            <a:off x="7639159" y="1060704"/>
-            <a:ext cx="1139081" cy="1005840"/>
+              <a:t>제작 기간 단축 · 투자 비용 최소화 · 빠른 효과 검증</a:t>
+            </a:r>
+            <a:endParaRPr lang="en-US" sz="800" dirty="0"/>
+          </a:p>
+        </p:txBody>
+      </p:sp>
+      <p:sp>
+        <p:nvSpPr>
+          <p:cNvPr id="22" name="Shape 20"/>
+          <p:cNvSpPr/>
+          <p:nvPr/>
+        </p:nvSpPr>
+        <p:spPr>
+          <a:xfrm>
+            <a:off x="4663440" y="1517904"/>
+            <a:ext cx="4114800" cy="1645920"/>
           </a:xfrm>
           <a:prstGeom prst="roundRect">
             <a:avLst>
-              <a:gd name="adj" fmla="val 6364"/>
+              <a:gd name="adj" fmla="val 3889"/>
             </a:avLst>
           </a:prstGeom>
           <a:solidFill>
             <a:srgbClr val="FFFFFF"/>
           </a:solidFill>
-          <a:ln w="19050">
-            <a:solidFill>
-              <a:srgbClr val="E2E8F0"/>
+          <a:ln w="25400">
+            <a:solidFill>
+              <a:srgbClr val="0D9488"/>
             </a:solidFill>
             <a:prstDash val="solid"/>
           </a:ln>
@@ -3455,152 +2939,92 @@
       </p:sp>
       <p:sp>
         <p:nvSpPr>
-          <p:cNvPr id="37" name="Shape 35"/>
-          <p:cNvSpPr/>
-          <p:nvPr/>
-        </p:nvSpPr>
-        <p:spPr>
-          <a:xfrm>
-            <a:off x="7970955" y="1152144"/>
-            <a:ext cx="475488" cy="475488"/>
-          </a:xfrm>
-          <a:prstGeom prst="ellipse">
-            <a:avLst/>
-          </a:prstGeom>
-          <a:solidFill>
-            <a:srgbClr val="DBEAFE"/>
-          </a:solidFill>
-          <a:ln w="12700">
-            <a:solidFill>
-              <a:srgbClr val="DBEAFE"/>
-            </a:solidFill>
-            <a:prstDash val="solid"/>
-          </a:ln>
-        </p:spPr>
-      </p:sp>
-      <p:sp>
-        <p:nvSpPr>
-          <p:cNvPr id="38" name="Text 36"/>
-          <p:cNvSpPr/>
-          <p:nvPr/>
-        </p:nvSpPr>
-        <p:spPr>
-          <a:xfrm>
-            <a:off x="7970955" y="1152144"/>
-            <a:ext cx="475488" cy="475488"/>
-          </a:xfrm>
-          <a:prstGeom prst="rect">
-            <a:avLst/>
-          </a:prstGeom>
-          <a:noFill/>
-          <a:ln/>
-        </p:spPr>
-        <p:txBody>
-          <a:bodyPr wrap="square" lIns="0" tIns="0" rIns="0" bIns="0" rtlCol="0" anchor="ctr"/>
-          <a:lstStyle/>
-          <a:p>
-            <a:pPr algn="ctr" indent="0" marL="0">
-              <a:buNone/>
-            </a:pPr>
-            <a:r>
-              <a:rPr lang="en-US" sz="1000" b="1" dirty="0">
-                <a:solidFill>
-                  <a:srgbClr val="2563EB"/>
-                </a:solidFill>
-                <a:latin typeface="Noto Sans KR" pitchFamily="34" charset="0"/>
-                <a:ea typeface="Noto Sans KR" pitchFamily="34" charset="-122"/>
-                <a:cs typeface="Noto Sans KR" pitchFamily="34" charset="-120"/>
-              </a:rPr>
-              <a:t>07</a:t>
-            </a:r>
-            <a:endParaRPr lang="en-US" sz="1000" dirty="0"/>
-          </a:p>
-        </p:txBody>
-      </p:sp>
-      <p:sp>
-        <p:nvSpPr>
-          <p:cNvPr id="39" name="Text 37"/>
-          <p:cNvSpPr/>
-          <p:nvPr/>
-        </p:nvSpPr>
-        <p:spPr>
-          <a:xfrm>
-            <a:off x="7675735" y="1700784"/>
-            <a:ext cx="1065929" cy="256032"/>
-          </a:xfrm>
-          <a:prstGeom prst="rect">
-            <a:avLst/>
-          </a:prstGeom>
-          <a:noFill/>
-          <a:ln/>
-        </p:spPr>
-        <p:txBody>
-          <a:bodyPr wrap="square" lIns="0" tIns="0" rIns="0" bIns="0" rtlCol="0" anchor="ctr"/>
-          <a:lstStyle/>
-          <a:p>
-            <a:pPr algn="ctr" indent="0" marL="0">
-              <a:lnSpc>
-                <a:spcPct val="110000"/>
-              </a:lnSpc>
-              <a:buNone/>
-            </a:pPr>
-            <a:r>
-              <a:rPr lang="en-US" sz="900" b="1" dirty="0">
-                <a:solidFill>
-                  <a:srgbClr val="1B2F5E"/>
-                </a:solidFill>
-                <a:latin typeface="Noto Sans KR" pitchFamily="34" charset="0"/>
-                <a:ea typeface="Noto Sans KR" pitchFamily="34" charset="-122"/>
-                <a:cs typeface="Noto Sans KR" pitchFamily="34" charset="-120"/>
-              </a:rPr>
-              <a:t>성능</a:t>
-            </a:r>
-            <a:endParaRPr lang="en-US" sz="900" dirty="0"/>
-          </a:p>
-          <a:p>
-            <a:pPr algn="ctr" indent="0" marL="0">
-              <a:lnSpc>
-                <a:spcPct val="110000"/>
-              </a:lnSpc>
-              <a:buNone/>
-            </a:pPr>
-            <a:r>
-              <a:rPr lang="en-US" sz="900" b="1" dirty="0">
-                <a:solidFill>
-                  <a:srgbClr val="1B2F5E"/>
-                </a:solidFill>
-                <a:latin typeface="Noto Sans KR" pitchFamily="34" charset="0"/>
-                <a:ea typeface="Noto Sans KR" pitchFamily="34" charset="-122"/>
-                <a:cs typeface="Noto Sans KR" pitchFamily="34" charset="-120"/>
-              </a:rPr>
-              <a:t>검증</a:t>
-            </a:r>
-            <a:endParaRPr lang="en-US" sz="900" dirty="0"/>
-          </a:p>
-        </p:txBody>
-      </p:sp>
-      <p:sp>
-        <p:nvSpPr>
-          <p:cNvPr id="40" name="Shape 38"/>
-          <p:cNvSpPr/>
-          <p:nvPr/>
-        </p:nvSpPr>
-        <p:spPr>
-          <a:xfrm>
-            <a:off x="365760" y="2139696"/>
-            <a:ext cx="1139081" cy="457200"/>
+          <p:cNvPr id="23" name="Shape 21"/>
+          <p:cNvSpPr/>
+          <p:nvPr/>
+        </p:nvSpPr>
+        <p:spPr>
+          <a:xfrm>
+            <a:off x="4663440" y="1517904"/>
+            <a:ext cx="4114800" cy="365760"/>
           </a:xfrm>
           <a:prstGeom prst="roundRect">
             <a:avLst>
-              <a:gd name="adj" fmla="val 14000"/>
+              <a:gd name="adj" fmla="val 17500"/>
             </a:avLst>
           </a:prstGeom>
           <a:solidFill>
-            <a:srgbClr val="F1F5F9"/>
+            <a:srgbClr val="0D9488"/>
           </a:solidFill>
           <a:ln w="12700">
             <a:solidFill>
-              <a:srgbClr val="F1F5F9"/>
+              <a:srgbClr val="0D9488"/>
+            </a:solidFill>
+            <a:prstDash val="solid"/>
+          </a:ln>
+        </p:spPr>
+      </p:sp>
+      <p:sp>
+        <p:nvSpPr>
+          <p:cNvPr id="24" name="Text 22"/>
+          <p:cNvSpPr/>
+          <p:nvPr/>
+        </p:nvSpPr>
+        <p:spPr>
+          <a:xfrm>
+            <a:off x="4663440" y="1517904"/>
+            <a:ext cx="4114800" cy="365760"/>
+          </a:xfrm>
+          <a:prstGeom prst="rect">
+            <a:avLst/>
+          </a:prstGeom>
+          <a:noFill/>
+          <a:ln/>
+        </p:spPr>
+        <p:txBody>
+          <a:bodyPr wrap="square" lIns="0" tIns="0" rIns="0" bIns="0" rtlCol="0" anchor="ctr"/>
+          <a:lstStyle/>
+          <a:p>
+            <a:pPr algn="ctr" indent="0" marL="0">
+              <a:buNone/>
+            </a:pPr>
+            <a:r>
+              <a:rPr lang="en-US" sz="1100" b="1" dirty="0">
+                <a:solidFill>
+                  <a:srgbClr val="FFFFFF"/>
+                </a:solidFill>
+                <a:latin typeface="Noto Sans KR" pitchFamily="34" charset="0"/>
+                <a:ea typeface="Noto Sans KR" pitchFamily="34" charset="-122"/>
+                <a:cs typeface="Noto Sans KR" pitchFamily="34" charset="-120"/>
+              </a:rPr>
+              <a:t>STEP 2  —  기능 확장 (효과 확인 후 협의)</a:t>
+            </a:r>
+            <a:endParaRPr lang="en-US" sz="1100" dirty="0"/>
+          </a:p>
+        </p:txBody>
+      </p:sp>
+      <p:sp>
+        <p:nvSpPr>
+          <p:cNvPr id="25" name="Shape 23"/>
+          <p:cNvSpPr/>
+          <p:nvPr/>
+        </p:nvSpPr>
+        <p:spPr>
+          <a:xfrm>
+            <a:off x="4773168" y="1938528"/>
+            <a:ext cx="3895344" cy="274320"/>
+          </a:xfrm>
+          <a:prstGeom prst="roundRect">
+            <a:avLst>
+              <a:gd name="adj" fmla="val 23333"/>
+            </a:avLst>
+          </a:prstGeom>
+          <a:solidFill>
+            <a:srgbClr val="CCFBF1"/>
+          </a:solidFill>
+          <a:ln w="12700">
+            <a:solidFill>
+              <a:srgbClr val="CCFBF1"/>
             </a:solidFill>
             <a:prstDash val="solid"/>
           </a:ln>
@@ -3615,33 +3039,69 @@
       </p:sp>
       <p:sp>
         <p:nvSpPr>
-          <p:cNvPr id="41" name="Text 39"/>
-          <p:cNvSpPr/>
-          <p:nvPr/>
-        </p:nvSpPr>
-        <p:spPr>
-          <a:xfrm>
-            <a:off x="365760" y="2139696"/>
-            <a:ext cx="1139081" cy="457200"/>
-          </a:xfrm>
-          <a:prstGeom prst="rect">
-            <a:avLst/>
-          </a:prstGeom>
-          <a:noFill/>
-          <a:ln/>
-        </p:spPr>
-        <p:txBody>
-          <a:bodyPr wrap="square" lIns="0" tIns="0" rIns="0" bIns="0" rtlCol="0" anchor="ctr"/>
-          <a:lstStyle/>
-          <a:p>
-            <a:pPr algn="ctr" indent="0" marL="0">
-              <a:lnSpc>
-                <a:spcPct val="120000"/>
-              </a:lnSpc>
-              <a:buNone/>
-            </a:pPr>
-            <a:r>
-              <a:rPr lang="en-US" sz="750" dirty="0">
+          <p:cNvPr id="26" name="Text 24"/>
+          <p:cNvSpPr/>
+          <p:nvPr/>
+        </p:nvSpPr>
+        <p:spPr>
+          <a:xfrm>
+            <a:off x="4846320" y="1956816"/>
+            <a:ext cx="1325880" cy="237744"/>
+          </a:xfrm>
+          <a:prstGeom prst="rect">
+            <a:avLst/>
+          </a:prstGeom>
+          <a:noFill/>
+          <a:ln/>
+        </p:spPr>
+        <p:txBody>
+          <a:bodyPr wrap="square" lIns="0" tIns="0" rIns="0" bIns="0" rtlCol="0" anchor="ctr"/>
+          <a:lstStyle/>
+          <a:p>
+            <a:pPr indent="0" marL="0">
+              <a:buNone/>
+            </a:pPr>
+            <a:r>
+              <a:rPr lang="en-US" sz="850" b="1" dirty="0">
+                <a:solidFill>
+                  <a:srgbClr val="0F766E"/>
+                </a:solidFill>
+                <a:latin typeface="Noto Sans KR" pitchFamily="34" charset="0"/>
+                <a:ea typeface="Noto Sans KR" pitchFamily="34" charset="-122"/>
+                <a:cs typeface="Noto Sans KR" pitchFamily="34" charset="-120"/>
+              </a:rPr>
+              <a:t>자동 투입·배출</a:t>
+            </a:r>
+            <a:endParaRPr lang="en-US" sz="850" dirty="0"/>
+          </a:p>
+        </p:txBody>
+      </p:sp>
+      <p:sp>
+        <p:nvSpPr>
+          <p:cNvPr id="27" name="Text 25"/>
+          <p:cNvSpPr/>
+          <p:nvPr/>
+        </p:nvSpPr>
+        <p:spPr>
+          <a:xfrm>
+            <a:off x="6199632" y="1956816"/>
+            <a:ext cx="2468880" cy="237744"/>
+          </a:xfrm>
+          <a:prstGeom prst="rect">
+            <a:avLst/>
+          </a:prstGeom>
+          <a:noFill/>
+          <a:ln/>
+        </p:spPr>
+        <p:txBody>
+          <a:bodyPr wrap="square" lIns="0" tIns="0" rIns="0" bIns="0" rtlCol="0" anchor="ctr"/>
+          <a:lstStyle/>
+          <a:p>
+            <a:pPr indent="0" marL="0">
+              <a:buNone/>
+            </a:pPr>
+            <a:r>
+              <a:rPr lang="en-US" sz="850" dirty="0">
                 <a:solidFill>
                   <a:srgbClr val="475569"/>
                 </a:solidFill>
@@ -3649,54 +3109,34 @@
                 <a:ea typeface="Noto Sans KR" pitchFamily="34" charset="-122"/>
                 <a:cs typeface="Noto Sans KR" pitchFamily="34" charset="-120"/>
               </a:rPr>
-              <a:t>불량·양품</a:t>
-            </a:r>
-            <a:endParaRPr lang="en-US" sz="750" dirty="0"/>
-          </a:p>
-          <a:p>
-            <a:pPr algn="ctr" indent="0" marL="0">
-              <a:lnSpc>
-                <a:spcPct val="120000"/>
-              </a:lnSpc>
-              <a:buNone/>
-            </a:pPr>
-            <a:r>
-              <a:rPr lang="en-US" sz="750" dirty="0">
-                <a:solidFill>
-                  <a:srgbClr val="475569"/>
-                </a:solidFill>
-                <a:latin typeface="Noto Sans KR" pitchFamily="34" charset="0"/>
-                <a:ea typeface="Noto Sans KR" pitchFamily="34" charset="-122"/>
-                <a:cs typeface="Noto Sans KR" pitchFamily="34" charset="-120"/>
-              </a:rPr>
-              <a:t>샘플 제공</a:t>
-            </a:r>
-            <a:endParaRPr lang="en-US" sz="750" dirty="0"/>
-          </a:p>
-        </p:txBody>
-      </p:sp>
-      <p:sp>
-        <p:nvSpPr>
-          <p:cNvPr id="42" name="Shape 40"/>
-          <p:cNvSpPr/>
-          <p:nvPr/>
-        </p:nvSpPr>
-        <p:spPr>
-          <a:xfrm>
-            <a:off x="1577993" y="2139696"/>
-            <a:ext cx="1139081" cy="457200"/>
+              <a:t>컨베어 연계, 자동 이송</a:t>
+            </a:r>
+            <a:endParaRPr lang="en-US" sz="850" dirty="0"/>
+          </a:p>
+        </p:txBody>
+      </p:sp>
+      <p:sp>
+        <p:nvSpPr>
+          <p:cNvPr id="28" name="Shape 26"/>
+          <p:cNvSpPr/>
+          <p:nvPr/>
+        </p:nvSpPr>
+        <p:spPr>
+          <a:xfrm>
+            <a:off x="4773168" y="2249424"/>
+            <a:ext cx="3895344" cy="274320"/>
           </a:xfrm>
           <a:prstGeom prst="roundRect">
             <a:avLst>
-              <a:gd name="adj" fmla="val 14000"/>
+              <a:gd name="adj" fmla="val 23333"/>
             </a:avLst>
           </a:prstGeom>
           <a:solidFill>
-            <a:srgbClr val="DBEAFE"/>
+            <a:srgbClr val="CCFBF1"/>
           </a:solidFill>
           <a:ln w="12700">
             <a:solidFill>
-              <a:srgbClr val="DBEAFE"/>
+              <a:srgbClr val="CCFBF1"/>
             </a:solidFill>
             <a:prstDash val="solid"/>
           </a:ln>
@@ -3711,88 +3151,104 @@
       </p:sp>
       <p:sp>
         <p:nvSpPr>
-          <p:cNvPr id="43" name="Text 41"/>
-          <p:cNvSpPr/>
-          <p:nvPr/>
-        </p:nvSpPr>
-        <p:spPr>
-          <a:xfrm>
-            <a:off x="1577993" y="2139696"/>
-            <a:ext cx="1139081" cy="457200"/>
-          </a:xfrm>
-          <a:prstGeom prst="rect">
-            <a:avLst/>
-          </a:prstGeom>
-          <a:noFill/>
-          <a:ln/>
-        </p:spPr>
-        <p:txBody>
-          <a:bodyPr wrap="square" lIns="0" tIns="0" rIns="0" bIns="0" rtlCol="0" anchor="ctr"/>
-          <a:lstStyle/>
-          <a:p>
-            <a:pPr algn="ctr" indent="0" marL="0">
-              <a:lnSpc>
-                <a:spcPct val="120000"/>
-              </a:lnSpc>
-              <a:buNone/>
-            </a:pPr>
-            <a:r>
-              <a:rPr lang="en-US" sz="750" dirty="0">
-                <a:solidFill>
-                  <a:srgbClr val="1B2F5E"/>
-                </a:solidFill>
-                <a:latin typeface="Noto Sans KR" pitchFamily="34" charset="0"/>
-                <a:ea typeface="Noto Sans KR" pitchFamily="34" charset="-122"/>
-                <a:cs typeface="Noto Sans KR" pitchFamily="34" charset="-120"/>
-              </a:rPr>
-              <a:t>불량 유형 분류</a:t>
-            </a:r>
-            <a:endParaRPr lang="en-US" sz="750" dirty="0"/>
-          </a:p>
-          <a:p>
-            <a:pPr algn="ctr" indent="0" marL="0">
-              <a:lnSpc>
-                <a:spcPct val="120000"/>
-              </a:lnSpc>
-              <a:buNone/>
-            </a:pPr>
-            <a:r>
-              <a:rPr lang="en-US" sz="750" dirty="0">
-                <a:solidFill>
-                  <a:srgbClr val="1B2F5E"/>
-                </a:solidFill>
-                <a:latin typeface="Noto Sans KR" pitchFamily="34" charset="0"/>
-                <a:ea typeface="Noto Sans KR" pitchFamily="34" charset="-122"/>
-                <a:cs typeface="Noto Sans KR" pitchFamily="34" charset="-120"/>
-              </a:rPr>
-              <a:t>1~2주 이내</a:t>
-            </a:r>
-            <a:endParaRPr lang="en-US" sz="750" dirty="0"/>
-          </a:p>
-        </p:txBody>
-      </p:sp>
-      <p:sp>
-        <p:nvSpPr>
-          <p:cNvPr id="44" name="Shape 42"/>
-          <p:cNvSpPr/>
-          <p:nvPr/>
-        </p:nvSpPr>
-        <p:spPr>
-          <a:xfrm>
-            <a:off x="2790226" y="2139696"/>
-            <a:ext cx="1139081" cy="457200"/>
+          <p:cNvPr id="29" name="Text 27"/>
+          <p:cNvSpPr/>
+          <p:nvPr/>
+        </p:nvSpPr>
+        <p:spPr>
+          <a:xfrm>
+            <a:off x="4846320" y="2267712"/>
+            <a:ext cx="1325880" cy="237744"/>
+          </a:xfrm>
+          <a:prstGeom prst="rect">
+            <a:avLst/>
+          </a:prstGeom>
+          <a:noFill/>
+          <a:ln/>
+        </p:spPr>
+        <p:txBody>
+          <a:bodyPr wrap="square" lIns="0" tIns="0" rIns="0" bIns="0" rtlCol="0" anchor="ctr"/>
+          <a:lstStyle/>
+          <a:p>
+            <a:pPr indent="0" marL="0">
+              <a:buNone/>
+            </a:pPr>
+            <a:r>
+              <a:rPr lang="en-US" sz="850" b="1" dirty="0">
+                <a:solidFill>
+                  <a:srgbClr val="0F766E"/>
+                </a:solidFill>
+                <a:latin typeface="Noto Sans KR" pitchFamily="34" charset="0"/>
+                <a:ea typeface="Noto Sans KR" pitchFamily="34" charset="-122"/>
+                <a:cs typeface="Noto Sans KR" pitchFamily="34" charset="-120"/>
+              </a:rPr>
+              <a:t>바코드 자동 스캔</a:t>
+            </a:r>
+            <a:endParaRPr lang="en-US" sz="850" dirty="0"/>
+          </a:p>
+        </p:txBody>
+      </p:sp>
+      <p:sp>
+        <p:nvSpPr>
+          <p:cNvPr id="30" name="Text 28"/>
+          <p:cNvSpPr/>
+          <p:nvPr/>
+        </p:nvSpPr>
+        <p:spPr>
+          <a:xfrm>
+            <a:off x="6199632" y="2267712"/>
+            <a:ext cx="2468880" cy="237744"/>
+          </a:xfrm>
+          <a:prstGeom prst="rect">
+            <a:avLst/>
+          </a:prstGeom>
+          <a:noFill/>
+          <a:ln/>
+        </p:spPr>
+        <p:txBody>
+          <a:bodyPr wrap="square" lIns="0" tIns="0" rIns="0" bIns="0" rtlCol="0" anchor="ctr"/>
+          <a:lstStyle/>
+          <a:p>
+            <a:pPr indent="0" marL="0">
+              <a:buNone/>
+            </a:pPr>
+            <a:r>
+              <a:rPr lang="en-US" sz="850" dirty="0">
+                <a:solidFill>
+                  <a:srgbClr val="475569"/>
+                </a:solidFill>
+                <a:latin typeface="Noto Sans KR" pitchFamily="34" charset="0"/>
+                <a:ea typeface="Noto Sans KR" pitchFamily="34" charset="-122"/>
+                <a:cs typeface="Noto Sans KR" pitchFamily="34" charset="-120"/>
+              </a:rPr>
+              <a:t>고정식 스캐너 · MES 연동</a:t>
+            </a:r>
+            <a:endParaRPr lang="en-US" sz="850" dirty="0"/>
+          </a:p>
+        </p:txBody>
+      </p:sp>
+      <p:sp>
+        <p:nvSpPr>
+          <p:cNvPr id="31" name="Shape 29"/>
+          <p:cNvSpPr/>
+          <p:nvPr/>
+        </p:nvSpPr>
+        <p:spPr>
+          <a:xfrm>
+            <a:off x="4773168" y="2560320"/>
+            <a:ext cx="3895344" cy="274320"/>
           </a:xfrm>
           <a:prstGeom prst="roundRect">
             <a:avLst>
-              <a:gd name="adj" fmla="val 14000"/>
+              <a:gd name="adj" fmla="val 23333"/>
             </a:avLst>
           </a:prstGeom>
           <a:solidFill>
-            <a:srgbClr val="F1F5F9"/>
+            <a:srgbClr val="CCFBF1"/>
           </a:solidFill>
           <a:ln w="12700">
             <a:solidFill>
-              <a:srgbClr val="F1F5F9"/>
+              <a:srgbClr val="CCFBF1"/>
             </a:solidFill>
             <a:prstDash val="solid"/>
           </a:ln>
@@ -3807,33 +3263,69 @@
       </p:sp>
       <p:sp>
         <p:nvSpPr>
-          <p:cNvPr id="45" name="Text 43"/>
-          <p:cNvSpPr/>
-          <p:nvPr/>
-        </p:nvSpPr>
-        <p:spPr>
-          <a:xfrm>
-            <a:off x="2790226" y="2139696"/>
-            <a:ext cx="1139081" cy="457200"/>
-          </a:xfrm>
-          <a:prstGeom prst="rect">
-            <a:avLst/>
-          </a:prstGeom>
-          <a:noFill/>
-          <a:ln/>
-        </p:spPr>
-        <p:txBody>
-          <a:bodyPr wrap="square" lIns="0" tIns="0" rIns="0" bIns="0" rtlCol="0" anchor="ctr"/>
-          <a:lstStyle/>
-          <a:p>
-            <a:pPr algn="ctr" indent="0" marL="0">
-              <a:lnSpc>
-                <a:spcPct val="120000"/>
-              </a:lnSpc>
-              <a:buNone/>
-            </a:pPr>
-            <a:r>
-              <a:rPr lang="en-US" sz="750" dirty="0">
+          <p:cNvPr id="32" name="Text 30"/>
+          <p:cNvSpPr/>
+          <p:nvPr/>
+        </p:nvSpPr>
+        <p:spPr>
+          <a:xfrm>
+            <a:off x="4846320" y="2578608"/>
+            <a:ext cx="1325880" cy="237744"/>
+          </a:xfrm>
+          <a:prstGeom prst="rect">
+            <a:avLst/>
+          </a:prstGeom>
+          <a:noFill/>
+          <a:ln/>
+        </p:spPr>
+        <p:txBody>
+          <a:bodyPr wrap="square" lIns="0" tIns="0" rIns="0" bIns="0" rtlCol="0" anchor="ctr"/>
+          <a:lstStyle/>
+          <a:p>
+            <a:pPr indent="0" marL="0">
+              <a:buNone/>
+            </a:pPr>
+            <a:r>
+              <a:rPr lang="en-US" sz="850" b="1" dirty="0">
+                <a:solidFill>
+                  <a:srgbClr val="0F766E"/>
+                </a:solidFill>
+                <a:latin typeface="Noto Sans KR" pitchFamily="34" charset="0"/>
+                <a:ea typeface="Noto Sans KR" pitchFamily="34" charset="-122"/>
+                <a:cs typeface="Noto Sans KR" pitchFamily="34" charset="-120"/>
+              </a:rPr>
+              <a:t>NG 자동 분리</a:t>
+            </a:r>
+            <a:endParaRPr lang="en-US" sz="850" dirty="0"/>
+          </a:p>
+        </p:txBody>
+      </p:sp>
+      <p:sp>
+        <p:nvSpPr>
+          <p:cNvPr id="33" name="Text 31"/>
+          <p:cNvSpPr/>
+          <p:nvPr/>
+        </p:nvSpPr>
+        <p:spPr>
+          <a:xfrm>
+            <a:off x="6199632" y="2578608"/>
+            <a:ext cx="2468880" cy="237744"/>
+          </a:xfrm>
+          <a:prstGeom prst="rect">
+            <a:avLst/>
+          </a:prstGeom>
+          <a:noFill/>
+          <a:ln/>
+        </p:spPr>
+        <p:txBody>
+          <a:bodyPr wrap="square" lIns="0" tIns="0" rIns="0" bIns="0" rtlCol="0" anchor="ctr"/>
+          <a:lstStyle/>
+          <a:p>
+            <a:pPr indent="0" marL="0">
+              <a:buNone/>
+            </a:pPr>
+            <a:r>
+              <a:rPr lang="en-US" sz="850" dirty="0">
                 <a:solidFill>
                   <a:srgbClr val="475569"/>
                 </a:solidFill>
@@ -3841,54 +3333,34 @@
                 <a:ea typeface="Noto Sans KR" pitchFamily="34" charset="-122"/>
                 <a:cs typeface="Noto Sans KR" pitchFamily="34" charset="-120"/>
               </a:rPr>
-              <a:t>라인 구조</a:t>
-            </a:r>
-            <a:endParaRPr lang="en-US" sz="750" dirty="0"/>
-          </a:p>
-          <a:p>
-            <a:pPr algn="ctr" indent="0" marL="0">
-              <a:lnSpc>
-                <a:spcPct val="120000"/>
-              </a:lnSpc>
-              <a:buNone/>
-            </a:pPr>
-            <a:r>
-              <a:rPr lang="en-US" sz="750" dirty="0">
-                <a:solidFill>
-                  <a:srgbClr val="475569"/>
-                </a:solidFill>
-                <a:latin typeface="Noto Sans KR" pitchFamily="34" charset="0"/>
-                <a:ea typeface="Noto Sans KR" pitchFamily="34" charset="-122"/>
-                <a:cs typeface="Noto Sans KR" pitchFamily="34" charset="-120"/>
-              </a:rPr>
-              <a:t>MES 환경 확인</a:t>
-            </a:r>
-            <a:endParaRPr lang="en-US" sz="750" dirty="0"/>
-          </a:p>
-        </p:txBody>
-      </p:sp>
-      <p:sp>
-        <p:nvSpPr>
-          <p:cNvPr id="46" name="Shape 44"/>
-          <p:cNvSpPr/>
-          <p:nvPr/>
-        </p:nvSpPr>
-        <p:spPr>
-          <a:xfrm>
-            <a:off x="4002459" y="2139696"/>
-            <a:ext cx="1139081" cy="457200"/>
+              <a:t>양불 자동 분리 배출 구조</a:t>
+            </a:r>
+            <a:endParaRPr lang="en-US" sz="850" dirty="0"/>
+          </a:p>
+        </p:txBody>
+      </p:sp>
+      <p:sp>
+        <p:nvSpPr>
+          <p:cNvPr id="34" name="Shape 32"/>
+          <p:cNvSpPr/>
+          <p:nvPr/>
+        </p:nvSpPr>
+        <p:spPr>
+          <a:xfrm>
+            <a:off x="4773168" y="2871216"/>
+            <a:ext cx="3895344" cy="237744"/>
           </a:xfrm>
           <a:prstGeom prst="roundRect">
             <a:avLst>
-              <a:gd name="adj" fmla="val 14000"/>
+              <a:gd name="adj" fmla="val 26923"/>
             </a:avLst>
           </a:prstGeom>
           <a:solidFill>
-            <a:srgbClr val="F1F5F9"/>
+            <a:srgbClr val="CCFBF1"/>
           </a:solidFill>
           <a:ln w="12700">
             <a:solidFill>
-              <a:srgbClr val="F1F5F9"/>
+              <a:srgbClr val="0D9488"/>
             </a:solidFill>
             <a:prstDash val="solid"/>
           </a:ln>
@@ -3903,14 +3375,14 @@
       </p:sp>
       <p:sp>
         <p:nvSpPr>
-          <p:cNvPr id="47" name="Text 45"/>
-          <p:cNvSpPr/>
-          <p:nvPr/>
-        </p:nvSpPr>
-        <p:spPr>
-          <a:xfrm>
-            <a:off x="4002459" y="2139696"/>
-            <a:ext cx="1139081" cy="457200"/>
+          <p:cNvPr id="35" name="Text 33"/>
+          <p:cNvSpPr/>
+          <p:nvPr/>
+        </p:nvSpPr>
+        <p:spPr>
+          <a:xfrm>
+            <a:off x="4773168" y="2871216"/>
+            <a:ext cx="3895344" cy="237744"/>
           </a:xfrm>
           <a:prstGeom prst="rect">
             <a:avLst/>
@@ -3923,68 +3395,70 @@
           <a:lstStyle/>
           <a:p>
             <a:pPr algn="ctr" indent="0" marL="0">
-              <a:lnSpc>
-                <a:spcPct val="120000"/>
-              </a:lnSpc>
-              <a:buNone/>
-            </a:pPr>
-            <a:r>
-              <a:rPr lang="en-US" sz="750" dirty="0">
-                <a:solidFill>
-                  <a:srgbClr val="475569"/>
-                </a:solidFill>
-                <a:latin typeface="Noto Sans KR" pitchFamily="34" charset="0"/>
-                <a:ea typeface="Noto Sans KR" pitchFamily="34" charset="-122"/>
-                <a:cs typeface="Noto Sans KR" pitchFamily="34" charset="-120"/>
-              </a:rPr>
-              <a:t>설치 조건</a:t>
-            </a:r>
-            <a:endParaRPr lang="en-US" sz="750" dirty="0"/>
-          </a:p>
-          <a:p>
-            <a:pPr algn="ctr" indent="0" marL="0">
-              <a:lnSpc>
-                <a:spcPct val="120000"/>
-              </a:lnSpc>
-              <a:buNone/>
-            </a:pPr>
-            <a:r>
-              <a:rPr lang="en-US" sz="750" dirty="0">
-                <a:solidFill>
-                  <a:srgbClr val="475569"/>
-                </a:solidFill>
-                <a:latin typeface="Noto Sans KR" pitchFamily="34" charset="0"/>
-                <a:ea typeface="Noto Sans KR" pitchFamily="34" charset="-122"/>
-                <a:cs typeface="Noto Sans KR" pitchFamily="34" charset="-120"/>
-              </a:rPr>
-              <a:t>MES 방식 협의</a:t>
-            </a:r>
-            <a:endParaRPr lang="en-US" sz="750" dirty="0"/>
-          </a:p>
-        </p:txBody>
-      </p:sp>
-      <p:sp>
-        <p:nvSpPr>
-          <p:cNvPr id="48" name="Shape 46"/>
-          <p:cNvSpPr/>
-          <p:nvPr/>
-        </p:nvSpPr>
-        <p:spPr>
-          <a:xfrm>
-            <a:off x="5214693" y="2139696"/>
-            <a:ext cx="1139081" cy="457200"/>
+              <a:buNone/>
+            </a:pPr>
+            <a:r>
+              <a:rPr lang="en-US" sz="800" b="1" dirty="0">
+                <a:solidFill>
+                  <a:srgbClr val="0F766E"/>
+                </a:solidFill>
+                <a:latin typeface="Noto Sans KR" pitchFamily="34" charset="0"/>
+                <a:ea typeface="Noto Sans KR" pitchFamily="34" charset="-122"/>
+                <a:cs typeface="Noto Sans KR" pitchFamily="34" charset="-120"/>
+              </a:rPr>
+              <a:t>검증 결과 확인 후 범위·일정·비용 별도 협의</a:t>
+            </a:r>
+            <a:endParaRPr lang="en-US" sz="800" dirty="0"/>
+          </a:p>
+        </p:txBody>
+      </p:sp>
+      <p:sp>
+        <p:nvSpPr>
+          <p:cNvPr id="36" name="Shape 34"/>
+          <p:cNvSpPr/>
+          <p:nvPr/>
+        </p:nvSpPr>
+        <p:spPr>
+          <a:xfrm>
+            <a:off x="4517136" y="2249424"/>
+            <a:ext cx="109728" cy="182880"/>
+          </a:xfrm>
+          <a:prstGeom prst="rightArrow">
+            <a:avLst/>
+          </a:prstGeom>
+          <a:solidFill>
+            <a:srgbClr val="F59E0B"/>
+          </a:solidFill>
+          <a:ln w="12700">
+            <a:solidFill>
+              <a:srgbClr val="F59E0B"/>
+            </a:solidFill>
+            <a:prstDash val="solid"/>
+          </a:ln>
+        </p:spPr>
+      </p:sp>
+      <p:sp>
+        <p:nvSpPr>
+          <p:cNvPr id="37" name="Shape 35"/>
+          <p:cNvSpPr/>
+          <p:nvPr/>
+        </p:nvSpPr>
+        <p:spPr>
+          <a:xfrm>
+            <a:off x="365760" y="3273552"/>
+            <a:ext cx="1341120" cy="566928"/>
           </a:xfrm>
           <a:prstGeom prst="roundRect">
             <a:avLst>
-              <a:gd name="adj" fmla="val 14000"/>
+              <a:gd name="adj" fmla="val 11290"/>
             </a:avLst>
           </a:prstGeom>
           <a:solidFill>
-            <a:srgbClr val="DBEAFE"/>
-          </a:solidFill>
-          <a:ln w="12700">
-            <a:solidFill>
-              <a:srgbClr val="DBEAFE"/>
+            <a:srgbClr val="FFFFFF"/>
+          </a:solidFill>
+          <a:ln w="15240">
+            <a:solidFill>
+              <a:srgbClr val="E2E8F0"/>
             </a:solidFill>
             <a:prstDash val="solid"/>
           </a:ln>
@@ -3999,14 +3473,39 @@
       </p:sp>
       <p:sp>
         <p:nvSpPr>
-          <p:cNvPr id="49" name="Text 47"/>
-          <p:cNvSpPr/>
-          <p:nvPr/>
-        </p:nvSpPr>
-        <p:spPr>
-          <a:xfrm>
-            <a:off x="5214693" y="2139696"/>
-            <a:ext cx="1139081" cy="457200"/>
+          <p:cNvPr id="38" name="Shape 36"/>
+          <p:cNvSpPr/>
+          <p:nvPr/>
+        </p:nvSpPr>
+        <p:spPr>
+          <a:xfrm>
+            <a:off x="880872" y="3328416"/>
+            <a:ext cx="310896" cy="310896"/>
+          </a:xfrm>
+          <a:prstGeom prst="ellipse">
+            <a:avLst/>
+          </a:prstGeom>
+          <a:solidFill>
+            <a:srgbClr val="DBEAFE"/>
+          </a:solidFill>
+          <a:ln w="12700">
+            <a:solidFill>
+              <a:srgbClr val="DBEAFE"/>
+            </a:solidFill>
+            <a:prstDash val="solid"/>
+          </a:ln>
+        </p:spPr>
+      </p:sp>
+      <p:sp>
+        <p:nvSpPr>
+          <p:cNvPr id="39" name="Text 37"/>
+          <p:cNvSpPr/>
+          <p:nvPr/>
+        </p:nvSpPr>
+        <p:spPr>
+          <a:xfrm>
+            <a:off x="880872" y="3328416"/>
+            <a:ext cx="310896" cy="310896"/>
           </a:xfrm>
           <a:prstGeom prst="rect">
             <a:avLst/>
@@ -4019,13 +3518,49 @@
           <a:lstStyle/>
           <a:p>
             <a:pPr algn="ctr" indent="0" marL="0">
-              <a:lnSpc>
-                <a:spcPct val="120000"/>
-              </a:lnSpc>
-              <a:buNone/>
-            </a:pPr>
-            <a:r>
-              <a:rPr lang="en-US" sz="750" dirty="0">
+              <a:buNone/>
+            </a:pPr>
+            <a:r>
+              <a:rPr lang="en-US" sz="800" b="1" dirty="0">
+                <a:solidFill>
+                  <a:srgbClr val="2563EB"/>
+                </a:solidFill>
+                <a:latin typeface="Noto Sans KR" pitchFamily="34" charset="0"/>
+                <a:ea typeface="Noto Sans KR" pitchFamily="34" charset="-122"/>
+                <a:cs typeface="Noto Sans KR" pitchFamily="34" charset="-120"/>
+              </a:rPr>
+              <a:t>01</a:t>
+            </a:r>
+            <a:endParaRPr lang="en-US" sz="800" dirty="0"/>
+          </a:p>
+        </p:txBody>
+      </p:sp>
+      <p:sp>
+        <p:nvSpPr>
+          <p:cNvPr id="40" name="Text 38"/>
+          <p:cNvSpPr/>
+          <p:nvPr/>
+        </p:nvSpPr>
+        <p:spPr>
+          <a:xfrm>
+            <a:off x="393192" y="3657600"/>
+            <a:ext cx="1286256" cy="164592"/>
+          </a:xfrm>
+          <a:prstGeom prst="rect">
+            <a:avLst/>
+          </a:prstGeom>
+          <a:noFill/>
+          <a:ln/>
+        </p:spPr>
+        <p:txBody>
+          <a:bodyPr wrap="square" lIns="0" tIns="0" rIns="0" bIns="0" rtlCol="0" anchor="ctr"/>
+          <a:lstStyle/>
+          <a:p>
+            <a:pPr algn="ctr" indent="0" marL="0">
+              <a:buNone/>
+            </a:pPr>
+            <a:r>
+              <a:rPr lang="en-US" sz="800" b="1" dirty="0">
                 <a:solidFill>
                   <a:srgbClr val="1B2F5E"/>
                 </a:solidFill>
@@ -4033,34 +3568,57 @@
                 <a:ea typeface="Noto Sans KR" pitchFamily="34" charset="-122"/>
                 <a:cs typeface="Noto Sans KR" pitchFamily="34" charset="-120"/>
               </a:rPr>
-              <a:t>약 40일</a:t>
-            </a:r>
-            <a:endParaRPr lang="en-US" sz="750" dirty="0"/>
-          </a:p>
-        </p:txBody>
-      </p:sp>
-      <p:sp>
-        <p:nvSpPr>
-          <p:cNvPr id="50" name="Shape 48"/>
-          <p:cNvSpPr/>
-          <p:nvPr/>
-        </p:nvSpPr>
-        <p:spPr>
-          <a:xfrm>
-            <a:off x="6426926" y="2139696"/>
-            <a:ext cx="1139081" cy="457200"/>
+              <a:t>샘플 입수</a:t>
+            </a:r>
+            <a:endParaRPr lang="en-US" sz="800" dirty="0"/>
+          </a:p>
+        </p:txBody>
+      </p:sp>
+      <p:sp>
+        <p:nvSpPr>
+          <p:cNvPr id="41" name="Shape 39"/>
+          <p:cNvSpPr/>
+          <p:nvPr/>
+        </p:nvSpPr>
+        <p:spPr>
+          <a:xfrm>
+            <a:off x="1706880" y="3557016"/>
+            <a:ext cx="73152" cy="0"/>
+          </a:xfrm>
+          <a:prstGeom prst="line">
+            <a:avLst/>
+          </a:prstGeom>
+          <a:noFill/>
+          <a:ln w="15240">
+            <a:solidFill>
+              <a:srgbClr val="94A3B8"/>
+            </a:solidFill>
+            <a:prstDash val="solid"/>
+          </a:ln>
+        </p:spPr>
+      </p:sp>
+      <p:sp>
+        <p:nvSpPr>
+          <p:cNvPr id="42" name="Shape 40"/>
+          <p:cNvSpPr/>
+          <p:nvPr/>
+        </p:nvSpPr>
+        <p:spPr>
+          <a:xfrm>
+            <a:off x="1780032" y="3273552"/>
+            <a:ext cx="1341120" cy="566928"/>
           </a:xfrm>
           <a:prstGeom prst="roundRect">
             <a:avLst>
-              <a:gd name="adj" fmla="val 14000"/>
+              <a:gd name="adj" fmla="val 11290"/>
             </a:avLst>
           </a:prstGeom>
           <a:solidFill>
-            <a:srgbClr val="DBEAFE"/>
-          </a:solidFill>
-          <a:ln w="12700">
-            <a:solidFill>
-              <a:srgbClr val="DBEAFE"/>
+            <a:srgbClr val="1B2F5E"/>
+          </a:solidFill>
+          <a:ln w="15240">
+            <a:solidFill>
+              <a:srgbClr val="1B2F5E"/>
             </a:solidFill>
             <a:prstDash val="solid"/>
           </a:ln>
@@ -4075,14 +3633,39 @@
       </p:sp>
       <p:sp>
         <p:nvSpPr>
-          <p:cNvPr id="51" name="Text 49"/>
-          <p:cNvSpPr/>
-          <p:nvPr/>
-        </p:nvSpPr>
-        <p:spPr>
-          <a:xfrm>
-            <a:off x="6426926" y="2139696"/>
-            <a:ext cx="1139081" cy="457200"/>
+          <p:cNvPr id="43" name="Shape 41"/>
+          <p:cNvSpPr/>
+          <p:nvPr/>
+        </p:nvSpPr>
+        <p:spPr>
+          <a:xfrm>
+            <a:off x="2295144" y="3328416"/>
+            <a:ext cx="310896" cy="310896"/>
+          </a:xfrm>
+          <a:prstGeom prst="ellipse">
+            <a:avLst/>
+          </a:prstGeom>
+          <a:solidFill>
+            <a:srgbClr val="F59E0B"/>
+          </a:solidFill>
+          <a:ln w="12700">
+            <a:solidFill>
+              <a:srgbClr val="F59E0B"/>
+            </a:solidFill>
+            <a:prstDash val="solid"/>
+          </a:ln>
+        </p:spPr>
+      </p:sp>
+      <p:sp>
+        <p:nvSpPr>
+          <p:cNvPr id="44" name="Text 42"/>
+          <p:cNvSpPr/>
+          <p:nvPr/>
+        </p:nvSpPr>
+        <p:spPr>
+          <a:xfrm>
+            <a:off x="2295144" y="3328416"/>
+            <a:ext cx="310896" cy="310896"/>
           </a:xfrm>
           <a:prstGeom prst="rect">
             <a:avLst/>
@@ -4095,13 +3678,10 @@
           <a:lstStyle/>
           <a:p>
             <a:pPr algn="ctr" indent="0" marL="0">
-              <a:lnSpc>
-                <a:spcPct val="120000"/>
-              </a:lnSpc>
-              <a:buNone/>
-            </a:pPr>
-            <a:r>
-              <a:rPr lang="en-US" sz="750" dirty="0">
+              <a:buNone/>
+            </a:pPr>
+            <a:r>
+              <a:rPr lang="en-US" sz="800" b="1" dirty="0">
                 <a:solidFill>
                   <a:srgbClr val="1B2F5E"/>
                 </a:solidFill>
@@ -4109,54 +3689,96 @@
                 <a:ea typeface="Noto Sans KR" pitchFamily="34" charset="-122"/>
                 <a:cs typeface="Noto Sans KR" pitchFamily="34" charset="-120"/>
               </a:rPr>
-              <a:t>MES 연계</a:t>
-            </a:r>
-            <a:endParaRPr lang="en-US" sz="750" dirty="0"/>
-          </a:p>
+              <a:t>02</a:t>
+            </a:r>
+            <a:endParaRPr lang="en-US" sz="800" dirty="0"/>
+          </a:p>
+        </p:txBody>
+      </p:sp>
+      <p:sp>
+        <p:nvSpPr>
+          <p:cNvPr id="45" name="Text 43"/>
+          <p:cNvSpPr/>
+          <p:nvPr/>
+        </p:nvSpPr>
+        <p:spPr>
+          <a:xfrm>
+            <a:off x="1807464" y="3657600"/>
+            <a:ext cx="1286256" cy="164592"/>
+          </a:xfrm>
+          <a:prstGeom prst="rect">
+            <a:avLst/>
+          </a:prstGeom>
+          <a:noFill/>
+          <a:ln/>
+        </p:spPr>
+        <p:txBody>
+          <a:bodyPr wrap="square" lIns="0" tIns="0" rIns="0" bIns="0" rtlCol="0" anchor="ctr"/>
+          <a:lstStyle/>
           <a:p>
             <a:pPr algn="ctr" indent="0" marL="0">
-              <a:lnSpc>
-                <a:spcPct val="120000"/>
-              </a:lnSpc>
-              <a:buNone/>
-            </a:pPr>
-            <a:r>
-              <a:rPr lang="en-US" sz="750" dirty="0">
-                <a:solidFill>
-                  <a:srgbClr val="1B2F5E"/>
-                </a:solidFill>
-                <a:latin typeface="Noto Sans KR" pitchFamily="34" charset="0"/>
-                <a:ea typeface="Noto Sans KR" pitchFamily="34" charset="-122"/>
-                <a:cs typeface="Noto Sans KR" pitchFamily="34" charset="-120"/>
-              </a:rPr>
-              <a:t>약 2주</a:t>
-            </a:r>
-            <a:endParaRPr lang="en-US" sz="750" dirty="0"/>
-          </a:p>
-        </p:txBody>
-      </p:sp>
-      <p:sp>
-        <p:nvSpPr>
-          <p:cNvPr id="52" name="Shape 50"/>
-          <p:cNvSpPr/>
-          <p:nvPr/>
-        </p:nvSpPr>
-        <p:spPr>
-          <a:xfrm>
-            <a:off x="7639159" y="2139696"/>
-            <a:ext cx="1139081" cy="457200"/>
+              <a:buNone/>
+            </a:pPr>
+            <a:r>
+              <a:rPr lang="en-US" sz="800" b="1" dirty="0">
+                <a:solidFill>
+                  <a:srgbClr val="FFFFFF"/>
+                </a:solidFill>
+                <a:latin typeface="Noto Sans KR" pitchFamily="34" charset="0"/>
+                <a:ea typeface="Noto Sans KR" pitchFamily="34" charset="-122"/>
+                <a:cs typeface="Noto Sans KR" pitchFamily="34" charset="-120"/>
+              </a:rPr>
+              <a:t>검토 리포트</a:t>
+            </a:r>
+            <a:endParaRPr lang="en-US" sz="800" dirty="0"/>
+          </a:p>
+        </p:txBody>
+      </p:sp>
+      <p:sp>
+        <p:nvSpPr>
+          <p:cNvPr id="46" name="Shape 44"/>
+          <p:cNvSpPr/>
+          <p:nvPr/>
+        </p:nvSpPr>
+        <p:spPr>
+          <a:xfrm>
+            <a:off x="3121152" y="3557016"/>
+            <a:ext cx="73152" cy="0"/>
+          </a:xfrm>
+          <a:prstGeom prst="line">
+            <a:avLst/>
+          </a:prstGeom>
+          <a:noFill/>
+          <a:ln w="15240">
+            <a:solidFill>
+              <a:srgbClr val="94A3B8"/>
+            </a:solidFill>
+            <a:prstDash val="solid"/>
+          </a:ln>
+        </p:spPr>
+      </p:sp>
+      <p:sp>
+        <p:nvSpPr>
+          <p:cNvPr id="47" name="Shape 45"/>
+          <p:cNvSpPr/>
+          <p:nvPr/>
+        </p:nvSpPr>
+        <p:spPr>
+          <a:xfrm>
+            <a:off x="3194304" y="3273552"/>
+            <a:ext cx="1341120" cy="566928"/>
           </a:xfrm>
           <a:prstGeom prst="roundRect">
             <a:avLst>
-              <a:gd name="adj" fmla="val 14000"/>
+              <a:gd name="adj" fmla="val 11290"/>
             </a:avLst>
           </a:prstGeom>
           <a:solidFill>
-            <a:srgbClr val="F1F5F9"/>
-          </a:solidFill>
-          <a:ln w="12700">
-            <a:solidFill>
-              <a:srgbClr val="F1F5F9"/>
+            <a:srgbClr val="FFFFFF"/>
+          </a:solidFill>
+          <a:ln w="15240">
+            <a:solidFill>
+              <a:srgbClr val="E2E8F0"/>
             </a:solidFill>
             <a:prstDash val="solid"/>
           </a:ln>
@@ -4171,14 +3793,39 @@
       </p:sp>
       <p:sp>
         <p:nvSpPr>
-          <p:cNvPr id="53" name="Text 51"/>
-          <p:cNvSpPr/>
-          <p:nvPr/>
-        </p:nvSpPr>
-        <p:spPr>
-          <a:xfrm>
-            <a:off x="7639159" y="2139696"/>
-            <a:ext cx="1139081" cy="457200"/>
+          <p:cNvPr id="48" name="Shape 46"/>
+          <p:cNvSpPr/>
+          <p:nvPr/>
+        </p:nvSpPr>
+        <p:spPr>
+          <a:xfrm>
+            <a:off x="3709416" y="3328416"/>
+            <a:ext cx="310896" cy="310896"/>
+          </a:xfrm>
+          <a:prstGeom prst="ellipse">
+            <a:avLst/>
+          </a:prstGeom>
+          <a:solidFill>
+            <a:srgbClr val="DBEAFE"/>
+          </a:solidFill>
+          <a:ln w="12700">
+            <a:solidFill>
+              <a:srgbClr val="DBEAFE"/>
+            </a:solidFill>
+            <a:prstDash val="solid"/>
+          </a:ln>
+        </p:spPr>
+      </p:sp>
+      <p:sp>
+        <p:nvSpPr>
+          <p:cNvPr id="49" name="Text 47"/>
+          <p:cNvSpPr/>
+          <p:nvPr/>
+        </p:nvSpPr>
+        <p:spPr>
+          <a:xfrm>
+            <a:off x="3709416" y="3328416"/>
+            <a:ext cx="310896" cy="310896"/>
           </a:xfrm>
           <a:prstGeom prst="rect">
             <a:avLst/>
@@ -4191,144 +3838,57 @@
           <a:lstStyle/>
           <a:p>
             <a:pPr algn="ctr" indent="0" marL="0">
-              <a:lnSpc>
-                <a:spcPct val="120000"/>
-              </a:lnSpc>
-              <a:buNone/>
-            </a:pPr>
-            <a:r>
-              <a:rPr lang="en-US" sz="750" dirty="0">
-                <a:solidFill>
-                  <a:srgbClr val="475569"/>
-                </a:solidFill>
-                <a:latin typeface="Noto Sans KR" pitchFamily="34" charset="0"/>
-                <a:ea typeface="Noto Sans KR" pitchFamily="34" charset="-122"/>
-                <a:cs typeface="Noto Sans KR" pitchFamily="34" charset="-120"/>
-              </a:rPr>
-              <a:t>검출율 확인</a:t>
-            </a:r>
-            <a:endParaRPr lang="en-US" sz="750" dirty="0"/>
-          </a:p>
+              <a:buNone/>
+            </a:pPr>
+            <a:r>
+              <a:rPr lang="en-US" sz="800" b="1" dirty="0">
+                <a:solidFill>
+                  <a:srgbClr val="2563EB"/>
+                </a:solidFill>
+                <a:latin typeface="Noto Sans KR" pitchFamily="34" charset="0"/>
+                <a:ea typeface="Noto Sans KR" pitchFamily="34" charset="-122"/>
+                <a:cs typeface="Noto Sans KR" pitchFamily="34" charset="-120"/>
+              </a:rPr>
+              <a:t>03</a:t>
+            </a:r>
+            <a:endParaRPr lang="en-US" sz="800" dirty="0"/>
+          </a:p>
+        </p:txBody>
+      </p:sp>
+      <p:sp>
+        <p:nvSpPr>
+          <p:cNvPr id="50" name="Text 48"/>
+          <p:cNvSpPr/>
+          <p:nvPr/>
+        </p:nvSpPr>
+        <p:spPr>
+          <a:xfrm>
+            <a:off x="3221736" y="3657600"/>
+            <a:ext cx="1286256" cy="164592"/>
+          </a:xfrm>
+          <a:prstGeom prst="rect">
+            <a:avLst/>
+          </a:prstGeom>
+          <a:noFill/>
+          <a:ln/>
+        </p:spPr>
+        <p:txBody>
+          <a:bodyPr wrap="square" lIns="0" tIns="0" rIns="0" bIns="0" rtlCol="0" anchor="ctr"/>
+          <a:lstStyle/>
           <a:p>
             <a:pPr algn="ctr" indent="0" marL="0">
-              <a:lnSpc>
-                <a:spcPct val="120000"/>
-              </a:lnSpc>
-              <a:buNone/>
-            </a:pPr>
-            <a:r>
-              <a:rPr lang="en-US" sz="750" dirty="0">
-                <a:solidFill>
-                  <a:srgbClr val="475569"/>
-                </a:solidFill>
-                <a:latin typeface="Noto Sans KR" pitchFamily="34" charset="0"/>
-                <a:ea typeface="Noto Sans KR" pitchFamily="34" charset="-122"/>
-                <a:cs typeface="Noto Sans KR" pitchFamily="34" charset="-120"/>
-              </a:rPr>
-              <a:t>생산팀 인수</a:t>
-            </a:r>
-            <a:endParaRPr lang="en-US" sz="750" dirty="0"/>
-          </a:p>
-        </p:txBody>
-      </p:sp>
-      <p:sp>
-        <p:nvSpPr>
-          <p:cNvPr id="54" name="Shape 52"/>
-          <p:cNvSpPr/>
-          <p:nvPr/>
-        </p:nvSpPr>
-        <p:spPr>
-          <a:xfrm>
-            <a:off x="365760" y="3255264"/>
-            <a:ext cx="1280160" cy="566928"/>
-          </a:xfrm>
-          <a:prstGeom prst="rect">
-            <a:avLst/>
-          </a:prstGeom>
-          <a:solidFill>
-            <a:srgbClr val="2563EB"/>
-          </a:solidFill>
-          <a:ln w="12700">
-            <a:solidFill>
-              <a:srgbClr val="2563EB"/>
-            </a:solidFill>
-            <a:prstDash val="solid"/>
-          </a:ln>
-        </p:spPr>
-      </p:sp>
-      <p:sp>
-        <p:nvSpPr>
-          <p:cNvPr id="55" name="Text 53"/>
-          <p:cNvSpPr/>
-          <p:nvPr/>
-        </p:nvSpPr>
-        <p:spPr>
-          <a:xfrm>
-            <a:off x="365760" y="3291840"/>
-            <a:ext cx="1280160" cy="274320"/>
-          </a:xfrm>
-          <a:prstGeom prst="rect">
-            <a:avLst/>
-          </a:prstGeom>
-          <a:noFill/>
-          <a:ln/>
-        </p:spPr>
-        <p:txBody>
-          <a:bodyPr wrap="square" lIns="0" tIns="0" rIns="0" bIns="0" rtlCol="0" anchor="ctr"/>
-          <a:lstStyle/>
-          <a:p>
-            <a:pPr algn="ctr" indent="0" marL="0">
-              <a:buNone/>
-            </a:pPr>
-            <a:r>
-              <a:rPr lang="en-US" sz="850" b="1" dirty="0">
-                <a:solidFill>
-                  <a:srgbClr val="FFFFFF"/>
-                </a:solidFill>
-                <a:latin typeface="Noto Sans KR" pitchFamily="34" charset="0"/>
-                <a:ea typeface="Noto Sans KR" pitchFamily="34" charset="-122"/>
-                <a:cs typeface="Noto Sans KR" pitchFamily="34" charset="-120"/>
-              </a:rPr>
-              <a:t>샘플 &amp; 리포트</a:t>
-            </a:r>
-            <a:endParaRPr lang="en-US" sz="850" dirty="0"/>
-          </a:p>
-        </p:txBody>
-      </p:sp>
-      <p:sp>
-        <p:nvSpPr>
-          <p:cNvPr id="56" name="Text 54"/>
-          <p:cNvSpPr/>
-          <p:nvPr/>
-        </p:nvSpPr>
-        <p:spPr>
-          <a:xfrm>
-            <a:off x="365760" y="3566160"/>
-            <a:ext cx="1280160" cy="219456"/>
-          </a:xfrm>
-          <a:prstGeom prst="rect">
-            <a:avLst/>
-          </a:prstGeom>
-          <a:noFill/>
-          <a:ln/>
-        </p:spPr>
-        <p:txBody>
-          <a:bodyPr wrap="square" lIns="0" tIns="0" rIns="0" bIns="0" rtlCol="0" anchor="ctr"/>
-          <a:lstStyle/>
-          <a:p>
-            <a:pPr algn="ctr" indent="0" marL="0">
-              <a:buNone/>
-            </a:pPr>
-            <a:r>
-              <a:rPr lang="en-US" sz="800" dirty="0">
-                <a:solidFill>
-                  <a:srgbClr val="DBEAFE"/>
-                </a:solidFill>
-                <a:latin typeface="Noto Sans KR" pitchFamily="34" charset="0"/>
-                <a:ea typeface="Noto Sans KR" pitchFamily="34" charset="-122"/>
-                <a:cs typeface="Noto Sans KR" pitchFamily="34" charset="-120"/>
-              </a:rPr>
-              <a:t>1~2주</a:t>
+              <a:buNone/>
+            </a:pPr>
+            <a:r>
+              <a:rPr lang="en-US" sz="800" b="1" dirty="0">
+                <a:solidFill>
+                  <a:srgbClr val="1B2F5E"/>
+                </a:solidFill>
+                <a:latin typeface="Noto Sans KR" pitchFamily="34" charset="0"/>
+                <a:ea typeface="Noto Sans KR" pitchFamily="34" charset="-122"/>
+                <a:cs typeface="Noto Sans KR" pitchFamily="34" charset="-120"/>
+              </a:rPr>
+              <a:t>사양 확정</a:t>
             </a:r>
             <a:endParaRPr lang="en-US" sz="800" dirty="0"/>
           </a:p>
@@ -4336,438 +3896,49 @@
       </p:sp>
       <p:sp>
         <p:nvSpPr>
-          <p:cNvPr id="57" name="Shape 55"/>
-          <p:cNvSpPr/>
-          <p:nvPr/>
-        </p:nvSpPr>
-        <p:spPr>
-          <a:xfrm>
-            <a:off x="1645920" y="3255264"/>
-            <a:ext cx="822960" cy="566928"/>
-          </a:xfrm>
-          <a:prstGeom prst="rect">
-            <a:avLst/>
-          </a:prstGeom>
-          <a:solidFill>
-            <a:srgbClr val="5B8DEF"/>
-          </a:solidFill>
-          <a:ln w="12700">
-            <a:solidFill>
-              <a:srgbClr val="5B8DEF"/>
-            </a:solidFill>
-            <a:prstDash val="solid"/>
-          </a:ln>
-        </p:spPr>
-      </p:sp>
-      <p:sp>
-        <p:nvSpPr>
-          <p:cNvPr id="58" name="Text 56"/>
-          <p:cNvSpPr/>
-          <p:nvPr/>
-        </p:nvSpPr>
-        <p:spPr>
-          <a:xfrm>
-            <a:off x="1645920" y="3291840"/>
-            <a:ext cx="822960" cy="274320"/>
-          </a:xfrm>
-          <a:prstGeom prst="rect">
-            <a:avLst/>
-          </a:prstGeom>
-          <a:noFill/>
-          <a:ln/>
-        </p:spPr>
-        <p:txBody>
-          <a:bodyPr wrap="square" lIns="0" tIns="0" rIns="0" bIns="0" rtlCol="0" anchor="ctr"/>
-          <a:lstStyle/>
-          <a:p>
-            <a:pPr algn="ctr" indent="0" marL="0">
-              <a:buNone/>
-            </a:pPr>
-            <a:r>
-              <a:rPr lang="en-US" sz="850" b="1" dirty="0">
-                <a:solidFill>
-                  <a:srgbClr val="FFFFFF"/>
-                </a:solidFill>
-                <a:latin typeface="Noto Sans KR" pitchFamily="34" charset="0"/>
-                <a:ea typeface="Noto Sans KR" pitchFamily="34" charset="-122"/>
-                <a:cs typeface="Noto Sans KR" pitchFamily="34" charset="-120"/>
-              </a:rPr>
-              <a:t>실사·사양</a:t>
-            </a:r>
-            <a:endParaRPr lang="en-US" sz="850" dirty="0"/>
-          </a:p>
-        </p:txBody>
-      </p:sp>
-      <p:sp>
-        <p:nvSpPr>
-          <p:cNvPr id="59" name="Text 57"/>
-          <p:cNvSpPr/>
-          <p:nvPr/>
-        </p:nvSpPr>
-        <p:spPr>
-          <a:xfrm>
-            <a:off x="1645920" y="3566160"/>
-            <a:ext cx="822960" cy="219456"/>
-          </a:xfrm>
-          <a:prstGeom prst="rect">
-            <a:avLst/>
-          </a:prstGeom>
-          <a:noFill/>
-          <a:ln/>
-        </p:spPr>
-        <p:txBody>
-          <a:bodyPr wrap="square" lIns="0" tIns="0" rIns="0" bIns="0" rtlCol="0" anchor="ctr"/>
-          <a:lstStyle/>
-          <a:p>
-            <a:pPr algn="ctr" indent="0" marL="0">
-              <a:buNone/>
-            </a:pPr>
-            <a:r>
-              <a:rPr lang="en-US" sz="800" dirty="0">
-                <a:solidFill>
-                  <a:srgbClr val="DBEAFE"/>
-                </a:solidFill>
-                <a:latin typeface="Noto Sans KR" pitchFamily="34" charset="0"/>
-                <a:ea typeface="Noto Sans KR" pitchFamily="34" charset="-122"/>
-                <a:cs typeface="Noto Sans KR" pitchFamily="34" charset="-120"/>
-              </a:rPr>
-              <a:t>1주</a:t>
-            </a:r>
-            <a:endParaRPr lang="en-US" sz="800" dirty="0"/>
-          </a:p>
-        </p:txBody>
-      </p:sp>
-      <p:sp>
-        <p:nvSpPr>
-          <p:cNvPr id="60" name="Shape 58"/>
-          <p:cNvSpPr/>
-          <p:nvPr/>
-        </p:nvSpPr>
-        <p:spPr>
-          <a:xfrm>
-            <a:off x="2468880" y="3255264"/>
-            <a:ext cx="2926080" cy="566928"/>
-          </a:xfrm>
-          <a:prstGeom prst="rect">
-            <a:avLst/>
-          </a:prstGeom>
-          <a:solidFill>
-            <a:srgbClr val="1B2F5E"/>
-          </a:solidFill>
-          <a:ln w="12700">
-            <a:solidFill>
-              <a:srgbClr val="1B2F5E"/>
-            </a:solidFill>
-            <a:prstDash val="solid"/>
-          </a:ln>
-        </p:spPr>
-      </p:sp>
-      <p:sp>
-        <p:nvSpPr>
-          <p:cNvPr id="61" name="Text 59"/>
-          <p:cNvSpPr/>
-          <p:nvPr/>
-        </p:nvSpPr>
-        <p:spPr>
-          <a:xfrm>
-            <a:off x="2468880" y="3291840"/>
-            <a:ext cx="2926080" cy="274320"/>
-          </a:xfrm>
-          <a:prstGeom prst="rect">
-            <a:avLst/>
-          </a:prstGeom>
-          <a:noFill/>
-          <a:ln/>
-        </p:spPr>
-        <p:txBody>
-          <a:bodyPr wrap="square" lIns="0" tIns="0" rIns="0" bIns="0" rtlCol="0" anchor="ctr"/>
-          <a:lstStyle/>
-          <a:p>
-            <a:pPr algn="ctr" indent="0" marL="0">
-              <a:buNone/>
-            </a:pPr>
-            <a:r>
-              <a:rPr lang="en-US" sz="850" b="1" dirty="0">
-                <a:solidFill>
-                  <a:srgbClr val="FFFFFF"/>
-                </a:solidFill>
-                <a:latin typeface="Noto Sans KR" pitchFamily="34" charset="0"/>
-                <a:ea typeface="Noto Sans KR" pitchFamily="34" charset="-122"/>
-                <a:cs typeface="Noto Sans KR" pitchFamily="34" charset="-120"/>
-              </a:rPr>
-              <a:t>개발·제작</a:t>
-            </a:r>
-            <a:endParaRPr lang="en-US" sz="850" dirty="0"/>
-          </a:p>
-        </p:txBody>
-      </p:sp>
-      <p:sp>
-        <p:nvSpPr>
-          <p:cNvPr id="62" name="Text 60"/>
-          <p:cNvSpPr/>
-          <p:nvPr/>
-        </p:nvSpPr>
-        <p:spPr>
-          <a:xfrm>
-            <a:off x="2468880" y="3566160"/>
-            <a:ext cx="2926080" cy="219456"/>
-          </a:xfrm>
-          <a:prstGeom prst="rect">
-            <a:avLst/>
-          </a:prstGeom>
-          <a:noFill/>
-          <a:ln/>
-        </p:spPr>
-        <p:txBody>
-          <a:bodyPr wrap="square" lIns="0" tIns="0" rIns="0" bIns="0" rtlCol="0" anchor="ctr"/>
-          <a:lstStyle/>
-          <a:p>
-            <a:pPr algn="ctr" indent="0" marL="0">
-              <a:buNone/>
-            </a:pPr>
-            <a:r>
-              <a:rPr lang="en-US" sz="800" dirty="0">
-                <a:solidFill>
-                  <a:srgbClr val="DBEAFE"/>
-                </a:solidFill>
-                <a:latin typeface="Noto Sans KR" pitchFamily="34" charset="0"/>
-                <a:ea typeface="Noto Sans KR" pitchFamily="34" charset="-122"/>
-                <a:cs typeface="Noto Sans KR" pitchFamily="34" charset="-120"/>
-              </a:rPr>
-              <a:t>약 40일</a:t>
-            </a:r>
-            <a:endParaRPr lang="en-US" sz="800" dirty="0"/>
-          </a:p>
-        </p:txBody>
-      </p:sp>
-      <p:sp>
-        <p:nvSpPr>
-          <p:cNvPr id="63" name="Shape 61"/>
-          <p:cNvSpPr/>
-          <p:nvPr/>
-        </p:nvSpPr>
-        <p:spPr>
-          <a:xfrm>
-            <a:off x="5394960" y="3255264"/>
-            <a:ext cx="1463040" cy="566928"/>
-          </a:xfrm>
-          <a:prstGeom prst="rect">
-            <a:avLst/>
-          </a:prstGeom>
-          <a:solidFill>
-            <a:srgbClr val="0D9488"/>
-          </a:solidFill>
-          <a:ln w="12700">
-            <a:solidFill>
-              <a:srgbClr val="0D9488"/>
-            </a:solidFill>
-            <a:prstDash val="solid"/>
-          </a:ln>
-        </p:spPr>
-      </p:sp>
-      <p:sp>
-        <p:nvSpPr>
-          <p:cNvPr id="64" name="Text 62"/>
-          <p:cNvSpPr/>
-          <p:nvPr/>
-        </p:nvSpPr>
-        <p:spPr>
-          <a:xfrm>
-            <a:off x="5394960" y="3291840"/>
-            <a:ext cx="1463040" cy="274320"/>
-          </a:xfrm>
-          <a:prstGeom prst="rect">
-            <a:avLst/>
-          </a:prstGeom>
-          <a:noFill/>
-          <a:ln/>
-        </p:spPr>
-        <p:txBody>
-          <a:bodyPr wrap="square" lIns="0" tIns="0" rIns="0" bIns="0" rtlCol="0" anchor="ctr"/>
-          <a:lstStyle/>
-          <a:p>
-            <a:pPr algn="ctr" indent="0" marL="0">
-              <a:buNone/>
-            </a:pPr>
-            <a:r>
-              <a:rPr lang="en-US" sz="850" b="1" dirty="0">
-                <a:solidFill>
-                  <a:srgbClr val="FFFFFF"/>
-                </a:solidFill>
-                <a:latin typeface="Noto Sans KR" pitchFamily="34" charset="0"/>
-                <a:ea typeface="Noto Sans KR" pitchFamily="34" charset="-122"/>
-                <a:cs typeface="Noto Sans KR" pitchFamily="34" charset="-120"/>
-              </a:rPr>
-              <a:t>설치·테스트</a:t>
-            </a:r>
-            <a:endParaRPr lang="en-US" sz="850" dirty="0"/>
-          </a:p>
-        </p:txBody>
-      </p:sp>
-      <p:sp>
-        <p:nvSpPr>
-          <p:cNvPr id="65" name="Text 63"/>
-          <p:cNvSpPr/>
-          <p:nvPr/>
-        </p:nvSpPr>
-        <p:spPr>
-          <a:xfrm>
-            <a:off x="5394960" y="3566160"/>
-            <a:ext cx="1463040" cy="219456"/>
-          </a:xfrm>
-          <a:prstGeom prst="rect">
-            <a:avLst/>
-          </a:prstGeom>
-          <a:noFill/>
-          <a:ln/>
-        </p:spPr>
-        <p:txBody>
-          <a:bodyPr wrap="square" lIns="0" tIns="0" rIns="0" bIns="0" rtlCol="0" anchor="ctr"/>
-          <a:lstStyle/>
-          <a:p>
-            <a:pPr algn="ctr" indent="0" marL="0">
-              <a:buNone/>
-            </a:pPr>
-            <a:r>
-              <a:rPr lang="en-US" sz="800" dirty="0">
-                <a:solidFill>
-                  <a:srgbClr val="DBEAFE"/>
-                </a:solidFill>
-                <a:latin typeface="Noto Sans KR" pitchFamily="34" charset="0"/>
-                <a:ea typeface="Noto Sans KR" pitchFamily="34" charset="-122"/>
-                <a:cs typeface="Noto Sans KR" pitchFamily="34" charset="-120"/>
-              </a:rPr>
-              <a:t>약 2주</a:t>
-            </a:r>
-            <a:endParaRPr lang="en-US" sz="800" dirty="0"/>
-          </a:p>
-        </p:txBody>
-      </p:sp>
-      <p:sp>
-        <p:nvSpPr>
-          <p:cNvPr id="66" name="Shape 64"/>
-          <p:cNvSpPr/>
-          <p:nvPr/>
-        </p:nvSpPr>
-        <p:spPr>
-          <a:xfrm>
-            <a:off x="6858000" y="3255264"/>
-            <a:ext cx="1005840" cy="566928"/>
-          </a:xfrm>
-          <a:prstGeom prst="rect">
-            <a:avLst/>
-          </a:prstGeom>
-          <a:solidFill>
-            <a:srgbClr val="0D9488"/>
-          </a:solidFill>
-          <a:ln w="12700">
-            <a:solidFill>
-              <a:srgbClr val="0D9488"/>
-            </a:solidFill>
-            <a:prstDash val="solid"/>
-          </a:ln>
-        </p:spPr>
-      </p:sp>
-      <p:sp>
-        <p:nvSpPr>
-          <p:cNvPr id="67" name="Text 65"/>
-          <p:cNvSpPr/>
-          <p:nvPr/>
-        </p:nvSpPr>
-        <p:spPr>
-          <a:xfrm>
-            <a:off x="6858000" y="3291840"/>
-            <a:ext cx="1005840" cy="274320"/>
-          </a:xfrm>
-          <a:prstGeom prst="rect">
-            <a:avLst/>
-          </a:prstGeom>
-          <a:noFill/>
-          <a:ln/>
-        </p:spPr>
-        <p:txBody>
-          <a:bodyPr wrap="square" lIns="0" tIns="0" rIns="0" bIns="0" rtlCol="0" anchor="ctr"/>
-          <a:lstStyle/>
-          <a:p>
-            <a:pPr algn="ctr" indent="0" marL="0">
-              <a:buNone/>
-            </a:pPr>
-            <a:r>
-              <a:rPr lang="en-US" sz="850" b="1" dirty="0">
-                <a:solidFill>
-                  <a:srgbClr val="FFFFFF"/>
-                </a:solidFill>
-                <a:latin typeface="Noto Sans KR" pitchFamily="34" charset="0"/>
-                <a:ea typeface="Noto Sans KR" pitchFamily="34" charset="-122"/>
-                <a:cs typeface="Noto Sans KR" pitchFamily="34" charset="-120"/>
-              </a:rPr>
-              <a:t>검증·인수</a:t>
-            </a:r>
-            <a:endParaRPr lang="en-US" sz="850" dirty="0"/>
-          </a:p>
-        </p:txBody>
-      </p:sp>
-      <p:sp>
-        <p:nvSpPr>
-          <p:cNvPr id="68" name="Text 66"/>
-          <p:cNvSpPr/>
-          <p:nvPr/>
-        </p:nvSpPr>
-        <p:spPr>
-          <a:xfrm>
-            <a:off x="6858000" y="3566160"/>
-            <a:ext cx="1005840" cy="219456"/>
-          </a:xfrm>
-          <a:prstGeom prst="rect">
-            <a:avLst/>
-          </a:prstGeom>
-          <a:noFill/>
-          <a:ln/>
-        </p:spPr>
-        <p:txBody>
-          <a:bodyPr wrap="square" lIns="0" tIns="0" rIns="0" bIns="0" rtlCol="0" anchor="ctr"/>
-          <a:lstStyle/>
-          <a:p>
-            <a:pPr algn="ctr" indent="0" marL="0">
-              <a:buNone/>
-            </a:pPr>
-            <a:r>
-              <a:rPr lang="en-US" sz="800" dirty="0">
-                <a:solidFill>
-                  <a:srgbClr val="DBEAFE"/>
-                </a:solidFill>
-                <a:latin typeface="Noto Sans KR" pitchFamily="34" charset="0"/>
-                <a:ea typeface="Noto Sans KR" pitchFamily="34" charset="-122"/>
-                <a:cs typeface="Noto Sans KR" pitchFamily="34" charset="-120"/>
-              </a:rPr>
-              <a:t>~</a:t>
-            </a:r>
-            <a:endParaRPr lang="en-US" sz="800" dirty="0"/>
-          </a:p>
-        </p:txBody>
-      </p:sp>
-      <p:sp>
-        <p:nvSpPr>
-          <p:cNvPr id="69" name="Shape 67"/>
-          <p:cNvSpPr/>
-          <p:nvPr/>
-        </p:nvSpPr>
-        <p:spPr>
-          <a:xfrm>
-            <a:off x="365760" y="3931920"/>
-            <a:ext cx="8412480" cy="603504"/>
+          <p:cNvPr id="51" name="Shape 49"/>
+          <p:cNvSpPr/>
+          <p:nvPr/>
+        </p:nvSpPr>
+        <p:spPr>
+          <a:xfrm>
+            <a:off x="4535424" y="3557016"/>
+            <a:ext cx="73152" cy="0"/>
+          </a:xfrm>
+          <a:prstGeom prst="line">
+            <a:avLst/>
+          </a:prstGeom>
+          <a:noFill/>
+          <a:ln w="15240">
+            <a:solidFill>
+              <a:srgbClr val="94A3B8"/>
+            </a:solidFill>
+            <a:prstDash val="solid"/>
+          </a:ln>
+        </p:spPr>
+      </p:sp>
+      <p:sp>
+        <p:nvSpPr>
+          <p:cNvPr id="52" name="Shape 50"/>
+          <p:cNvSpPr/>
+          <p:nvPr/>
+        </p:nvSpPr>
+        <p:spPr>
+          <a:xfrm>
+            <a:off x="4608576" y="3273552"/>
+            <a:ext cx="1341120" cy="566928"/>
           </a:xfrm>
           <a:prstGeom prst="roundRect">
             <a:avLst>
-              <a:gd name="adj" fmla="val 10606"/>
+              <a:gd name="adj" fmla="val 11290"/>
             </a:avLst>
           </a:prstGeom>
           <a:solidFill>
-            <a:srgbClr val="DBEAFE"/>
-          </a:solidFill>
-          <a:ln w="19050">
-            <a:solidFill>
-              <a:srgbClr val="2563EB"/>
+            <a:srgbClr val="1B2F5E"/>
+          </a:solidFill>
+          <a:ln w="15240">
+            <a:solidFill>
+              <a:srgbClr val="1B2F5E"/>
             </a:solidFill>
             <a:prstDash val="solid"/>
           </a:ln>
@@ -4782,14 +3953,39 @@
       </p:sp>
       <p:sp>
         <p:nvSpPr>
-          <p:cNvPr id="70" name="Text 68"/>
-          <p:cNvSpPr/>
-          <p:nvPr/>
-        </p:nvSpPr>
-        <p:spPr>
-          <a:xfrm>
-            <a:off x="548640" y="3931920"/>
-            <a:ext cx="8046720" cy="603504"/>
+          <p:cNvPr id="53" name="Shape 51"/>
+          <p:cNvSpPr/>
+          <p:nvPr/>
+        </p:nvSpPr>
+        <p:spPr>
+          <a:xfrm>
+            <a:off x="5123688" y="3328416"/>
+            <a:ext cx="310896" cy="310896"/>
+          </a:xfrm>
+          <a:prstGeom prst="ellipse">
+            <a:avLst/>
+          </a:prstGeom>
+          <a:solidFill>
+            <a:srgbClr val="F59E0B"/>
+          </a:solidFill>
+          <a:ln w="12700">
+            <a:solidFill>
+              <a:srgbClr val="F59E0B"/>
+            </a:solidFill>
+            <a:prstDash val="solid"/>
+          </a:ln>
+        </p:spPr>
+      </p:sp>
+      <p:sp>
+        <p:nvSpPr>
+          <p:cNvPr id="54" name="Text 52"/>
+          <p:cNvSpPr/>
+          <p:nvPr/>
+        </p:nvSpPr>
+        <p:spPr>
+          <a:xfrm>
+            <a:off x="5123688" y="3328416"/>
+            <a:ext cx="310896" cy="310896"/>
           </a:xfrm>
           <a:prstGeom prst="rect">
             <a:avLst/>
@@ -4805,7 +4001,7 @@
               <a:buNone/>
             </a:pPr>
             <a:r>
-              <a:rPr lang="en-US" sz="1200" b="1" dirty="0">
+              <a:rPr lang="en-US" sz="800" b="1" dirty="0">
                 <a:solidFill>
                   <a:srgbClr val="1B2F5E"/>
                 </a:solidFill>
@@ -4813,9 +4009,879 @@
                 <a:ea typeface="Noto Sans KR" pitchFamily="34" charset="-122"/>
                 <a:cs typeface="Noto Sans KR" pitchFamily="34" charset="-120"/>
               </a:rPr>
-              <a:t>사양 확정 후 개발 착수부터 현장 가동까지  →  약 2개월</a:t>
-            </a:r>
-            <a:endParaRPr lang="en-US" sz="1200" dirty="0"/>
+              <a:t>04</a:t>
+            </a:r>
+            <a:endParaRPr lang="en-US" sz="800" dirty="0"/>
+          </a:p>
+        </p:txBody>
+      </p:sp>
+      <p:sp>
+        <p:nvSpPr>
+          <p:cNvPr id="55" name="Text 53"/>
+          <p:cNvSpPr/>
+          <p:nvPr/>
+        </p:nvSpPr>
+        <p:spPr>
+          <a:xfrm>
+            <a:off x="4636008" y="3657600"/>
+            <a:ext cx="1286256" cy="164592"/>
+          </a:xfrm>
+          <a:prstGeom prst="rect">
+            <a:avLst/>
+          </a:prstGeom>
+          <a:noFill/>
+          <a:ln/>
+        </p:spPr>
+        <p:txBody>
+          <a:bodyPr wrap="square" lIns="0" tIns="0" rIns="0" bIns="0" rtlCol="0" anchor="ctr"/>
+          <a:lstStyle/>
+          <a:p>
+            <a:pPr algn="ctr" indent="0" marL="0">
+              <a:buNone/>
+            </a:pPr>
+            <a:r>
+              <a:rPr lang="en-US" sz="800" b="1" dirty="0">
+                <a:solidFill>
+                  <a:srgbClr val="FFFFFF"/>
+                </a:solidFill>
+                <a:latin typeface="Noto Sans KR" pitchFamily="34" charset="0"/>
+                <a:ea typeface="Noto Sans KR" pitchFamily="34" charset="-122"/>
+                <a:cs typeface="Noto Sans KR" pitchFamily="34" charset="-120"/>
+              </a:rPr>
+              <a:t>제작</a:t>
+            </a:r>
+            <a:endParaRPr lang="en-US" sz="800" dirty="0"/>
+          </a:p>
+        </p:txBody>
+      </p:sp>
+      <p:sp>
+        <p:nvSpPr>
+          <p:cNvPr id="56" name="Shape 54"/>
+          <p:cNvSpPr/>
+          <p:nvPr/>
+        </p:nvSpPr>
+        <p:spPr>
+          <a:xfrm>
+            <a:off x="5949696" y="3557016"/>
+            <a:ext cx="73152" cy="0"/>
+          </a:xfrm>
+          <a:prstGeom prst="line">
+            <a:avLst/>
+          </a:prstGeom>
+          <a:noFill/>
+          <a:ln w="15240">
+            <a:solidFill>
+              <a:srgbClr val="94A3B8"/>
+            </a:solidFill>
+            <a:prstDash val="solid"/>
+          </a:ln>
+        </p:spPr>
+      </p:sp>
+      <p:sp>
+        <p:nvSpPr>
+          <p:cNvPr id="57" name="Shape 55"/>
+          <p:cNvSpPr/>
+          <p:nvPr/>
+        </p:nvSpPr>
+        <p:spPr>
+          <a:xfrm>
+            <a:off x="6022848" y="3273552"/>
+            <a:ext cx="1341120" cy="566928"/>
+          </a:xfrm>
+          <a:prstGeom prst="roundRect">
+            <a:avLst>
+              <a:gd name="adj" fmla="val 11290"/>
+            </a:avLst>
+          </a:prstGeom>
+          <a:solidFill>
+            <a:srgbClr val="1B2F5E"/>
+          </a:solidFill>
+          <a:ln w="15240">
+            <a:solidFill>
+              <a:srgbClr val="1B2F5E"/>
+            </a:solidFill>
+            <a:prstDash val="solid"/>
+          </a:ln>
+          <a:effectLst>
+            <a:outerShdw sx="100000" sy="100000" kx="0" ky="0" algn="bl" rotWithShape="0" blurRad="50800" dist="25400" dir="16200000">
+              <a:srgbClr val="9CA3AF">
+                <a:alpha val="15000"/>
+              </a:srgbClr>
+            </a:outerShdw>
+          </a:effectLst>
+        </p:spPr>
+      </p:sp>
+      <p:sp>
+        <p:nvSpPr>
+          <p:cNvPr id="58" name="Shape 56"/>
+          <p:cNvSpPr/>
+          <p:nvPr/>
+        </p:nvSpPr>
+        <p:spPr>
+          <a:xfrm>
+            <a:off x="6537960" y="3328416"/>
+            <a:ext cx="310896" cy="310896"/>
+          </a:xfrm>
+          <a:prstGeom prst="ellipse">
+            <a:avLst/>
+          </a:prstGeom>
+          <a:solidFill>
+            <a:srgbClr val="F59E0B"/>
+          </a:solidFill>
+          <a:ln w="12700">
+            <a:solidFill>
+              <a:srgbClr val="F59E0B"/>
+            </a:solidFill>
+            <a:prstDash val="solid"/>
+          </a:ln>
+        </p:spPr>
+      </p:sp>
+      <p:sp>
+        <p:nvSpPr>
+          <p:cNvPr id="59" name="Text 57"/>
+          <p:cNvSpPr/>
+          <p:nvPr/>
+        </p:nvSpPr>
+        <p:spPr>
+          <a:xfrm>
+            <a:off x="6537960" y="3328416"/>
+            <a:ext cx="310896" cy="310896"/>
+          </a:xfrm>
+          <a:prstGeom prst="rect">
+            <a:avLst/>
+          </a:prstGeom>
+          <a:noFill/>
+          <a:ln/>
+        </p:spPr>
+        <p:txBody>
+          <a:bodyPr wrap="square" lIns="0" tIns="0" rIns="0" bIns="0" rtlCol="0" anchor="ctr"/>
+          <a:lstStyle/>
+          <a:p>
+            <a:pPr algn="ctr" indent="0" marL="0">
+              <a:buNone/>
+            </a:pPr>
+            <a:r>
+              <a:rPr lang="en-US" sz="800" b="1" dirty="0">
+                <a:solidFill>
+                  <a:srgbClr val="1B2F5E"/>
+                </a:solidFill>
+                <a:latin typeface="Noto Sans KR" pitchFamily="34" charset="0"/>
+                <a:ea typeface="Noto Sans KR" pitchFamily="34" charset="-122"/>
+                <a:cs typeface="Noto Sans KR" pitchFamily="34" charset="-120"/>
+              </a:rPr>
+              <a:t>05</a:t>
+            </a:r>
+            <a:endParaRPr lang="en-US" sz="800" dirty="0"/>
+          </a:p>
+        </p:txBody>
+      </p:sp>
+      <p:sp>
+        <p:nvSpPr>
+          <p:cNvPr id="60" name="Text 58"/>
+          <p:cNvSpPr/>
+          <p:nvPr/>
+        </p:nvSpPr>
+        <p:spPr>
+          <a:xfrm>
+            <a:off x="6050280" y="3657600"/>
+            <a:ext cx="1286256" cy="164592"/>
+          </a:xfrm>
+          <a:prstGeom prst="rect">
+            <a:avLst/>
+          </a:prstGeom>
+          <a:noFill/>
+          <a:ln/>
+        </p:spPr>
+        <p:txBody>
+          <a:bodyPr wrap="square" lIns="0" tIns="0" rIns="0" bIns="0" rtlCol="0" anchor="ctr"/>
+          <a:lstStyle/>
+          <a:p>
+            <a:pPr algn="ctr" indent="0" marL="0">
+              <a:buNone/>
+            </a:pPr>
+            <a:r>
+              <a:rPr lang="en-US" sz="800" b="1" dirty="0">
+                <a:solidFill>
+                  <a:srgbClr val="FFFFFF"/>
+                </a:solidFill>
+                <a:latin typeface="Noto Sans KR" pitchFamily="34" charset="0"/>
+                <a:ea typeface="Noto Sans KR" pitchFamily="34" charset="-122"/>
+                <a:cs typeface="Noto Sans KR" pitchFamily="34" charset="-120"/>
+              </a:rPr>
+              <a:t>시범 적용</a:t>
+            </a:r>
+            <a:endParaRPr lang="en-US" sz="800" dirty="0"/>
+          </a:p>
+        </p:txBody>
+      </p:sp>
+      <p:sp>
+        <p:nvSpPr>
+          <p:cNvPr id="61" name="Shape 59"/>
+          <p:cNvSpPr/>
+          <p:nvPr/>
+        </p:nvSpPr>
+        <p:spPr>
+          <a:xfrm>
+            <a:off x="7363968" y="3557016"/>
+            <a:ext cx="73152" cy="0"/>
+          </a:xfrm>
+          <a:prstGeom prst="line">
+            <a:avLst/>
+          </a:prstGeom>
+          <a:noFill/>
+          <a:ln w="15240">
+            <a:solidFill>
+              <a:srgbClr val="94A3B8"/>
+            </a:solidFill>
+            <a:prstDash val="solid"/>
+          </a:ln>
+        </p:spPr>
+      </p:sp>
+      <p:sp>
+        <p:nvSpPr>
+          <p:cNvPr id="62" name="Shape 60"/>
+          <p:cNvSpPr/>
+          <p:nvPr/>
+        </p:nvSpPr>
+        <p:spPr>
+          <a:xfrm>
+            <a:off x="7437120" y="3273552"/>
+            <a:ext cx="1341120" cy="566928"/>
+          </a:xfrm>
+          <a:prstGeom prst="roundRect">
+            <a:avLst>
+              <a:gd name="adj" fmla="val 11290"/>
+            </a:avLst>
+          </a:prstGeom>
+          <a:solidFill>
+            <a:srgbClr val="FFFFFF"/>
+          </a:solidFill>
+          <a:ln w="15240">
+            <a:solidFill>
+              <a:srgbClr val="E2E8F0"/>
+            </a:solidFill>
+            <a:prstDash val="solid"/>
+          </a:ln>
+          <a:effectLst>
+            <a:outerShdw sx="100000" sy="100000" kx="0" ky="0" algn="bl" rotWithShape="0" blurRad="50800" dist="25400" dir="16200000">
+              <a:srgbClr val="9CA3AF">
+                <a:alpha val="15000"/>
+              </a:srgbClr>
+            </a:outerShdw>
+          </a:effectLst>
+        </p:spPr>
+      </p:sp>
+      <p:sp>
+        <p:nvSpPr>
+          <p:cNvPr id="63" name="Shape 61"/>
+          <p:cNvSpPr/>
+          <p:nvPr/>
+        </p:nvSpPr>
+        <p:spPr>
+          <a:xfrm>
+            <a:off x="7952232" y="3328416"/>
+            <a:ext cx="310896" cy="310896"/>
+          </a:xfrm>
+          <a:prstGeom prst="ellipse">
+            <a:avLst/>
+          </a:prstGeom>
+          <a:solidFill>
+            <a:srgbClr val="DBEAFE"/>
+          </a:solidFill>
+          <a:ln w="12700">
+            <a:solidFill>
+              <a:srgbClr val="DBEAFE"/>
+            </a:solidFill>
+            <a:prstDash val="solid"/>
+          </a:ln>
+        </p:spPr>
+      </p:sp>
+      <p:sp>
+        <p:nvSpPr>
+          <p:cNvPr id="64" name="Text 62"/>
+          <p:cNvSpPr/>
+          <p:nvPr/>
+        </p:nvSpPr>
+        <p:spPr>
+          <a:xfrm>
+            <a:off x="7952232" y="3328416"/>
+            <a:ext cx="310896" cy="310896"/>
+          </a:xfrm>
+          <a:prstGeom prst="rect">
+            <a:avLst/>
+          </a:prstGeom>
+          <a:noFill/>
+          <a:ln/>
+        </p:spPr>
+        <p:txBody>
+          <a:bodyPr wrap="square" lIns="0" tIns="0" rIns="0" bIns="0" rtlCol="0" anchor="ctr"/>
+          <a:lstStyle/>
+          <a:p>
+            <a:pPr algn="ctr" indent="0" marL="0">
+              <a:buNone/>
+            </a:pPr>
+            <a:r>
+              <a:rPr lang="en-US" sz="800" b="1" dirty="0">
+                <a:solidFill>
+                  <a:srgbClr val="2563EB"/>
+                </a:solidFill>
+                <a:latin typeface="Noto Sans KR" pitchFamily="34" charset="0"/>
+                <a:ea typeface="Noto Sans KR" pitchFamily="34" charset="-122"/>
+                <a:cs typeface="Noto Sans KR" pitchFamily="34" charset="-120"/>
+              </a:rPr>
+              <a:t>06</a:t>
+            </a:r>
+            <a:endParaRPr lang="en-US" sz="800" dirty="0"/>
+          </a:p>
+        </p:txBody>
+      </p:sp>
+      <p:sp>
+        <p:nvSpPr>
+          <p:cNvPr id="65" name="Text 63"/>
+          <p:cNvSpPr/>
+          <p:nvPr/>
+        </p:nvSpPr>
+        <p:spPr>
+          <a:xfrm>
+            <a:off x="7464552" y="3657600"/>
+            <a:ext cx="1286256" cy="164592"/>
+          </a:xfrm>
+          <a:prstGeom prst="rect">
+            <a:avLst/>
+          </a:prstGeom>
+          <a:noFill/>
+          <a:ln/>
+        </p:spPr>
+        <p:txBody>
+          <a:bodyPr wrap="square" lIns="0" tIns="0" rIns="0" bIns="0" rtlCol="0" anchor="ctr"/>
+          <a:lstStyle/>
+          <a:p>
+            <a:pPr algn="ctr" indent="0" marL="0">
+              <a:buNone/>
+            </a:pPr>
+            <a:r>
+              <a:rPr lang="en-US" sz="800" b="1" dirty="0">
+                <a:solidFill>
+                  <a:srgbClr val="1B2F5E"/>
+                </a:solidFill>
+                <a:latin typeface="Noto Sans KR" pitchFamily="34" charset="0"/>
+                <a:ea typeface="Noto Sans KR" pitchFamily="34" charset="-122"/>
+                <a:cs typeface="Noto Sans KR" pitchFamily="34" charset="-120"/>
+              </a:rPr>
+              <a:t>검출력 검증</a:t>
+            </a:r>
+            <a:endParaRPr lang="en-US" sz="800" dirty="0"/>
+          </a:p>
+        </p:txBody>
+      </p:sp>
+      <p:sp>
+        <p:nvSpPr>
+          <p:cNvPr id="66" name="Shape 64"/>
+          <p:cNvSpPr/>
+          <p:nvPr/>
+        </p:nvSpPr>
+        <p:spPr>
+          <a:xfrm>
+            <a:off x="365760" y="3895344"/>
+            <a:ext cx="1341120" cy="256032"/>
+          </a:xfrm>
+          <a:prstGeom prst="roundRect">
+            <a:avLst>
+              <a:gd name="adj" fmla="val 25000"/>
+            </a:avLst>
+          </a:prstGeom>
+          <a:solidFill>
+            <a:srgbClr val="F1F5F9"/>
+          </a:solidFill>
+          <a:ln w="12700">
+            <a:solidFill>
+              <a:srgbClr val="F1F5F9"/>
+            </a:solidFill>
+            <a:prstDash val="solid"/>
+          </a:ln>
+          <a:effectLst>
+            <a:outerShdw sx="100000" sy="100000" kx="0" ky="0" algn="bl" rotWithShape="0" blurRad="50800" dist="25400" dir="16200000">
+              <a:srgbClr val="9CA3AF">
+                <a:alpha val="15000"/>
+              </a:srgbClr>
+            </a:outerShdw>
+          </a:effectLst>
+        </p:spPr>
+      </p:sp>
+      <p:sp>
+        <p:nvSpPr>
+          <p:cNvPr id="67" name="Text 65"/>
+          <p:cNvSpPr/>
+          <p:nvPr/>
+        </p:nvSpPr>
+        <p:spPr>
+          <a:xfrm>
+            <a:off x="365760" y="3895344"/>
+            <a:ext cx="1341120" cy="256032"/>
+          </a:xfrm>
+          <a:prstGeom prst="rect">
+            <a:avLst/>
+          </a:prstGeom>
+          <a:noFill/>
+          <a:ln/>
+        </p:spPr>
+        <p:txBody>
+          <a:bodyPr wrap="square" lIns="0" tIns="0" rIns="0" bIns="0" rtlCol="0" anchor="ctr"/>
+          <a:lstStyle/>
+          <a:p>
+            <a:pPr algn="ctr" indent="0" marL="0">
+              <a:buNone/>
+            </a:pPr>
+            <a:r>
+              <a:rPr lang="en-US" sz="700" dirty="0">
+                <a:solidFill>
+                  <a:srgbClr val="475569"/>
+                </a:solidFill>
+                <a:latin typeface="Noto Sans KR" pitchFamily="34" charset="0"/>
+                <a:ea typeface="Noto Sans KR" pitchFamily="34" charset="-122"/>
+                <a:cs typeface="Noto Sans KR" pitchFamily="34" charset="-120"/>
+              </a:rPr>
+              <a:t>불량·양품 샘플</a:t>
+            </a:r>
+            <a:endParaRPr lang="en-US" sz="700" dirty="0"/>
+          </a:p>
+        </p:txBody>
+      </p:sp>
+      <p:sp>
+        <p:nvSpPr>
+          <p:cNvPr id="68" name="Shape 66"/>
+          <p:cNvSpPr/>
+          <p:nvPr/>
+        </p:nvSpPr>
+        <p:spPr>
+          <a:xfrm>
+            <a:off x="1780032" y="3895344"/>
+            <a:ext cx="1341120" cy="256032"/>
+          </a:xfrm>
+          <a:prstGeom prst="roundRect">
+            <a:avLst>
+              <a:gd name="adj" fmla="val 25000"/>
+            </a:avLst>
+          </a:prstGeom>
+          <a:solidFill>
+            <a:srgbClr val="DBEAFE"/>
+          </a:solidFill>
+          <a:ln w="12700">
+            <a:solidFill>
+              <a:srgbClr val="DBEAFE"/>
+            </a:solidFill>
+            <a:prstDash val="solid"/>
+          </a:ln>
+          <a:effectLst>
+            <a:outerShdw sx="100000" sy="100000" kx="0" ky="0" algn="bl" rotWithShape="0" blurRad="50800" dist="25400" dir="16200000">
+              <a:srgbClr val="9CA3AF">
+                <a:alpha val="15000"/>
+              </a:srgbClr>
+            </a:outerShdw>
+          </a:effectLst>
+        </p:spPr>
+      </p:sp>
+      <p:sp>
+        <p:nvSpPr>
+          <p:cNvPr id="69" name="Text 67"/>
+          <p:cNvSpPr/>
+          <p:nvPr/>
+        </p:nvSpPr>
+        <p:spPr>
+          <a:xfrm>
+            <a:off x="1780032" y="3895344"/>
+            <a:ext cx="1341120" cy="256032"/>
+          </a:xfrm>
+          <a:prstGeom prst="rect">
+            <a:avLst/>
+          </a:prstGeom>
+          <a:noFill/>
+          <a:ln/>
+        </p:spPr>
+        <p:txBody>
+          <a:bodyPr wrap="square" lIns="0" tIns="0" rIns="0" bIns="0" rtlCol="0" anchor="ctr"/>
+          <a:lstStyle/>
+          <a:p>
+            <a:pPr algn="ctr" indent="0" marL="0">
+              <a:buNone/>
+            </a:pPr>
+            <a:r>
+              <a:rPr lang="en-US" sz="700" dirty="0">
+                <a:solidFill>
+                  <a:srgbClr val="1B2F5E"/>
+                </a:solidFill>
+                <a:latin typeface="Noto Sans KR" pitchFamily="34" charset="0"/>
+                <a:ea typeface="Noto Sans KR" pitchFamily="34" charset="-122"/>
+                <a:cs typeface="Noto Sans KR" pitchFamily="34" charset="-120"/>
+              </a:rPr>
+              <a:t>유형 분류 1~2주</a:t>
+            </a:r>
+            <a:endParaRPr lang="en-US" sz="700" dirty="0"/>
+          </a:p>
+        </p:txBody>
+      </p:sp>
+      <p:sp>
+        <p:nvSpPr>
+          <p:cNvPr id="70" name="Shape 68"/>
+          <p:cNvSpPr/>
+          <p:nvPr/>
+        </p:nvSpPr>
+        <p:spPr>
+          <a:xfrm>
+            <a:off x="3194304" y="3895344"/>
+            <a:ext cx="1341120" cy="256032"/>
+          </a:xfrm>
+          <a:prstGeom prst="roundRect">
+            <a:avLst>
+              <a:gd name="adj" fmla="val 25000"/>
+            </a:avLst>
+          </a:prstGeom>
+          <a:solidFill>
+            <a:srgbClr val="F1F5F9"/>
+          </a:solidFill>
+          <a:ln w="12700">
+            <a:solidFill>
+              <a:srgbClr val="F1F5F9"/>
+            </a:solidFill>
+            <a:prstDash val="solid"/>
+          </a:ln>
+          <a:effectLst>
+            <a:outerShdw sx="100000" sy="100000" kx="0" ky="0" algn="bl" rotWithShape="0" blurRad="50800" dist="25400" dir="16200000">
+              <a:srgbClr val="9CA3AF">
+                <a:alpha val="15000"/>
+              </a:srgbClr>
+            </a:outerShdw>
+          </a:effectLst>
+        </p:spPr>
+      </p:sp>
+      <p:sp>
+        <p:nvSpPr>
+          <p:cNvPr id="71" name="Text 69"/>
+          <p:cNvSpPr/>
+          <p:nvPr/>
+        </p:nvSpPr>
+        <p:spPr>
+          <a:xfrm>
+            <a:off x="3194304" y="3895344"/>
+            <a:ext cx="1341120" cy="256032"/>
+          </a:xfrm>
+          <a:prstGeom prst="rect">
+            <a:avLst/>
+          </a:prstGeom>
+          <a:noFill/>
+          <a:ln/>
+        </p:spPr>
+        <p:txBody>
+          <a:bodyPr wrap="square" lIns="0" tIns="0" rIns="0" bIns="0" rtlCol="0" anchor="ctr"/>
+          <a:lstStyle/>
+          <a:p>
+            <a:pPr algn="ctr" indent="0" marL="0">
+              <a:buNone/>
+            </a:pPr>
+            <a:r>
+              <a:rPr lang="en-US" sz="700" dirty="0">
+                <a:solidFill>
+                  <a:srgbClr val="475569"/>
+                </a:solidFill>
+                <a:latin typeface="Noto Sans KR" pitchFamily="34" charset="0"/>
+                <a:ea typeface="Noto Sans KR" pitchFamily="34" charset="-122"/>
+                <a:cs typeface="Noto Sans KR" pitchFamily="34" charset="-120"/>
+              </a:rPr>
+              <a:t>검증기 사양 협의</a:t>
+            </a:r>
+            <a:endParaRPr lang="en-US" sz="700" dirty="0"/>
+          </a:p>
+        </p:txBody>
+      </p:sp>
+      <p:sp>
+        <p:nvSpPr>
+          <p:cNvPr id="72" name="Shape 70"/>
+          <p:cNvSpPr/>
+          <p:nvPr/>
+        </p:nvSpPr>
+        <p:spPr>
+          <a:xfrm>
+            <a:off x="4608576" y="3895344"/>
+            <a:ext cx="1341120" cy="256032"/>
+          </a:xfrm>
+          <a:prstGeom prst="roundRect">
+            <a:avLst>
+              <a:gd name="adj" fmla="val 25000"/>
+            </a:avLst>
+          </a:prstGeom>
+          <a:solidFill>
+            <a:srgbClr val="DBEAFE"/>
+          </a:solidFill>
+          <a:ln w="12700">
+            <a:solidFill>
+              <a:srgbClr val="DBEAFE"/>
+            </a:solidFill>
+            <a:prstDash val="solid"/>
+          </a:ln>
+          <a:effectLst>
+            <a:outerShdw sx="100000" sy="100000" kx="0" ky="0" algn="bl" rotWithShape="0" blurRad="50800" dist="25400" dir="16200000">
+              <a:srgbClr val="9CA3AF">
+                <a:alpha val="15000"/>
+              </a:srgbClr>
+            </a:outerShdw>
+          </a:effectLst>
+        </p:spPr>
+      </p:sp>
+      <p:sp>
+        <p:nvSpPr>
+          <p:cNvPr id="73" name="Text 71"/>
+          <p:cNvSpPr/>
+          <p:nvPr/>
+        </p:nvSpPr>
+        <p:spPr>
+          <a:xfrm>
+            <a:off x="4608576" y="3895344"/>
+            <a:ext cx="1341120" cy="256032"/>
+          </a:xfrm>
+          <a:prstGeom prst="rect">
+            <a:avLst/>
+          </a:prstGeom>
+          <a:noFill/>
+          <a:ln/>
+        </p:spPr>
+        <p:txBody>
+          <a:bodyPr wrap="square" lIns="0" tIns="0" rIns="0" bIns="0" rtlCol="0" anchor="ctr"/>
+          <a:lstStyle/>
+          <a:p>
+            <a:pPr algn="ctr" indent="0" marL="0">
+              <a:buNone/>
+            </a:pPr>
+            <a:r>
+              <a:rPr lang="en-US" sz="700" dirty="0">
+                <a:solidFill>
+                  <a:srgbClr val="1B2F5E"/>
+                </a:solidFill>
+                <a:latin typeface="Noto Sans KR" pitchFamily="34" charset="0"/>
+                <a:ea typeface="Noto Sans KR" pitchFamily="34" charset="-122"/>
+                <a:cs typeface="Noto Sans KR" pitchFamily="34" charset="-120"/>
+              </a:rPr>
+              <a:t>검증 전용 단순 구조</a:t>
+            </a:r>
+            <a:endParaRPr lang="en-US" sz="700" dirty="0"/>
+          </a:p>
+        </p:txBody>
+      </p:sp>
+      <p:sp>
+        <p:nvSpPr>
+          <p:cNvPr id="74" name="Shape 72"/>
+          <p:cNvSpPr/>
+          <p:nvPr/>
+        </p:nvSpPr>
+        <p:spPr>
+          <a:xfrm>
+            <a:off x="6022848" y="3895344"/>
+            <a:ext cx="1341120" cy="256032"/>
+          </a:xfrm>
+          <a:prstGeom prst="roundRect">
+            <a:avLst>
+              <a:gd name="adj" fmla="val 25000"/>
+            </a:avLst>
+          </a:prstGeom>
+          <a:solidFill>
+            <a:srgbClr val="DBEAFE"/>
+          </a:solidFill>
+          <a:ln w="12700">
+            <a:solidFill>
+              <a:srgbClr val="DBEAFE"/>
+            </a:solidFill>
+            <a:prstDash val="solid"/>
+          </a:ln>
+          <a:effectLst>
+            <a:outerShdw sx="100000" sy="100000" kx="0" ky="0" algn="bl" rotWithShape="0" blurRad="50800" dist="25400" dir="16200000">
+              <a:srgbClr val="9CA3AF">
+                <a:alpha val="15000"/>
+              </a:srgbClr>
+            </a:outerShdw>
+          </a:effectLst>
+        </p:spPr>
+      </p:sp>
+      <p:sp>
+        <p:nvSpPr>
+          <p:cNvPr id="75" name="Text 73"/>
+          <p:cNvSpPr/>
+          <p:nvPr/>
+        </p:nvSpPr>
+        <p:spPr>
+          <a:xfrm>
+            <a:off x="6022848" y="3895344"/>
+            <a:ext cx="1341120" cy="256032"/>
+          </a:xfrm>
+          <a:prstGeom prst="rect">
+            <a:avLst/>
+          </a:prstGeom>
+          <a:noFill/>
+          <a:ln/>
+        </p:spPr>
+        <p:txBody>
+          <a:bodyPr wrap="square" lIns="0" tIns="0" rIns="0" bIns="0" rtlCol="0" anchor="ctr"/>
+          <a:lstStyle/>
+          <a:p>
+            <a:pPr algn="ctr" indent="0" marL="0">
+              <a:buNone/>
+            </a:pPr>
+            <a:r>
+              <a:rPr lang="en-US" sz="700" dirty="0">
+                <a:solidFill>
+                  <a:srgbClr val="1B2F5E"/>
+                </a:solidFill>
+                <a:latin typeface="Noto Sans KR" pitchFamily="34" charset="0"/>
+                <a:ea typeface="Noto Sans KR" pitchFamily="34" charset="-122"/>
+                <a:cs typeface="Noto Sans KR" pitchFamily="34" charset="-120"/>
+              </a:rPr>
+              <a:t>현장 병행 운영</a:t>
+            </a:r>
+            <a:endParaRPr lang="en-US" sz="700" dirty="0"/>
+          </a:p>
+        </p:txBody>
+      </p:sp>
+      <p:sp>
+        <p:nvSpPr>
+          <p:cNvPr id="76" name="Shape 74"/>
+          <p:cNvSpPr/>
+          <p:nvPr/>
+        </p:nvSpPr>
+        <p:spPr>
+          <a:xfrm>
+            <a:off x="7437120" y="3895344"/>
+            <a:ext cx="1341120" cy="256032"/>
+          </a:xfrm>
+          <a:prstGeom prst="roundRect">
+            <a:avLst>
+              <a:gd name="adj" fmla="val 25000"/>
+            </a:avLst>
+          </a:prstGeom>
+          <a:solidFill>
+            <a:srgbClr val="F1F5F9"/>
+          </a:solidFill>
+          <a:ln w="12700">
+            <a:solidFill>
+              <a:srgbClr val="F1F5F9"/>
+            </a:solidFill>
+            <a:prstDash val="solid"/>
+          </a:ln>
+          <a:effectLst>
+            <a:outerShdw sx="100000" sy="100000" kx="0" ky="0" algn="bl" rotWithShape="0" blurRad="50800" dist="25400" dir="16200000">
+              <a:srgbClr val="9CA3AF">
+                <a:alpha val="15000"/>
+              </a:srgbClr>
+            </a:outerShdw>
+          </a:effectLst>
+        </p:spPr>
+      </p:sp>
+      <p:sp>
+        <p:nvSpPr>
+          <p:cNvPr id="77" name="Text 75"/>
+          <p:cNvSpPr/>
+          <p:nvPr/>
+        </p:nvSpPr>
+        <p:spPr>
+          <a:xfrm>
+            <a:off x="7437120" y="3895344"/>
+            <a:ext cx="1341120" cy="256032"/>
+          </a:xfrm>
+          <a:prstGeom prst="rect">
+            <a:avLst/>
+          </a:prstGeom>
+          <a:noFill/>
+          <a:ln/>
+        </p:spPr>
+        <p:txBody>
+          <a:bodyPr wrap="square" lIns="0" tIns="0" rIns="0" bIns="0" rtlCol="0" anchor="ctr"/>
+          <a:lstStyle/>
+          <a:p>
+            <a:pPr algn="ctr" indent="0" marL="0">
+              <a:buNone/>
+            </a:pPr>
+            <a:r>
+              <a:rPr lang="en-US" sz="700" dirty="0">
+                <a:solidFill>
+                  <a:srgbClr val="475569"/>
+                </a:solidFill>
+                <a:latin typeface="Noto Sans KR" pitchFamily="34" charset="0"/>
+                <a:ea typeface="Noto Sans KR" pitchFamily="34" charset="-122"/>
+                <a:cs typeface="Noto Sans KR" pitchFamily="34" charset="-120"/>
+              </a:rPr>
+              <a:t>검사원 대비 비교</a:t>
+            </a:r>
+            <a:endParaRPr lang="en-US" sz="700" dirty="0"/>
+          </a:p>
+        </p:txBody>
+      </p:sp>
+      <p:sp>
+        <p:nvSpPr>
+          <p:cNvPr id="78" name="Shape 76"/>
+          <p:cNvSpPr/>
+          <p:nvPr/>
+        </p:nvSpPr>
+        <p:spPr>
+          <a:xfrm>
+            <a:off x="365760" y="4261104"/>
+            <a:ext cx="8412480" cy="384048"/>
+          </a:xfrm>
+          <a:prstGeom prst="roundRect">
+            <a:avLst>
+              <a:gd name="adj" fmla="val 16667"/>
+            </a:avLst>
+          </a:prstGeom>
+          <a:solidFill>
+            <a:srgbClr val="1B2F5E"/>
+          </a:solidFill>
+          <a:ln w="12700">
+            <a:solidFill>
+              <a:srgbClr val="1B2F5E"/>
+            </a:solidFill>
+            <a:prstDash val="solid"/>
+          </a:ln>
+          <a:effectLst>
+            <a:outerShdw sx="100000" sy="100000" kx="0" ky="0" algn="bl" rotWithShape="0" blurRad="50800" dist="25400" dir="16200000">
+              <a:srgbClr val="9CA3AF">
+                <a:alpha val="15000"/>
+              </a:srgbClr>
+            </a:outerShdw>
+          </a:effectLst>
+        </p:spPr>
+      </p:sp>
+      <p:sp>
+        <p:nvSpPr>
+          <p:cNvPr id="79" name="Text 77"/>
+          <p:cNvSpPr/>
+          <p:nvPr/>
+        </p:nvSpPr>
+        <p:spPr>
+          <a:xfrm>
+            <a:off x="548640" y="4261104"/>
+            <a:ext cx="8046720" cy="384048"/>
+          </a:xfrm>
+          <a:prstGeom prst="rect">
+            <a:avLst/>
+          </a:prstGeom>
+          <a:noFill/>
+          <a:ln/>
+        </p:spPr>
+        <p:txBody>
+          <a:bodyPr wrap="square" lIns="0" tIns="0" rIns="0" bIns="0" rtlCol="0" anchor="ctr"/>
+          <a:lstStyle/>
+          <a:p>
+            <a:pPr algn="ctr" indent="0" marL="0">
+              <a:buNone/>
+            </a:pPr>
+            <a:r>
+              <a:rPr lang="en-US" sz="1000" b="1" dirty="0">
+                <a:solidFill>
+                  <a:srgbClr val="FFFFFF"/>
+                </a:solidFill>
+                <a:latin typeface="Noto Sans KR" pitchFamily="34" charset="0"/>
+                <a:ea typeface="Noto Sans KR" pitchFamily="34" charset="-122"/>
+                <a:cs typeface="Noto Sans KR" pitchFamily="34" charset="-120"/>
+              </a:rPr>
+              <a:t>1호기 제작 기간 약 3~4주  ·  시범 적용 후 검출력 검증  →  결과 기반으로 자동화 확장 여부 결정</a:t>
+            </a:r>
+            <a:endParaRPr lang="en-US" sz="1000" dirty="0"/>
           </a:p>
         </p:txBody>
       </p:sp>
@@ -8601,7 +8667,7 @@
                 <a:ea typeface="Noto Sans KR" pitchFamily="34" charset="-122"/>
                 <a:cs typeface="Noto Sans KR" pitchFamily="34" charset="-120"/>
               </a:rPr>
-              <a:t>진행 절차 &amp; 개발 일정</a:t>
+              <a:t>진행 절차 — 단계별 도입 전략</a:t>
             </a:r>
             <a:endParaRPr lang="en-US" sz="1150" dirty="0"/>
           </a:p>

</xml_diff>

<commit_message>
Update winnercom.pptx - dept name to 연구개발실
</commit_message>
<xml_diff>
--- a/winnercom.pptx
+++ b/winnercom.pptx
@@ -2099,7 +2099,7 @@
                 <a:ea typeface="Noto Sans KR" pitchFamily="34" charset="-122"/>
                 <a:cs typeface="Noto Sans KR" pitchFamily="34" charset="-120"/>
               </a:rPr>
-              <a:t>제안사: 인시스 AI혁신 R&amp;D센터</a:t>
+              <a:t>제안사: 인시스 AI혁신 연구개발실</a:t>
             </a:r>
             <a:endParaRPr lang="en-US" sz="1100" dirty="0"/>
           </a:p>
@@ -7579,7 +7579,7 @@
                 <a:ea typeface="Noto Sans KR" pitchFamily="34" charset="-122"/>
                 <a:cs typeface="Noto Sans KR" pitchFamily="34" charset="-120"/>
               </a:rPr>
-              <a:t>인시스 AI혁신 R&amp;D센터  |  담당: 센터장 김양섭  |  ys.kim@in-sys.co.kr</a:t>
+              <a:t>인시스 AI혁신 연구개발실  |  담당: 센터장 김양섭  |  ys.kim@in-sys.co.kr</a:t>
             </a:r>
             <a:endParaRPr lang="en-US" sz="1100" dirty="0"/>
           </a:p>

</xml_diff>

<commit_message>
Update winnercom.pptx - replace concept image with keyence machine
</commit_message>
<xml_diff>
--- a/winnercom.pptx
+++ b/winnercom.pptx
@@ -14333,13 +14333,14 @@
         </p:nvPicPr>
         <p:blipFill>
           <a:blip r:embed="rId1"/>
-          <a:srcRect l="0" r="0" t="0" b="0"/>
-          <a:stretch/>
+          <a:stretch>
+            <a:fillRect/>
+          </a:stretch>
         </p:blipFill>
         <p:spPr>
           <a:xfrm>
-            <a:off x="1057229" y="438912"/>
-            <a:ext cx="7029450" cy="4686300"/>
+            <a:off x="1812707" y="438912"/>
+            <a:ext cx="5518678" cy="4686300"/>
           </a:xfrm>
           <a:prstGeom prst="rect">
             <a:avLst/>

</xml_diff>

<commit_message>
Update winnercom.pptx - align script with PPT, add business model slide
</commit_message>
<xml_diff>
--- a/winnercom.pptx
+++ b/winnercom.pptx
@@ -17,9 +17,10 @@
     <p:sldId id="265" r:id="rId11"/>
     <p:sldId id="266" r:id="rId12"/>
     <p:sldId id="267" r:id="rId13"/>
+    <p:sldId id="268" r:id="rId14"/>
   </p:sldIdLst>
   <p:notesMasterIdLst>
-    <p:notesMasterId r:id="rId14"/>
+    <p:notesMasterId r:id="rId15"/>
   </p:notesMasterIdLst>
   <p:sldSz cx="9144000" cy="5143500"/>
   <p:notesSz cx="5143500" cy="9144000"/>
@@ -819,6 +820,94 @@
 </p:notes>
 </file>
 
+<file path=ppt/notesSlides/notesSlide13.xml><?xml version="1.0" encoding="utf-8"?>
+<p:notes xmlns:a="http://schemas.openxmlformats.org/drawingml/2006/main" xmlns:r="http://schemas.openxmlformats.org/officeDocument/2006/relationships" xmlns:p="http://schemas.openxmlformats.org/presentationml/2006/main">
+  <p:cSld>
+    <p:spTree>
+      <p:nvGrpSpPr>
+        <p:cNvPr id="1" name=""/>
+        <p:cNvGrpSpPr/>
+        <p:nvPr/>
+      </p:nvGrpSpPr>
+      <p:grpSpPr>
+        <a:xfrm>
+          <a:off x="0" y="0"/>
+          <a:ext cx="0" cy="0"/>
+          <a:chOff x="0" y="0"/>
+          <a:chExt cx="0" cy="0"/>
+        </a:xfrm>
+      </p:grpSpPr>
+      <p:sp>
+        <p:nvSpPr>
+          <p:cNvPr id="2" name="Slide Image Placeholder 1"/>
+          <p:cNvSpPr>
+            <a:spLocks noGrp="1" noRot="1" noChangeAspect="1"/>
+          </p:cNvSpPr>
+          <p:nvPr>
+            <p:ph type="sldImg"/>
+          </p:nvPr>
+        </p:nvSpPr>
+        <p:spPr/>
+      </p:sp>
+      <p:sp>
+        <p:nvSpPr>
+          <p:cNvPr id="3" name="Notes Placeholder 2"/>
+          <p:cNvSpPr>
+            <a:spLocks noGrp="1"/>
+          </p:cNvSpPr>
+          <p:nvPr>
+            <p:ph type="body" idx="1"/>
+          </p:nvPr>
+        </p:nvSpPr>
+        <p:spPr/>
+        <p:txBody>
+          <a:bodyPr/>
+          <a:lstStyle/>
+          <a:p>
+            <a:r>
+              <a:rPr lang="en-US" dirty="0"/>
+              <a:t/>
+            </a:r>
+            <a:endParaRPr lang="en-US" dirty="0"/>
+          </a:p>
+        </p:txBody>
+      </p:sp>
+      <p:sp>
+        <p:nvSpPr>
+          <p:cNvPr id="4" name="Slide Number Placeholder 3"/>
+          <p:cNvSpPr>
+            <a:spLocks noGrp="1"/>
+          </p:cNvSpPr>
+          <p:nvPr>
+            <p:ph type="sldNum" sz="quarter" idx="10"/>
+          </p:nvPr>
+        </p:nvSpPr>
+        <p:spPr/>
+        <p:txBody>
+          <a:bodyPr/>
+          <a:lstStyle/>
+          <a:p>
+            <a:fld id="{F7021451-1387-4CA6-816F-3879F97B5CBC}" type="slidenum">
+              <a:rPr lang="en-US"/>
+              <a:t>13</a:t>
+            </a:fld>
+            <a:endParaRPr lang="en-US"/>
+          </a:p>
+        </p:txBody>
+      </p:sp>
+    </p:spTree>
+    <p:extLst>
+      <p:ext uri="{BB962C8B-B14F-4D97-AF65-F5344CB8AC3E}">
+        <p14:creationId xmlns:p14="http://schemas.microsoft.com/office/powerpoint/2010/main" val="1024086991"/>
+      </p:ext>
+    </p:extLst>
+  </p:cSld>
+  <p:clrMapOvr>
+    <a:masterClrMapping/>
+  </p:clrMapOvr>
+</p:notes>
+</file>
+
 <file path=ppt/notesSlides/notesSlide2.xml><?xml version="1.0" encoding="utf-8"?>
 <p:notes xmlns:a="http://schemas.openxmlformats.org/drawingml/2006/main" xmlns:r="http://schemas.openxmlformats.org/officeDocument/2006/relationships" xmlns:p="http://schemas.openxmlformats.org/presentationml/2006/main">
   <p:cSld>
@@ -4993,7 +5082,7 @@
                 <a:ea typeface="Noto Sans KR" pitchFamily="34" charset="-122"/>
                 <a:cs typeface="Noto Sans KR" pitchFamily="34" charset="-120"/>
               </a:rPr>
-              <a:t>예상 문제점 및 협의 사항</a:t>
+              <a:t>사업 모델 — 부담 없는 임대 방식</a:t>
             </a:r>
             <a:endParaRPr lang="en-US" sz="2200" dirty="0"/>
           </a:p>
@@ -5032,7 +5121,7 @@
                 <a:ea typeface="Noto Sans KR" pitchFamily="34" charset="-122"/>
                 <a:cs typeface="Noto Sans KR" pitchFamily="34" charset="-120"/>
               </a:rPr>
-              <a:t>현장 적용 전 사전 검토가 필요한 항목입니다</a:t>
+              <a:t>인시스가 투자·제작하고 위너콤은 임대로 사용합니다</a:t>
             </a:r>
             <a:endParaRPr lang="en-US" sz="1050" dirty="0"/>
           </a:p>
@@ -5047,19 +5136,19 @@
         <p:spPr>
           <a:xfrm>
             <a:off x="365760" y="1078992"/>
-            <a:ext cx="8412480" cy="749808"/>
+            <a:ext cx="8412480" cy="548640"/>
           </a:xfrm>
           <a:prstGeom prst="roundRect">
             <a:avLst>
-              <a:gd name="adj" fmla="val 8537"/>
+              <a:gd name="adj" fmla="val 11667"/>
             </a:avLst>
           </a:prstGeom>
           <a:solidFill>
-            <a:srgbClr val="FFFFFF"/>
+            <a:srgbClr val="1B3A6B"/>
           </a:solidFill>
           <a:ln w="12700">
             <a:solidFill>
-              <a:srgbClr val="2563EB"/>
+              <a:srgbClr val="2E5EA8"/>
             </a:solidFill>
             <a:prstDash val="solid"/>
           </a:ln>
@@ -5074,239 +5163,68 @@
       </p:sp>
       <p:sp>
         <p:nvSpPr>
-          <p:cNvPr id="7" name="Shape 5"/>
-          <p:cNvSpPr/>
-          <p:nvPr/>
-        </p:nvSpPr>
-        <p:spPr>
-          <a:xfrm>
-            <a:off x="365760" y="1078992"/>
-            <a:ext cx="475488" cy="749808"/>
+          <p:cNvPr id="7" name="Text 5"/>
+          <p:cNvSpPr/>
+          <p:nvPr/>
+        </p:nvSpPr>
+        <p:spPr>
+          <a:xfrm>
+            <a:off x="548640" y="1078992"/>
+            <a:ext cx="8046720" cy="548640"/>
+          </a:xfrm>
+          <a:prstGeom prst="rect">
+            <a:avLst/>
+          </a:prstGeom>
+          <a:noFill/>
+          <a:ln/>
+        </p:spPr>
+        <p:txBody>
+          <a:bodyPr wrap="square" lIns="0" tIns="0" rIns="0" bIns="0" rtlCol="0" anchor="ctr"/>
+          <a:lstStyle/>
+          <a:p>
+            <a:pPr indent="0" marL="0">
+              <a:lnSpc>
+                <a:spcPct val="120000"/>
+              </a:lnSpc>
+              <a:buNone/>
+            </a:pPr>
+            <a:r>
+              <a:rPr lang="en-US" sz="1050" dirty="0">
+                <a:solidFill>
+                  <a:srgbClr val="A5C4F3"/>
+                </a:solidFill>
+                <a:latin typeface="Noto Sans KR" pitchFamily="34" charset="0"/>
+                <a:ea typeface="Noto Sans KR" pitchFamily="34" charset="-122"/>
+                <a:cs typeface="Noto Sans KR" pitchFamily="34" charset="-120"/>
+              </a:rPr>
+              <a:t>💡  인시스가 검사기를 투자·제작하여 임대 제공 — 위너콤은 초기 설비 투자 부담 없이 딥러닝 검사 효과부터 확인하실 수 있습니다.</a:t>
+            </a:r>
+            <a:endParaRPr lang="en-US" sz="1050" dirty="0"/>
+          </a:p>
+        </p:txBody>
+      </p:sp>
+      <p:sp>
+        <p:nvSpPr>
+          <p:cNvPr id="8" name="Shape 6"/>
+          <p:cNvSpPr/>
+          <p:nvPr/>
+        </p:nvSpPr>
+        <p:spPr>
+          <a:xfrm>
+            <a:off x="365760" y="1828800"/>
+            <a:ext cx="4297680" cy="786384"/>
           </a:xfrm>
           <a:prstGeom prst="roundRect">
             <a:avLst>
-              <a:gd name="adj" fmla="val 11538"/>
+              <a:gd name="adj" fmla="val 8140"/>
             </a:avLst>
           </a:prstGeom>
           <a:solidFill>
-            <a:srgbClr val="2563EB"/>
+            <a:srgbClr val="FFFFFF"/>
           </a:solidFill>
           <a:ln w="12700">
             <a:solidFill>
-              <a:srgbClr val="2563EB"/>
-            </a:solidFill>
-            <a:prstDash val="solid"/>
-          </a:ln>
-        </p:spPr>
-      </p:sp>
-      <p:sp>
-        <p:nvSpPr>
-          <p:cNvPr id="8" name="Text 6"/>
-          <p:cNvSpPr/>
-          <p:nvPr/>
-        </p:nvSpPr>
-        <p:spPr>
-          <a:xfrm>
-            <a:off x="365760" y="1078992"/>
-            <a:ext cx="475488" cy="749808"/>
-          </a:xfrm>
-          <a:prstGeom prst="rect">
-            <a:avLst/>
-          </a:prstGeom>
-          <a:noFill/>
-          <a:ln/>
-        </p:spPr>
-        <p:txBody>
-          <a:bodyPr wrap="square" lIns="0" tIns="0" rIns="0" bIns="0" rtlCol="0" anchor="ctr"/>
-          <a:lstStyle/>
-          <a:p>
-            <a:pPr algn="ctr" indent="0" marL="0">
-              <a:buNone/>
-            </a:pPr>
-            <a:r>
-              <a:rPr lang="en-US" sz="1100" b="1" dirty="0">
-                <a:solidFill>
-                  <a:srgbClr val="FFFFFF"/>
-                </a:solidFill>
-                <a:latin typeface="Noto Sans KR" pitchFamily="34" charset="0"/>
-                <a:ea typeface="Noto Sans KR" pitchFamily="34" charset="-122"/>
-                <a:cs typeface="Noto Sans KR" pitchFamily="34" charset="-120"/>
-              </a:rPr>
-              <a:t>01</a:t>
-            </a:r>
-            <a:endParaRPr lang="en-US" sz="1100" dirty="0"/>
-          </a:p>
-        </p:txBody>
-      </p:sp>
-      <p:sp>
-        <p:nvSpPr>
-          <p:cNvPr id="9" name="Shape 7"/>
-          <p:cNvSpPr/>
-          <p:nvPr/>
-        </p:nvSpPr>
-        <p:spPr>
-          <a:xfrm>
-            <a:off x="914400" y="1152144"/>
-            <a:ext cx="658368" cy="182880"/>
-          </a:xfrm>
-          <a:prstGeom prst="roundRect">
-            <a:avLst>
-              <a:gd name="adj" fmla="val 20000"/>
-            </a:avLst>
-          </a:prstGeom>
-          <a:solidFill>
-            <a:srgbClr val="DBEAFE"/>
-          </a:solidFill>
-          <a:ln w="6350">
-            <a:solidFill>
-              <a:srgbClr val="2563EB"/>
-            </a:solidFill>
-            <a:prstDash val="solid"/>
-          </a:ln>
-        </p:spPr>
-      </p:sp>
-      <p:sp>
-        <p:nvSpPr>
-          <p:cNvPr id="10" name="Text 8"/>
-          <p:cNvSpPr/>
-          <p:nvPr/>
-        </p:nvSpPr>
-        <p:spPr>
-          <a:xfrm>
-            <a:off x="914400" y="1152144"/>
-            <a:ext cx="658368" cy="182880"/>
-          </a:xfrm>
-          <a:prstGeom prst="rect">
-            <a:avLst/>
-          </a:prstGeom>
-          <a:noFill/>
-          <a:ln/>
-        </p:spPr>
-        <p:txBody>
-          <a:bodyPr wrap="square" lIns="0" tIns="0" rIns="0" bIns="0" rtlCol="0" anchor="ctr"/>
-          <a:lstStyle/>
-          <a:p>
-            <a:pPr algn="ctr" indent="0" marL="0">
-              <a:buNone/>
-            </a:pPr>
-            <a:r>
-              <a:rPr lang="en-US" sz="650" b="1" dirty="0">
-                <a:solidFill>
-                  <a:srgbClr val="2563EB"/>
-                </a:solidFill>
-                <a:latin typeface="Noto Sans KR" pitchFamily="34" charset="0"/>
-                <a:ea typeface="Noto Sans KR" pitchFamily="34" charset="-122"/>
-                <a:cs typeface="Noto Sans KR" pitchFamily="34" charset="-120"/>
-              </a:rPr>
-              <a:t>기구·지그</a:t>
-            </a:r>
-            <a:endParaRPr lang="en-US" sz="650" dirty="0"/>
-          </a:p>
-        </p:txBody>
-      </p:sp>
-      <p:sp>
-        <p:nvSpPr>
-          <p:cNvPr id="11" name="Text 9"/>
-          <p:cNvSpPr/>
-          <p:nvPr/>
-        </p:nvSpPr>
-        <p:spPr>
-          <a:xfrm>
-            <a:off x="914400" y="1353312"/>
-            <a:ext cx="4572000" cy="237744"/>
-          </a:xfrm>
-          <a:prstGeom prst="rect">
-            <a:avLst/>
-          </a:prstGeom>
-          <a:noFill/>
-          <a:ln/>
-        </p:spPr>
-        <p:txBody>
-          <a:bodyPr wrap="square" lIns="0" tIns="0" rIns="0" bIns="0" rtlCol="0" anchor="ctr"/>
-          <a:lstStyle/>
-          <a:p>
-            <a:pPr indent="0" marL="0">
-              <a:buNone/>
-            </a:pPr>
-            <a:r>
-              <a:rPr lang="en-US" sz="950" b="1" dirty="0">
-                <a:solidFill>
-                  <a:srgbClr val="1B2F5E"/>
-                </a:solidFill>
-                <a:latin typeface="Noto Sans KR" pitchFamily="34" charset="0"/>
-                <a:ea typeface="Noto Sans KR" pitchFamily="34" charset="-122"/>
-                <a:cs typeface="Noto Sans KR" pitchFamily="34" charset="-120"/>
-              </a:rPr>
-              <a:t>PCB 연결 케이블 형태 균일화 및 바코드 위치 표준화</a:t>
-            </a:r>
-            <a:endParaRPr lang="en-US" sz="950" dirty="0"/>
-          </a:p>
-        </p:txBody>
-      </p:sp>
-      <p:sp>
-        <p:nvSpPr>
-          <p:cNvPr id="12" name="Text 10"/>
-          <p:cNvSpPr/>
-          <p:nvPr/>
-        </p:nvSpPr>
-        <p:spPr>
-          <a:xfrm>
-            <a:off x="914400" y="1572768"/>
-            <a:ext cx="4572000" cy="237744"/>
-          </a:xfrm>
-          <a:prstGeom prst="rect">
-            <a:avLst/>
-          </a:prstGeom>
-          <a:noFill/>
-          <a:ln/>
-        </p:spPr>
-        <p:txBody>
-          <a:bodyPr wrap="square" lIns="0" tIns="0" rIns="0" bIns="0" rtlCol="0" anchor="ctr"/>
-          <a:lstStyle/>
-          <a:p>
-            <a:pPr indent="0" marL="0">
-              <a:lnSpc>
-                <a:spcPct val="110000"/>
-              </a:lnSpc>
-              <a:buNone/>
-            </a:pPr>
-            <a:r>
-              <a:rPr lang="en-US" sz="750" dirty="0">
-                <a:solidFill>
-                  <a:srgbClr val="475569"/>
-                </a:solidFill>
-                <a:latin typeface="Noto Sans KR" pitchFamily="34" charset="0"/>
-                <a:ea typeface="Noto Sans KR" pitchFamily="34" charset="-122"/>
-                <a:cs typeface="Noto Sans KR" pitchFamily="34" charset="-120"/>
-              </a:rPr>
-              <a:t>케이블이 PCB와 연결된 상태에서 형태가 일정하지 않으면 지그 안착 불량 및 촬영 위치 오차가 발생할 수 있습니다. 또한 바코드 부착 위치가 개체마다 다를 경우 고정식 스캐너 인식률이 저하됩니다.</a:t>
-            </a:r>
-            <a:endParaRPr lang="en-US" sz="750" dirty="0"/>
-          </a:p>
-        </p:txBody>
-      </p:sp>
-      <p:sp>
-        <p:nvSpPr>
-          <p:cNvPr id="13" name="Shape 11"/>
-          <p:cNvSpPr/>
-          <p:nvPr/>
-        </p:nvSpPr>
-        <p:spPr>
-          <a:xfrm>
-            <a:off x="5943600" y="1133856"/>
-            <a:ext cx="2834640" cy="640080"/>
-          </a:xfrm>
-          <a:prstGeom prst="roundRect">
-            <a:avLst>
-              <a:gd name="adj" fmla="val 10000"/>
-            </a:avLst>
-          </a:prstGeom>
-          <a:solidFill>
-            <a:srgbClr val="DBEAFE"/>
-          </a:solidFill>
-          <a:ln w="12700">
-            <a:solidFill>
-              <a:srgbClr val="DBEAFE"/>
+              <a:srgbClr val="E2E8F0"/>
             </a:solidFill>
             <a:prstDash val="solid"/>
           </a:ln>
@@ -5321,14 +5239,78 @@
       </p:sp>
       <p:sp>
         <p:nvSpPr>
-          <p:cNvPr id="14" name="Text 12"/>
-          <p:cNvSpPr/>
-          <p:nvPr/>
-        </p:nvSpPr>
-        <p:spPr>
-          <a:xfrm>
-            <a:off x="6035040" y="1170432"/>
-            <a:ext cx="2706624" cy="182880"/>
+          <p:cNvPr id="9" name="Shape 7"/>
+          <p:cNvSpPr/>
+          <p:nvPr/>
+        </p:nvSpPr>
+        <p:spPr>
+          <a:xfrm>
+            <a:off x="512064" y="2011680"/>
+            <a:ext cx="420624" cy="420624"/>
+          </a:xfrm>
+          <a:prstGeom prst="ellipse">
+            <a:avLst/>
+          </a:prstGeom>
+          <a:solidFill>
+            <a:srgbClr val="DBEAFE"/>
+          </a:solidFill>
+          <a:ln w="12700">
+            <a:solidFill>
+              <a:srgbClr val="DBEAFE"/>
+            </a:solidFill>
+            <a:prstDash val="solid"/>
+          </a:ln>
+        </p:spPr>
+      </p:sp>
+      <p:sp>
+        <p:nvSpPr>
+          <p:cNvPr id="10" name="Text 8"/>
+          <p:cNvSpPr/>
+          <p:nvPr/>
+        </p:nvSpPr>
+        <p:spPr>
+          <a:xfrm>
+            <a:off x="512064" y="2011680"/>
+            <a:ext cx="420624" cy="420624"/>
+          </a:xfrm>
+          <a:prstGeom prst="rect">
+            <a:avLst/>
+          </a:prstGeom>
+          <a:noFill/>
+          <a:ln/>
+        </p:spPr>
+        <p:txBody>
+          <a:bodyPr wrap="square" lIns="0" tIns="0" rIns="0" bIns="0" rtlCol="0" anchor="ctr"/>
+          <a:lstStyle/>
+          <a:p>
+            <a:pPr algn="ctr" indent="0" marL="0">
+              <a:buNone/>
+            </a:pPr>
+            <a:r>
+              <a:rPr lang="en-US" sz="1600" dirty="0">
+                <a:solidFill>
+                  <a:srgbClr val="000000"/>
+                </a:solidFill>
+                <a:latin typeface="Noto Sans KR" pitchFamily="34" charset="0"/>
+                <a:ea typeface="Noto Sans KR" pitchFamily="34" charset="-122"/>
+                <a:cs typeface="Noto Sans KR" pitchFamily="34" charset="-120"/>
+              </a:rPr>
+              <a:t>💰</a:t>
+            </a:r>
+            <a:endParaRPr lang="en-US" sz="1600" dirty="0"/>
+          </a:p>
+        </p:txBody>
+      </p:sp>
+      <p:sp>
+        <p:nvSpPr>
+          <p:cNvPr id="11" name="Text 9"/>
+          <p:cNvSpPr/>
+          <p:nvPr/>
+        </p:nvSpPr>
+        <p:spPr>
+          <a:xfrm>
+            <a:off x="1060704" y="1956816"/>
+            <a:ext cx="3474720" cy="274320"/>
           </a:xfrm>
           <a:prstGeom prst="rect">
             <a:avLst/>
@@ -5344,30 +5326,30 @@
               <a:buNone/>
             </a:pPr>
             <a:r>
-              <a:rPr lang="en-US" sz="750" b="1" dirty="0">
-                <a:solidFill>
-                  <a:srgbClr val="2563EB"/>
-                </a:solidFill>
-                <a:latin typeface="Noto Sans KR" pitchFamily="34" charset="0"/>
-                <a:ea typeface="Noto Sans KR" pitchFamily="34" charset="-122"/>
-                <a:cs typeface="Noto Sans KR" pitchFamily="34" charset="-120"/>
-              </a:rPr>
-              <a:t>💬 협의 요청</a:t>
-            </a:r>
-            <a:endParaRPr lang="en-US" sz="750" dirty="0"/>
-          </a:p>
-        </p:txBody>
-      </p:sp>
-      <p:sp>
-        <p:nvSpPr>
-          <p:cNvPr id="15" name="Text 13"/>
-          <p:cNvSpPr/>
-          <p:nvPr/>
-        </p:nvSpPr>
-        <p:spPr>
-          <a:xfrm>
-            <a:off x="6035040" y="1353312"/>
-            <a:ext cx="2706624" cy="438912"/>
+              <a:rPr lang="en-US" sz="1200" b="1" dirty="0">
+                <a:solidFill>
+                  <a:srgbClr val="1B2F5E"/>
+                </a:solidFill>
+                <a:latin typeface="Noto Sans KR" pitchFamily="34" charset="0"/>
+                <a:ea typeface="Noto Sans KR" pitchFamily="34" charset="-122"/>
+                <a:cs typeface="Noto Sans KR" pitchFamily="34" charset="-120"/>
+              </a:rPr>
+              <a:t>초기 투자 없음</a:t>
+            </a:r>
+            <a:endParaRPr lang="en-US" sz="1200" dirty="0"/>
+          </a:p>
+        </p:txBody>
+      </p:sp>
+      <p:sp>
+        <p:nvSpPr>
+          <p:cNvPr id="12" name="Text 10"/>
+          <p:cNvSpPr/>
+          <p:nvPr/>
+        </p:nvSpPr>
+        <p:spPr>
+          <a:xfrm>
+            <a:off x="1060704" y="2212848"/>
+            <a:ext cx="3474720" cy="365760"/>
           </a:xfrm>
           <a:prstGeom prst="rect">
             <a:avLst/>
@@ -5381,39 +5363,59 @@
           <a:p>
             <a:pPr indent="0" marL="0">
               <a:lnSpc>
-                <a:spcPct val="130000"/>
+                <a:spcPct val="125000"/>
               </a:lnSpc>
               <a:buNone/>
             </a:pPr>
             <a:r>
-              <a:rPr lang="en-US" sz="800" dirty="0">
-                <a:solidFill>
-                  <a:srgbClr val="1E293B"/>
-                </a:solidFill>
-                <a:latin typeface="Noto Sans KR" pitchFamily="34" charset="0"/>
-                <a:ea typeface="Noto Sans KR" pitchFamily="34" charset="-122"/>
-                <a:cs typeface="Noto Sans KR" pitchFamily="34" charset="-120"/>
-              </a:rPr>
-              <a:t>케이블 정형화 가능 여부 및 바코드 부착 위치 표준화 협의</a:t>
-            </a:r>
-            <a:endParaRPr lang="en-US" sz="800" dirty="0"/>
-          </a:p>
-        </p:txBody>
-      </p:sp>
-      <p:sp>
-        <p:nvSpPr>
-          <p:cNvPr id="16" name="Shape 14"/>
-          <p:cNvSpPr/>
-          <p:nvPr/>
-        </p:nvSpPr>
-        <p:spPr>
-          <a:xfrm>
-            <a:off x="365760" y="1879092"/>
-            <a:ext cx="8412480" cy="749808"/>
+              <a:rPr lang="en-US" sz="950" dirty="0">
+                <a:solidFill>
+                  <a:srgbClr val="475569"/>
+                </a:solidFill>
+                <a:latin typeface="Noto Sans KR" pitchFamily="34" charset="0"/>
+                <a:ea typeface="Noto Sans KR" pitchFamily="34" charset="-122"/>
+                <a:cs typeface="Noto Sans KR" pitchFamily="34" charset="-120"/>
+              </a:rPr>
+              <a:t>설비 구매 부담 없이</a:t>
+            </a:r>
+            <a:endParaRPr lang="en-US" sz="950" dirty="0"/>
+          </a:p>
+          <a:p>
+            <a:pPr indent="0" marL="0">
+              <a:lnSpc>
+                <a:spcPct val="125000"/>
+              </a:lnSpc>
+              <a:buNone/>
+            </a:pPr>
+            <a:r>
+              <a:rPr lang="en-US" sz="950" dirty="0">
+                <a:solidFill>
+                  <a:srgbClr val="475569"/>
+                </a:solidFill>
+                <a:latin typeface="Noto Sans KR" pitchFamily="34" charset="0"/>
+                <a:ea typeface="Noto Sans KR" pitchFamily="34" charset="-122"/>
+                <a:cs typeface="Noto Sans KR" pitchFamily="34" charset="-120"/>
+              </a:rPr>
+              <a:t>월 임대료만으로 도입</a:t>
+            </a:r>
+            <a:endParaRPr lang="en-US" sz="950" dirty="0"/>
+          </a:p>
+        </p:txBody>
+      </p:sp>
+      <p:sp>
+        <p:nvSpPr>
+          <p:cNvPr id="13" name="Shape 11"/>
+          <p:cNvSpPr/>
+          <p:nvPr/>
+        </p:nvSpPr>
+        <p:spPr>
+          <a:xfrm>
+            <a:off x="365760" y="2724912"/>
+            <a:ext cx="4297680" cy="786384"/>
           </a:xfrm>
           <a:prstGeom prst="roundRect">
             <a:avLst>
-              <a:gd name="adj" fmla="val 8537"/>
+              <a:gd name="adj" fmla="val 8140"/>
             </a:avLst>
           </a:prstGeom>
           <a:solidFill>
@@ -5421,7 +5423,7 @@
           </a:solidFill>
           <a:ln w="12700">
             <a:solidFill>
-              <a:srgbClr val="7C3AED"/>
+              <a:srgbClr val="E2E8F0"/>
             </a:solidFill>
             <a:prstDash val="solid"/>
           </a:ln>
@@ -5436,239 +5438,191 @@
       </p:sp>
       <p:sp>
         <p:nvSpPr>
-          <p:cNvPr id="17" name="Shape 15"/>
-          <p:cNvSpPr/>
-          <p:nvPr/>
-        </p:nvSpPr>
-        <p:spPr>
-          <a:xfrm>
-            <a:off x="365760" y="1879092"/>
-            <a:ext cx="475488" cy="749808"/>
+          <p:cNvPr id="14" name="Shape 12"/>
+          <p:cNvSpPr/>
+          <p:nvPr/>
+        </p:nvSpPr>
+        <p:spPr>
+          <a:xfrm>
+            <a:off x="512064" y="2907792"/>
+            <a:ext cx="420624" cy="420624"/>
+          </a:xfrm>
+          <a:prstGeom prst="ellipse">
+            <a:avLst/>
+          </a:prstGeom>
+          <a:solidFill>
+            <a:srgbClr val="DBEAFE"/>
+          </a:solidFill>
+          <a:ln w="12700">
+            <a:solidFill>
+              <a:srgbClr val="DBEAFE"/>
+            </a:solidFill>
+            <a:prstDash val="solid"/>
+          </a:ln>
+        </p:spPr>
+      </p:sp>
+      <p:sp>
+        <p:nvSpPr>
+          <p:cNvPr id="15" name="Text 13"/>
+          <p:cNvSpPr/>
+          <p:nvPr/>
+        </p:nvSpPr>
+        <p:spPr>
+          <a:xfrm>
+            <a:off x="512064" y="2907792"/>
+            <a:ext cx="420624" cy="420624"/>
+          </a:xfrm>
+          <a:prstGeom prst="rect">
+            <a:avLst/>
+          </a:prstGeom>
+          <a:noFill/>
+          <a:ln/>
+        </p:spPr>
+        <p:txBody>
+          <a:bodyPr wrap="square" lIns="0" tIns="0" rIns="0" bIns="0" rtlCol="0" anchor="ctr"/>
+          <a:lstStyle/>
+          <a:p>
+            <a:pPr algn="ctr" indent="0" marL="0">
+              <a:buNone/>
+            </a:pPr>
+            <a:r>
+              <a:rPr lang="en-US" sz="1600" dirty="0">
+                <a:solidFill>
+                  <a:srgbClr val="000000"/>
+                </a:solidFill>
+                <a:latin typeface="Noto Sans KR" pitchFamily="34" charset="0"/>
+                <a:ea typeface="Noto Sans KR" pitchFamily="34" charset="-122"/>
+                <a:cs typeface="Noto Sans KR" pitchFamily="34" charset="-120"/>
+              </a:rPr>
+              <a:t>🛡️</a:t>
+            </a:r>
+            <a:endParaRPr lang="en-US" sz="1600" dirty="0"/>
+          </a:p>
+        </p:txBody>
+      </p:sp>
+      <p:sp>
+        <p:nvSpPr>
+          <p:cNvPr id="16" name="Text 14"/>
+          <p:cNvSpPr/>
+          <p:nvPr/>
+        </p:nvSpPr>
+        <p:spPr>
+          <a:xfrm>
+            <a:off x="1060704" y="2852928"/>
+            <a:ext cx="3474720" cy="274320"/>
+          </a:xfrm>
+          <a:prstGeom prst="rect">
+            <a:avLst/>
+          </a:prstGeom>
+          <a:noFill/>
+          <a:ln/>
+        </p:spPr>
+        <p:txBody>
+          <a:bodyPr wrap="square" lIns="0" tIns="0" rIns="0" bIns="0" rtlCol="0" anchor="ctr"/>
+          <a:lstStyle/>
+          <a:p>
+            <a:pPr indent="0" marL="0">
+              <a:buNone/>
+            </a:pPr>
+            <a:r>
+              <a:rPr lang="en-US" sz="1200" b="1" dirty="0">
+                <a:solidFill>
+                  <a:srgbClr val="1B2F5E"/>
+                </a:solidFill>
+                <a:latin typeface="Noto Sans KR" pitchFamily="34" charset="0"/>
+                <a:ea typeface="Noto Sans KR" pitchFamily="34" charset="-122"/>
+                <a:cs typeface="Noto Sans KR" pitchFamily="34" charset="-120"/>
+              </a:rPr>
+              <a:t>리스크 최소화</a:t>
+            </a:r>
+            <a:endParaRPr lang="en-US" sz="1200" dirty="0"/>
+          </a:p>
+        </p:txBody>
+      </p:sp>
+      <p:sp>
+        <p:nvSpPr>
+          <p:cNvPr id="17" name="Text 15"/>
+          <p:cNvSpPr/>
+          <p:nvPr/>
+        </p:nvSpPr>
+        <p:spPr>
+          <a:xfrm>
+            <a:off x="1060704" y="3108960"/>
+            <a:ext cx="3474720" cy="365760"/>
+          </a:xfrm>
+          <a:prstGeom prst="rect">
+            <a:avLst/>
+          </a:prstGeom>
+          <a:noFill/>
+          <a:ln/>
+        </p:spPr>
+        <p:txBody>
+          <a:bodyPr wrap="square" lIns="0" tIns="0" rIns="0" bIns="0" rtlCol="0" anchor="ctr"/>
+          <a:lstStyle/>
+          <a:p>
+            <a:pPr indent="0" marL="0">
+              <a:lnSpc>
+                <a:spcPct val="125000"/>
+              </a:lnSpc>
+              <a:buNone/>
+            </a:pPr>
+            <a:r>
+              <a:rPr lang="en-US" sz="950" dirty="0">
+                <a:solidFill>
+                  <a:srgbClr val="475569"/>
+                </a:solidFill>
+                <a:latin typeface="Noto Sans KR" pitchFamily="34" charset="0"/>
+                <a:ea typeface="Noto Sans KR" pitchFamily="34" charset="-122"/>
+                <a:cs typeface="Noto Sans KR" pitchFamily="34" charset="-120"/>
+              </a:rPr>
+              <a:t>검증 실패 시에도</a:t>
+            </a:r>
+            <a:endParaRPr lang="en-US" sz="950" dirty="0"/>
+          </a:p>
+          <a:p>
+            <a:pPr indent="0" marL="0">
+              <a:lnSpc>
+                <a:spcPct val="125000"/>
+              </a:lnSpc>
+              <a:buNone/>
+            </a:pPr>
+            <a:r>
+              <a:rPr lang="en-US" sz="950" dirty="0">
+                <a:solidFill>
+                  <a:srgbClr val="475569"/>
+                </a:solidFill>
+                <a:latin typeface="Noto Sans KR" pitchFamily="34" charset="0"/>
+                <a:ea typeface="Noto Sans KR" pitchFamily="34" charset="-122"/>
+                <a:cs typeface="Noto Sans KR" pitchFamily="34" charset="-120"/>
+              </a:rPr>
+              <a:t>고객사 손실 부담 최소</a:t>
+            </a:r>
+            <a:endParaRPr lang="en-US" sz="950" dirty="0"/>
+          </a:p>
+        </p:txBody>
+      </p:sp>
+      <p:sp>
+        <p:nvSpPr>
+          <p:cNvPr id="18" name="Shape 16"/>
+          <p:cNvSpPr/>
+          <p:nvPr/>
+        </p:nvSpPr>
+        <p:spPr>
+          <a:xfrm>
+            <a:off x="365760" y="3621024"/>
+            <a:ext cx="4297680" cy="786384"/>
           </a:xfrm>
           <a:prstGeom prst="roundRect">
             <a:avLst>
-              <a:gd name="adj" fmla="val 11538"/>
+              <a:gd name="adj" fmla="val 8140"/>
             </a:avLst>
           </a:prstGeom>
           <a:solidFill>
-            <a:srgbClr val="7C3AED"/>
+            <a:srgbClr val="FFFFFF"/>
           </a:solidFill>
           <a:ln w="12700">
             <a:solidFill>
-              <a:srgbClr val="7C3AED"/>
-            </a:solidFill>
-            <a:prstDash val="solid"/>
-          </a:ln>
-        </p:spPr>
-      </p:sp>
-      <p:sp>
-        <p:nvSpPr>
-          <p:cNvPr id="18" name="Text 16"/>
-          <p:cNvSpPr/>
-          <p:nvPr/>
-        </p:nvSpPr>
-        <p:spPr>
-          <a:xfrm>
-            <a:off x="365760" y="1879092"/>
-            <a:ext cx="475488" cy="749808"/>
-          </a:xfrm>
-          <a:prstGeom prst="rect">
-            <a:avLst/>
-          </a:prstGeom>
-          <a:noFill/>
-          <a:ln/>
-        </p:spPr>
-        <p:txBody>
-          <a:bodyPr wrap="square" lIns="0" tIns="0" rIns="0" bIns="0" rtlCol="0" anchor="ctr"/>
-          <a:lstStyle/>
-          <a:p>
-            <a:pPr algn="ctr" indent="0" marL="0">
-              <a:buNone/>
-            </a:pPr>
-            <a:r>
-              <a:rPr lang="en-US" sz="1100" b="1" dirty="0">
-                <a:solidFill>
-                  <a:srgbClr val="FFFFFF"/>
-                </a:solidFill>
-                <a:latin typeface="Noto Sans KR" pitchFamily="34" charset="0"/>
-                <a:ea typeface="Noto Sans KR" pitchFamily="34" charset="-122"/>
-                <a:cs typeface="Noto Sans KR" pitchFamily="34" charset="-120"/>
-              </a:rPr>
-              <a:t>02</a:t>
-            </a:r>
-            <a:endParaRPr lang="en-US" sz="1100" dirty="0"/>
-          </a:p>
-        </p:txBody>
-      </p:sp>
-      <p:sp>
-        <p:nvSpPr>
-          <p:cNvPr id="19" name="Shape 17"/>
-          <p:cNvSpPr/>
-          <p:nvPr/>
-        </p:nvSpPr>
-        <p:spPr>
-          <a:xfrm>
-            <a:off x="914400" y="1952244"/>
-            <a:ext cx="658368" cy="182880"/>
-          </a:xfrm>
-          <a:prstGeom prst="roundRect">
-            <a:avLst>
-              <a:gd name="adj" fmla="val 20000"/>
-            </a:avLst>
-          </a:prstGeom>
-          <a:solidFill>
-            <a:srgbClr val="EDE9FE"/>
-          </a:solidFill>
-          <a:ln w="6350">
-            <a:solidFill>
-              <a:srgbClr val="7C3AED"/>
-            </a:solidFill>
-            <a:prstDash val="solid"/>
-          </a:ln>
-        </p:spPr>
-      </p:sp>
-      <p:sp>
-        <p:nvSpPr>
-          <p:cNvPr id="20" name="Text 18"/>
-          <p:cNvSpPr/>
-          <p:nvPr/>
-        </p:nvSpPr>
-        <p:spPr>
-          <a:xfrm>
-            <a:off x="914400" y="1952244"/>
-            <a:ext cx="658368" cy="182880"/>
-          </a:xfrm>
-          <a:prstGeom prst="rect">
-            <a:avLst/>
-          </a:prstGeom>
-          <a:noFill/>
-          <a:ln/>
-        </p:spPr>
-        <p:txBody>
-          <a:bodyPr wrap="square" lIns="0" tIns="0" rIns="0" bIns="0" rtlCol="0" anchor="ctr"/>
-          <a:lstStyle/>
-          <a:p>
-            <a:pPr algn="ctr" indent="0" marL="0">
-              <a:buNone/>
-            </a:pPr>
-            <a:r>
-              <a:rPr lang="en-US" sz="650" b="1" dirty="0">
-                <a:solidFill>
-                  <a:srgbClr val="7C3AED"/>
-                </a:solidFill>
-                <a:latin typeface="Noto Sans KR" pitchFamily="34" charset="0"/>
-                <a:ea typeface="Noto Sans KR" pitchFamily="34" charset="-122"/>
-                <a:cs typeface="Noto Sans KR" pitchFamily="34" charset="-120"/>
-              </a:rPr>
-              <a:t>지그 운용</a:t>
-            </a:r>
-            <a:endParaRPr lang="en-US" sz="650" dirty="0"/>
-          </a:p>
-        </p:txBody>
-      </p:sp>
-      <p:sp>
-        <p:nvSpPr>
-          <p:cNvPr id="21" name="Text 19"/>
-          <p:cNvSpPr/>
-          <p:nvPr/>
-        </p:nvSpPr>
-        <p:spPr>
-          <a:xfrm>
-            <a:off x="914400" y="2153412"/>
-            <a:ext cx="4572000" cy="237744"/>
-          </a:xfrm>
-          <a:prstGeom prst="rect">
-            <a:avLst/>
-          </a:prstGeom>
-          <a:noFill/>
-          <a:ln/>
-        </p:spPr>
-        <p:txBody>
-          <a:bodyPr wrap="square" lIns="0" tIns="0" rIns="0" bIns="0" rtlCol="0" anchor="ctr"/>
-          <a:lstStyle/>
-          <a:p>
-            <a:pPr indent="0" marL="0">
-              <a:buNone/>
-            </a:pPr>
-            <a:r>
-              <a:rPr lang="en-US" sz="950" b="1" dirty="0">
-                <a:solidFill>
-                  <a:srgbClr val="1B2F5E"/>
-                </a:solidFill>
-                <a:latin typeface="Noto Sans KR" pitchFamily="34" charset="0"/>
-                <a:ea typeface="Noto Sans KR" pitchFamily="34" charset="-122"/>
-                <a:cs typeface="Noto Sans KR" pitchFamily="34" charset="-120"/>
-              </a:rPr>
-              <a:t>흐름 라인에서 안착 지그 회수 방법</a:t>
-            </a:r>
-            <a:endParaRPr lang="en-US" sz="950" dirty="0"/>
-          </a:p>
-        </p:txBody>
-      </p:sp>
-      <p:sp>
-        <p:nvSpPr>
-          <p:cNvPr id="22" name="Text 20"/>
-          <p:cNvSpPr/>
-          <p:nvPr/>
-        </p:nvSpPr>
-        <p:spPr>
-          <a:xfrm>
-            <a:off x="914400" y="2372868"/>
-            <a:ext cx="4572000" cy="237744"/>
-          </a:xfrm>
-          <a:prstGeom prst="rect">
-            <a:avLst/>
-          </a:prstGeom>
-          <a:noFill/>
-          <a:ln/>
-        </p:spPr>
-        <p:txBody>
-          <a:bodyPr wrap="square" lIns="0" tIns="0" rIns="0" bIns="0" rtlCol="0" anchor="ctr"/>
-          <a:lstStyle/>
-          <a:p>
-            <a:pPr indent="0" marL="0">
-              <a:lnSpc>
-                <a:spcPct val="110000"/>
-              </a:lnSpc>
-              <a:buNone/>
-            </a:pPr>
-            <a:r>
-              <a:rPr lang="en-US" sz="750" dirty="0">
-                <a:solidFill>
-                  <a:srgbClr val="475569"/>
-                </a:solidFill>
-                <a:latin typeface="Noto Sans KR" pitchFamily="34" charset="0"/>
-                <a:ea typeface="Noto Sans KR" pitchFamily="34" charset="-122"/>
-                <a:cs typeface="Noto Sans KR" pitchFamily="34" charset="-120"/>
-              </a:rPr>
-              <a:t>컨베어 타입 흐름 라인에 지그를 투입할 경우 검사 완료 후 지그를 투입 위치로 회수하는 방법이 필요합니다. 지그 미회수 시 라인 정체 및 추가 지그 소요 비용이 발생합니다.</a:t>
-            </a:r>
-            <a:endParaRPr lang="en-US" sz="750" dirty="0"/>
-          </a:p>
-        </p:txBody>
-      </p:sp>
-      <p:sp>
-        <p:nvSpPr>
-          <p:cNvPr id="23" name="Shape 21"/>
-          <p:cNvSpPr/>
-          <p:nvPr/>
-        </p:nvSpPr>
-        <p:spPr>
-          <a:xfrm>
-            <a:off x="5943600" y="1933956"/>
-            <a:ext cx="2834640" cy="640080"/>
-          </a:xfrm>
-          <a:prstGeom prst="roundRect">
-            <a:avLst>
-              <a:gd name="adj" fmla="val 10000"/>
-            </a:avLst>
-          </a:prstGeom>
-          <a:solidFill>
-            <a:srgbClr val="EDE9FE"/>
-          </a:solidFill>
-          <a:ln w="12700">
-            <a:solidFill>
-              <a:srgbClr val="EDE9FE"/>
+              <a:srgbClr val="E2E8F0"/>
             </a:solidFill>
             <a:prstDash val="solid"/>
           </a:ln>
@@ -5683,14 +5637,78 @@
       </p:sp>
       <p:sp>
         <p:nvSpPr>
-          <p:cNvPr id="24" name="Text 22"/>
-          <p:cNvSpPr/>
-          <p:nvPr/>
-        </p:nvSpPr>
-        <p:spPr>
-          <a:xfrm>
-            <a:off x="6035040" y="1970532"/>
-            <a:ext cx="2706624" cy="182880"/>
+          <p:cNvPr id="19" name="Shape 17"/>
+          <p:cNvSpPr/>
+          <p:nvPr/>
+        </p:nvSpPr>
+        <p:spPr>
+          <a:xfrm>
+            <a:off x="512064" y="3803904"/>
+            <a:ext cx="420624" cy="420624"/>
+          </a:xfrm>
+          <a:prstGeom prst="ellipse">
+            <a:avLst/>
+          </a:prstGeom>
+          <a:solidFill>
+            <a:srgbClr val="DBEAFE"/>
+          </a:solidFill>
+          <a:ln w="12700">
+            <a:solidFill>
+              <a:srgbClr val="DBEAFE"/>
+            </a:solidFill>
+            <a:prstDash val="solid"/>
+          </a:ln>
+        </p:spPr>
+      </p:sp>
+      <p:sp>
+        <p:nvSpPr>
+          <p:cNvPr id="20" name="Text 18"/>
+          <p:cNvSpPr/>
+          <p:nvPr/>
+        </p:nvSpPr>
+        <p:spPr>
+          <a:xfrm>
+            <a:off x="512064" y="3803904"/>
+            <a:ext cx="420624" cy="420624"/>
+          </a:xfrm>
+          <a:prstGeom prst="rect">
+            <a:avLst/>
+          </a:prstGeom>
+          <a:noFill/>
+          <a:ln/>
+        </p:spPr>
+        <p:txBody>
+          <a:bodyPr wrap="square" lIns="0" tIns="0" rIns="0" bIns="0" rtlCol="0" anchor="ctr"/>
+          <a:lstStyle/>
+          <a:p>
+            <a:pPr algn="ctr" indent="0" marL="0">
+              <a:buNone/>
+            </a:pPr>
+            <a:r>
+              <a:rPr lang="en-US" sz="1600" dirty="0">
+                <a:solidFill>
+                  <a:srgbClr val="000000"/>
+                </a:solidFill>
+                <a:latin typeface="Noto Sans KR" pitchFamily="34" charset="0"/>
+                <a:ea typeface="Noto Sans KR" pitchFamily="34" charset="-122"/>
+                <a:cs typeface="Noto Sans KR" pitchFamily="34" charset="-120"/>
+              </a:rPr>
+              <a:t>🔧</a:t>
+            </a:r>
+            <a:endParaRPr lang="en-US" sz="1600" dirty="0"/>
+          </a:p>
+        </p:txBody>
+      </p:sp>
+      <p:sp>
+        <p:nvSpPr>
+          <p:cNvPr id="21" name="Text 19"/>
+          <p:cNvSpPr/>
+          <p:nvPr/>
+        </p:nvSpPr>
+        <p:spPr>
+          <a:xfrm>
+            <a:off x="1060704" y="3749040"/>
+            <a:ext cx="3474720" cy="274320"/>
           </a:xfrm>
           <a:prstGeom prst="rect">
             <a:avLst/>
@@ -5706,30 +5724,30 @@
               <a:buNone/>
             </a:pPr>
             <a:r>
-              <a:rPr lang="en-US" sz="750" b="1" dirty="0">
-                <a:solidFill>
-                  <a:srgbClr val="7C3AED"/>
-                </a:solidFill>
-                <a:latin typeface="Noto Sans KR" pitchFamily="34" charset="0"/>
-                <a:ea typeface="Noto Sans KR" pitchFamily="34" charset="-122"/>
-                <a:cs typeface="Noto Sans KR" pitchFamily="34" charset="-120"/>
-              </a:rPr>
-              <a:t>💬 협의 요청</a:t>
-            </a:r>
-            <a:endParaRPr lang="en-US" sz="750" dirty="0"/>
-          </a:p>
-        </p:txBody>
-      </p:sp>
-      <p:sp>
-        <p:nvSpPr>
-          <p:cNvPr id="25" name="Text 23"/>
-          <p:cNvSpPr/>
-          <p:nvPr/>
-        </p:nvSpPr>
-        <p:spPr>
-          <a:xfrm>
-            <a:off x="6035040" y="2153412"/>
-            <a:ext cx="2706624" cy="438912"/>
+              <a:rPr lang="en-US" sz="1200" b="1" dirty="0">
+                <a:solidFill>
+                  <a:srgbClr val="1B2F5E"/>
+                </a:solidFill>
+                <a:latin typeface="Noto Sans KR" pitchFamily="34" charset="0"/>
+                <a:ea typeface="Noto Sans KR" pitchFamily="34" charset="-122"/>
+                <a:cs typeface="Noto Sans KR" pitchFamily="34" charset="-120"/>
+              </a:rPr>
+              <a:t>유지관리 포함</a:t>
+            </a:r>
+            <a:endParaRPr lang="en-US" sz="1200" dirty="0"/>
+          </a:p>
+        </p:txBody>
+      </p:sp>
+      <p:sp>
+        <p:nvSpPr>
+          <p:cNvPr id="22" name="Text 20"/>
+          <p:cNvSpPr/>
+          <p:nvPr/>
+        </p:nvSpPr>
+        <p:spPr>
+          <a:xfrm>
+            <a:off x="1060704" y="4005072"/>
+            <a:ext cx="3474720" cy="365760"/>
           </a:xfrm>
           <a:prstGeom prst="rect">
             <a:avLst/>
@@ -5743,45 +5761,65 @@
           <a:p>
             <a:pPr indent="0" marL="0">
               <a:lnSpc>
-                <a:spcPct val="130000"/>
+                <a:spcPct val="125000"/>
               </a:lnSpc>
               <a:buNone/>
             </a:pPr>
             <a:r>
-              <a:rPr lang="en-US" sz="800" dirty="0">
-                <a:solidFill>
-                  <a:srgbClr val="1E293B"/>
-                </a:solidFill>
-                <a:latin typeface="Noto Sans KR" pitchFamily="34" charset="0"/>
-                <a:ea typeface="Noto Sans KR" pitchFamily="34" charset="-122"/>
-                <a:cs typeface="Noto Sans KR" pitchFamily="34" charset="-120"/>
-              </a:rPr>
-              <a:t>지그 회수 방식(수동 회수 / 자동 리턴 구조) 및 지그 수량 협의</a:t>
-            </a:r>
-            <a:endParaRPr lang="en-US" sz="800" dirty="0"/>
-          </a:p>
-        </p:txBody>
-      </p:sp>
-      <p:sp>
-        <p:nvSpPr>
-          <p:cNvPr id="26" name="Shape 24"/>
-          <p:cNvSpPr/>
-          <p:nvPr/>
-        </p:nvSpPr>
-        <p:spPr>
-          <a:xfrm>
-            <a:off x="365760" y="2679192"/>
-            <a:ext cx="8412480" cy="749808"/>
+              <a:rPr lang="en-US" sz="950" dirty="0">
+                <a:solidFill>
+                  <a:srgbClr val="475569"/>
+                </a:solidFill>
+                <a:latin typeface="Noto Sans KR" pitchFamily="34" charset="0"/>
+                <a:ea typeface="Noto Sans KR" pitchFamily="34" charset="-122"/>
+                <a:cs typeface="Noto Sans KR" pitchFamily="34" charset="-120"/>
+              </a:rPr>
+              <a:t>정기 점검·모델 재학습·</a:t>
+            </a:r>
+            <a:endParaRPr lang="en-US" sz="950" dirty="0"/>
+          </a:p>
+          <a:p>
+            <a:pPr indent="0" marL="0">
+              <a:lnSpc>
+                <a:spcPct val="125000"/>
+              </a:lnSpc>
+              <a:buNone/>
+            </a:pPr>
+            <a:r>
+              <a:rPr lang="en-US" sz="950" dirty="0">
+                <a:solidFill>
+                  <a:srgbClr val="475569"/>
+                </a:solidFill>
+                <a:latin typeface="Noto Sans KR" pitchFamily="34" charset="0"/>
+                <a:ea typeface="Noto Sans KR" pitchFamily="34" charset="-122"/>
+                <a:cs typeface="Noto Sans KR" pitchFamily="34" charset="-120"/>
+              </a:rPr>
+              <a:t>A/S를 임대료에 포함</a:t>
+            </a:r>
+            <a:endParaRPr lang="en-US" sz="950" dirty="0"/>
+          </a:p>
+        </p:txBody>
+      </p:sp>
+      <p:sp>
+        <p:nvSpPr>
+          <p:cNvPr id="23" name="Shape 21"/>
+          <p:cNvSpPr/>
+          <p:nvPr/>
+        </p:nvSpPr>
+        <p:spPr>
+          <a:xfrm>
+            <a:off x="4846320" y="1828800"/>
+            <a:ext cx="3931920" cy="2578608"/>
           </a:xfrm>
           <a:prstGeom prst="roundRect">
             <a:avLst>
-              <a:gd name="adj" fmla="val 8537"/>
+              <a:gd name="adj" fmla="val 2482"/>
             </a:avLst>
           </a:prstGeom>
           <a:solidFill>
             <a:srgbClr val="FFFFFF"/>
           </a:solidFill>
-          <a:ln w="12700">
+          <a:ln w="19050">
             <a:solidFill>
               <a:srgbClr val="0D9488"/>
             </a:solidFill>
@@ -5798,18 +5836,18 @@
       </p:sp>
       <p:sp>
         <p:nvSpPr>
-          <p:cNvPr id="27" name="Shape 25"/>
-          <p:cNvSpPr/>
-          <p:nvPr/>
-        </p:nvSpPr>
-        <p:spPr>
-          <a:xfrm>
-            <a:off x="365760" y="2679192"/>
-            <a:ext cx="475488" cy="749808"/>
+          <p:cNvPr id="24" name="Shape 22"/>
+          <p:cNvSpPr/>
+          <p:nvPr/>
+        </p:nvSpPr>
+        <p:spPr>
+          <a:xfrm>
+            <a:off x="4846320" y="1828800"/>
+            <a:ext cx="3931920" cy="402336"/>
           </a:xfrm>
           <a:prstGeom prst="roundRect">
             <a:avLst>
-              <a:gd name="adj" fmla="val 11538"/>
+              <a:gd name="adj" fmla="val 15909"/>
             </a:avLst>
           </a:prstGeom>
           <a:solidFill>
@@ -5825,14 +5863,14 @@
       </p:sp>
       <p:sp>
         <p:nvSpPr>
-          <p:cNvPr id="28" name="Text 26"/>
-          <p:cNvSpPr/>
-          <p:nvPr/>
-        </p:nvSpPr>
-        <p:spPr>
-          <a:xfrm>
-            <a:off x="365760" y="2679192"/>
-            <a:ext cx="475488" cy="749808"/>
+          <p:cNvPr id="25" name="Text 23"/>
+          <p:cNvSpPr/>
+          <p:nvPr/>
+        </p:nvSpPr>
+        <p:spPr>
+          <a:xfrm>
+            <a:off x="4846320" y="1828800"/>
+            <a:ext cx="3931920" cy="402336"/>
           </a:xfrm>
           <a:prstGeom prst="rect">
             <a:avLst/>
@@ -5848,7 +5886,7 @@
               <a:buNone/>
             </a:pPr>
             <a:r>
-              <a:rPr lang="en-US" sz="1100" b="1" dirty="0">
+              <a:rPr lang="en-US" sz="1200" b="1" dirty="0">
                 <a:solidFill>
                   <a:srgbClr val="FFFFFF"/>
                 </a:solidFill>
@@ -5856,173 +5894,26 @@
                 <a:ea typeface="Noto Sans KR" pitchFamily="34" charset="-122"/>
                 <a:cs typeface="Noto Sans KR" pitchFamily="34" charset="-120"/>
               </a:rPr>
-              <a:t>03</a:t>
-            </a:r>
-            <a:endParaRPr lang="en-US" sz="1100" dirty="0"/>
-          </a:p>
-        </p:txBody>
-      </p:sp>
-      <p:sp>
-        <p:nvSpPr>
-          <p:cNvPr id="29" name="Shape 27"/>
-          <p:cNvSpPr/>
-          <p:nvPr/>
-        </p:nvSpPr>
-        <p:spPr>
-          <a:xfrm>
-            <a:off x="914400" y="2752344"/>
-            <a:ext cx="658368" cy="182880"/>
+              <a:t>기능 구성에 따른 임대료</a:t>
+            </a:r>
+            <a:endParaRPr lang="en-US" sz="1200" dirty="0"/>
+          </a:p>
+        </p:txBody>
+      </p:sp>
+      <p:sp>
+        <p:nvSpPr>
+          <p:cNvPr id="26" name="Shape 24"/>
+          <p:cNvSpPr/>
+          <p:nvPr/>
+        </p:nvSpPr>
+        <p:spPr>
+          <a:xfrm>
+            <a:off x="4974336" y="2340864"/>
+            <a:ext cx="3675888" cy="566928"/>
           </a:xfrm>
           <a:prstGeom prst="roundRect">
             <a:avLst>
-              <a:gd name="adj" fmla="val 20000"/>
-            </a:avLst>
-          </a:prstGeom>
-          <a:solidFill>
-            <a:srgbClr val="CCFBF1"/>
-          </a:solidFill>
-          <a:ln w="6350">
-            <a:solidFill>
-              <a:srgbClr val="0D9488"/>
-            </a:solidFill>
-            <a:prstDash val="solid"/>
-          </a:ln>
-        </p:spPr>
-      </p:sp>
-      <p:sp>
-        <p:nvSpPr>
-          <p:cNvPr id="30" name="Text 28"/>
-          <p:cNvSpPr/>
-          <p:nvPr/>
-        </p:nvSpPr>
-        <p:spPr>
-          <a:xfrm>
-            <a:off x="914400" y="2752344"/>
-            <a:ext cx="658368" cy="182880"/>
-          </a:xfrm>
-          <a:prstGeom prst="rect">
-            <a:avLst/>
-          </a:prstGeom>
-          <a:noFill/>
-          <a:ln/>
-        </p:spPr>
-        <p:txBody>
-          <a:bodyPr wrap="square" lIns="0" tIns="0" rIns="0" bIns="0" rtlCol="0" anchor="ctr"/>
-          <a:lstStyle/>
-          <a:p>
-            <a:pPr algn="ctr" indent="0" marL="0">
-              <a:buNone/>
-            </a:pPr>
-            <a:r>
-              <a:rPr lang="en-US" sz="650" b="1" dirty="0">
-                <a:solidFill>
-                  <a:srgbClr val="0D9488"/>
-                </a:solidFill>
-                <a:latin typeface="Noto Sans KR" pitchFamily="34" charset="0"/>
-                <a:ea typeface="Noto Sans KR" pitchFamily="34" charset="-122"/>
-                <a:cs typeface="Noto Sans KR" pitchFamily="34" charset="-120"/>
-              </a:rPr>
-              <a:t>처리량</a:t>
-            </a:r>
-            <a:endParaRPr lang="en-US" sz="650" dirty="0"/>
-          </a:p>
-        </p:txBody>
-      </p:sp>
-      <p:sp>
-        <p:nvSpPr>
-          <p:cNvPr id="31" name="Text 29"/>
-          <p:cNvSpPr/>
-          <p:nvPr/>
-        </p:nvSpPr>
-        <p:spPr>
-          <a:xfrm>
-            <a:off x="914400" y="2953512"/>
-            <a:ext cx="4572000" cy="237744"/>
-          </a:xfrm>
-          <a:prstGeom prst="rect">
-            <a:avLst/>
-          </a:prstGeom>
-          <a:noFill/>
-          <a:ln/>
-        </p:spPr>
-        <p:txBody>
-          <a:bodyPr wrap="square" lIns="0" tIns="0" rIns="0" bIns="0" rtlCol="0" anchor="ctr"/>
-          <a:lstStyle/>
-          <a:p>
-            <a:pPr indent="0" marL="0">
-              <a:buNone/>
-            </a:pPr>
-            <a:r>
-              <a:rPr lang="en-US" sz="950" b="1" dirty="0">
-                <a:solidFill>
-                  <a:srgbClr val="1B2F5E"/>
-                </a:solidFill>
-                <a:latin typeface="Noto Sans KR" pitchFamily="34" charset="0"/>
-                <a:ea typeface="Noto Sans KR" pitchFamily="34" charset="-122"/>
-                <a:cs typeface="Noto Sans KR" pitchFamily="34" charset="-120"/>
-              </a:rPr>
-              <a:t>다수 검사품 동시 안착 가능 여부</a:t>
-            </a:r>
-            <a:endParaRPr lang="en-US" sz="950" dirty="0"/>
-          </a:p>
-        </p:txBody>
-      </p:sp>
-      <p:sp>
-        <p:nvSpPr>
-          <p:cNvPr id="32" name="Text 30"/>
-          <p:cNvSpPr/>
-          <p:nvPr/>
-        </p:nvSpPr>
-        <p:spPr>
-          <a:xfrm>
-            <a:off x="914400" y="3172968"/>
-            <a:ext cx="4572000" cy="237744"/>
-          </a:xfrm>
-          <a:prstGeom prst="rect">
-            <a:avLst/>
-          </a:prstGeom>
-          <a:noFill/>
-          <a:ln/>
-        </p:spPr>
-        <p:txBody>
-          <a:bodyPr wrap="square" lIns="0" tIns="0" rIns="0" bIns="0" rtlCol="0" anchor="ctr"/>
-          <a:lstStyle/>
-          <a:p>
-            <a:pPr indent="0" marL="0">
-              <a:lnSpc>
-                <a:spcPct val="110000"/>
-              </a:lnSpc>
-              <a:buNone/>
-            </a:pPr>
-            <a:r>
-              <a:rPr lang="en-US" sz="750" dirty="0">
-                <a:solidFill>
-                  <a:srgbClr val="475569"/>
-                </a:solidFill>
-                <a:latin typeface="Noto Sans KR" pitchFamily="34" charset="0"/>
-                <a:ea typeface="Noto Sans KR" pitchFamily="34" charset="-122"/>
-                <a:cs typeface="Noto Sans KR" pitchFamily="34" charset="-120"/>
-              </a:rPr>
-              <a:t>02항의 지그 회수 방식에 따라 복수의 검사품을 동시에 지그에 올려두는 멀티 안착 구조가 가능한지 검토가 필요합니다. 동시 처리 수량에 따라 검사기 설계 규모와 S/T가 결정됩니다.</a:t>
-            </a:r>
-            <a:endParaRPr lang="en-US" sz="750" dirty="0"/>
-          </a:p>
-        </p:txBody>
-      </p:sp>
-      <p:sp>
-        <p:nvSpPr>
-          <p:cNvPr id="33" name="Shape 31"/>
-          <p:cNvSpPr/>
-          <p:nvPr/>
-        </p:nvSpPr>
-        <p:spPr>
-          <a:xfrm>
-            <a:off x="5943600" y="2734056"/>
-            <a:ext cx="2834640" cy="640080"/>
-          </a:xfrm>
-          <a:prstGeom prst="roundRect">
-            <a:avLst>
-              <a:gd name="adj" fmla="val 10000"/>
+              <a:gd name="adj" fmla="val 11290"/>
             </a:avLst>
           </a:prstGeom>
           <a:solidFill>
@@ -6045,14 +5936,14 @@
       </p:sp>
       <p:sp>
         <p:nvSpPr>
-          <p:cNvPr id="34" name="Text 32"/>
-          <p:cNvSpPr/>
-          <p:nvPr/>
-        </p:nvSpPr>
-        <p:spPr>
-          <a:xfrm>
-            <a:off x="6035040" y="2770632"/>
-            <a:ext cx="2706624" cy="182880"/>
+          <p:cNvPr id="27" name="Text 25"/>
+          <p:cNvSpPr/>
+          <p:nvPr/>
+        </p:nvSpPr>
+        <p:spPr>
+          <a:xfrm>
+            <a:off x="5065776" y="2395728"/>
+            <a:ext cx="1828800" cy="219456"/>
           </a:xfrm>
           <a:prstGeom prst="rect">
             <a:avLst/>
@@ -6068,30 +5959,30 @@
               <a:buNone/>
             </a:pPr>
             <a:r>
-              <a:rPr lang="en-US" sz="750" b="1" dirty="0">
-                <a:solidFill>
-                  <a:srgbClr val="0D9488"/>
-                </a:solidFill>
-                <a:latin typeface="Noto Sans KR" pitchFamily="34" charset="0"/>
-                <a:ea typeface="Noto Sans KR" pitchFamily="34" charset="-122"/>
-                <a:cs typeface="Noto Sans KR" pitchFamily="34" charset="-120"/>
-              </a:rPr>
-              <a:t>💬 협의 요청</a:t>
-            </a:r>
-            <a:endParaRPr lang="en-US" sz="750" dirty="0"/>
-          </a:p>
-        </p:txBody>
-      </p:sp>
-      <p:sp>
-        <p:nvSpPr>
-          <p:cNvPr id="35" name="Text 33"/>
-          <p:cNvSpPr/>
-          <p:nvPr/>
-        </p:nvSpPr>
-        <p:spPr>
-          <a:xfrm>
-            <a:off x="6035040" y="2953512"/>
-            <a:ext cx="2706624" cy="438912"/>
+              <a:rPr lang="en-US" sz="1050" b="1" dirty="0">
+                <a:solidFill>
+                  <a:srgbClr val="0F766E"/>
+                </a:solidFill>
+                <a:latin typeface="Noto Sans KR" pitchFamily="34" charset="0"/>
+                <a:ea typeface="Noto Sans KR" pitchFamily="34" charset="-122"/>
+                <a:cs typeface="Noto Sans KR" pitchFamily="34" charset="-120"/>
+              </a:rPr>
+              <a:t>검증기</a:t>
+            </a:r>
+            <a:endParaRPr lang="en-US" sz="1050" dirty="0"/>
+          </a:p>
+        </p:txBody>
+      </p:sp>
+      <p:sp>
+        <p:nvSpPr>
+          <p:cNvPr id="28" name="Text 26"/>
+          <p:cNvSpPr/>
+          <p:nvPr/>
+        </p:nvSpPr>
+        <p:spPr>
+          <a:xfrm>
+            <a:off x="5065776" y="2615184"/>
+            <a:ext cx="2743200" cy="237744"/>
           </a:xfrm>
           <a:prstGeom prst="rect">
             <a:avLst/>
@@ -6104,48 +5995,111 @@
           <a:lstStyle/>
           <a:p>
             <a:pPr indent="0" marL="0">
-              <a:lnSpc>
-                <a:spcPct val="130000"/>
-              </a:lnSpc>
-              <a:buNone/>
-            </a:pPr>
-            <a:r>
-              <a:rPr lang="en-US" sz="800" dirty="0">
-                <a:solidFill>
-                  <a:srgbClr val="1E293B"/>
-                </a:solidFill>
-                <a:latin typeface="Noto Sans KR" pitchFamily="34" charset="0"/>
-                <a:ea typeface="Noto Sans KR" pitchFamily="34" charset="-122"/>
-                <a:cs typeface="Noto Sans KR" pitchFamily="34" charset="-120"/>
-              </a:rPr>
-              <a:t>라인 생산 속도 및 동시 처리 목표 수량 공유 요청</a:t>
-            </a:r>
-            <a:endParaRPr lang="en-US" sz="800" dirty="0"/>
-          </a:p>
-        </p:txBody>
-      </p:sp>
-      <p:sp>
-        <p:nvSpPr>
-          <p:cNvPr id="36" name="Shape 34"/>
-          <p:cNvSpPr/>
-          <p:nvPr/>
-        </p:nvSpPr>
-        <p:spPr>
-          <a:xfrm>
-            <a:off x="365760" y="3479292"/>
-            <a:ext cx="8412480" cy="749808"/>
+              <a:buNone/>
+            </a:pPr>
+            <a:r>
+              <a:rPr lang="en-US" sz="850" dirty="0">
+                <a:solidFill>
+                  <a:srgbClr val="475569"/>
+                </a:solidFill>
+                <a:latin typeface="Noto Sans KR" pitchFamily="34" charset="0"/>
+                <a:ea typeface="Noto Sans KR" pitchFamily="34" charset="-122"/>
+                <a:cs typeface="Noto Sans KR" pitchFamily="34" charset="-120"/>
+              </a:rPr>
+              <a:t>딥러닝 검사 + 수동 투입·배출</a:t>
+            </a:r>
+            <a:endParaRPr lang="en-US" sz="850" dirty="0"/>
+          </a:p>
+        </p:txBody>
+      </p:sp>
+      <p:sp>
+        <p:nvSpPr>
+          <p:cNvPr id="29" name="Shape 27"/>
+          <p:cNvSpPr/>
+          <p:nvPr/>
+        </p:nvSpPr>
+        <p:spPr>
+          <a:xfrm>
+            <a:off x="7863840" y="2487168"/>
+            <a:ext cx="749808" cy="274320"/>
           </a:xfrm>
           <a:prstGeom prst="roundRect">
             <a:avLst>
-              <a:gd name="adj" fmla="val 8537"/>
+              <a:gd name="adj" fmla="val 13333"/>
             </a:avLst>
           </a:prstGeom>
           <a:solidFill>
-            <a:srgbClr val="FFFFFF"/>
+            <a:srgbClr val="0D9488"/>
           </a:solidFill>
           <a:ln w="12700">
             <a:solidFill>
-              <a:srgbClr val="D97706"/>
+              <a:srgbClr val="0D9488"/>
+            </a:solidFill>
+            <a:prstDash val="solid"/>
+          </a:ln>
+        </p:spPr>
+      </p:sp>
+      <p:sp>
+        <p:nvSpPr>
+          <p:cNvPr id="30" name="Text 28"/>
+          <p:cNvSpPr/>
+          <p:nvPr/>
+        </p:nvSpPr>
+        <p:spPr>
+          <a:xfrm>
+            <a:off x="7863840" y="2487168"/>
+            <a:ext cx="749808" cy="274320"/>
+          </a:xfrm>
+          <a:prstGeom prst="rect">
+            <a:avLst/>
+          </a:prstGeom>
+          <a:noFill/>
+          <a:ln/>
+        </p:spPr>
+        <p:txBody>
+          <a:bodyPr wrap="square" lIns="0" tIns="0" rIns="0" bIns="0" rtlCol="0" anchor="ctr"/>
+          <a:lstStyle/>
+          <a:p>
+            <a:pPr algn="ctr" indent="0" marL="0">
+              <a:buNone/>
+            </a:pPr>
+            <a:r>
+              <a:rPr lang="en-US" sz="850" b="1" dirty="0">
+                <a:solidFill>
+                  <a:srgbClr val="FFFFFF"/>
+                </a:solidFill>
+                <a:latin typeface="Noto Sans KR" pitchFamily="34" charset="0"/>
+                <a:ea typeface="Noto Sans KR" pitchFamily="34" charset="-122"/>
+                <a:cs typeface="Noto Sans KR" pitchFamily="34" charset="-120"/>
+              </a:rPr>
+              <a:t>기본</a:t>
+            </a:r>
+            <a:endParaRPr lang="en-US" sz="850" dirty="0"/>
+          </a:p>
+        </p:txBody>
+      </p:sp>
+      <p:sp>
+        <p:nvSpPr>
+          <p:cNvPr id="31" name="Shape 29"/>
+          <p:cNvSpPr/>
+          <p:nvPr/>
+        </p:nvSpPr>
+        <p:spPr>
+          <a:xfrm>
+            <a:off x="4974336" y="2999232"/>
+            <a:ext cx="3675888" cy="566928"/>
+          </a:xfrm>
+          <a:prstGeom prst="roundRect">
+            <a:avLst>
+              <a:gd name="adj" fmla="val 11290"/>
+            </a:avLst>
+          </a:prstGeom>
+          <a:solidFill>
+            <a:srgbClr val="EEF6F4"/>
+          </a:solidFill>
+          <a:ln w="12700">
+            <a:solidFill>
+              <a:srgbClr val="EEF6F4"/>
             </a:solidFill>
             <a:prstDash val="solid"/>
           </a:ln>
@@ -6160,41 +6114,119 @@
       </p:sp>
       <p:sp>
         <p:nvSpPr>
-          <p:cNvPr id="37" name="Shape 35"/>
-          <p:cNvSpPr/>
-          <p:nvPr/>
-        </p:nvSpPr>
-        <p:spPr>
-          <a:xfrm>
-            <a:off x="365760" y="3479292"/>
-            <a:ext cx="475488" cy="749808"/>
+          <p:cNvPr id="32" name="Text 30"/>
+          <p:cNvSpPr/>
+          <p:nvPr/>
+        </p:nvSpPr>
+        <p:spPr>
+          <a:xfrm>
+            <a:off x="5065776" y="3054096"/>
+            <a:ext cx="1828800" cy="219456"/>
+          </a:xfrm>
+          <a:prstGeom prst="rect">
+            <a:avLst/>
+          </a:prstGeom>
+          <a:noFill/>
+          <a:ln/>
+        </p:spPr>
+        <p:txBody>
+          <a:bodyPr wrap="square" lIns="0" tIns="0" rIns="0" bIns="0" rtlCol="0" anchor="ctr"/>
+          <a:lstStyle/>
+          <a:p>
+            <a:pPr indent="0" marL="0">
+              <a:buNone/>
+            </a:pPr>
+            <a:r>
+              <a:rPr lang="en-US" sz="1050" b="1" dirty="0">
+                <a:solidFill>
+                  <a:srgbClr val="0F766E"/>
+                </a:solidFill>
+                <a:latin typeface="Noto Sans KR" pitchFamily="34" charset="0"/>
+                <a:ea typeface="Noto Sans KR" pitchFamily="34" charset="-122"/>
+                <a:cs typeface="Noto Sans KR" pitchFamily="34" charset="-120"/>
+              </a:rPr>
+              <a:t>양산 표준형</a:t>
+            </a:r>
+            <a:endParaRPr lang="en-US" sz="1050" dirty="0"/>
+          </a:p>
+        </p:txBody>
+      </p:sp>
+      <p:sp>
+        <p:nvSpPr>
+          <p:cNvPr id="33" name="Text 31"/>
+          <p:cNvSpPr/>
+          <p:nvPr/>
+        </p:nvSpPr>
+        <p:spPr>
+          <a:xfrm>
+            <a:off x="5065776" y="3273552"/>
+            <a:ext cx="2743200" cy="237744"/>
+          </a:xfrm>
+          <a:prstGeom prst="rect">
+            <a:avLst/>
+          </a:prstGeom>
+          <a:noFill/>
+          <a:ln/>
+        </p:spPr>
+        <p:txBody>
+          <a:bodyPr wrap="square" lIns="0" tIns="0" rIns="0" bIns="0" rtlCol="0" anchor="ctr"/>
+          <a:lstStyle/>
+          <a:p>
+            <a:pPr indent="0" marL="0">
+              <a:buNone/>
+            </a:pPr>
+            <a:r>
+              <a:rPr lang="en-US" sz="850" dirty="0">
+                <a:solidFill>
+                  <a:srgbClr val="475569"/>
+                </a:solidFill>
+                <a:latin typeface="Noto Sans KR" pitchFamily="34" charset="0"/>
+                <a:ea typeface="Noto Sans KR" pitchFamily="34" charset="-122"/>
+                <a:cs typeface="Noto Sans KR" pitchFamily="34" charset="-120"/>
+              </a:rPr>
+              <a:t>자동 투입·배출 + 바코드 자동 스캔</a:t>
+            </a:r>
+            <a:endParaRPr lang="en-US" sz="850" dirty="0"/>
+          </a:p>
+        </p:txBody>
+      </p:sp>
+      <p:sp>
+        <p:nvSpPr>
+          <p:cNvPr id="34" name="Shape 32"/>
+          <p:cNvSpPr/>
+          <p:nvPr/>
+        </p:nvSpPr>
+        <p:spPr>
+          <a:xfrm>
+            <a:off x="7863840" y="3145536"/>
+            <a:ext cx="749808" cy="274320"/>
           </a:xfrm>
           <a:prstGeom prst="roundRect">
             <a:avLst>
-              <a:gd name="adj" fmla="val 11538"/>
+              <a:gd name="adj" fmla="val 13333"/>
             </a:avLst>
           </a:prstGeom>
           <a:solidFill>
-            <a:srgbClr val="D97706"/>
+            <a:srgbClr val="000000"/>
           </a:solidFill>
           <a:ln w="12700">
             <a:solidFill>
-              <a:srgbClr val="D97706"/>
-            </a:solidFill>
-            <a:prstDash val="solid"/>
-          </a:ln>
-        </p:spPr>
-      </p:sp>
-      <p:sp>
-        <p:nvSpPr>
-          <p:cNvPr id="38" name="Text 36"/>
-          <p:cNvSpPr/>
-          <p:nvPr/>
-        </p:nvSpPr>
-        <p:spPr>
-          <a:xfrm>
-            <a:off x="365760" y="3479292"/>
-            <a:ext cx="475488" cy="749808"/>
+              <a:srgbClr val="333333"/>
+            </a:solidFill>
+            <a:prstDash val="solid"/>
+          </a:ln>
+        </p:spPr>
+      </p:sp>
+      <p:sp>
+        <p:nvSpPr>
+          <p:cNvPr id="35" name="Text 33"/>
+          <p:cNvSpPr/>
+          <p:nvPr/>
+        </p:nvSpPr>
+        <p:spPr>
+          <a:xfrm>
+            <a:off x="7863840" y="3145536"/>
+            <a:ext cx="749808" cy="274320"/>
           </a:xfrm>
           <a:prstGeom prst="rect">
             <a:avLst/>
@@ -6210,7 +6242,7 @@
               <a:buNone/>
             </a:pPr>
             <a:r>
-              <a:rPr lang="en-US" sz="1100" b="1" dirty="0">
+              <a:rPr lang="en-US" sz="850" b="1" dirty="0">
                 <a:solidFill>
                   <a:srgbClr val="FFFFFF"/>
                 </a:solidFill>
@@ -6218,181 +6250,34 @@
                 <a:ea typeface="Noto Sans KR" pitchFamily="34" charset="-122"/>
                 <a:cs typeface="Noto Sans KR" pitchFamily="34" charset="-120"/>
               </a:rPr>
-              <a:t>04</a:t>
-            </a:r>
-            <a:endParaRPr lang="en-US" sz="1100" dirty="0"/>
-          </a:p>
-        </p:txBody>
-      </p:sp>
-      <p:sp>
-        <p:nvSpPr>
-          <p:cNvPr id="39" name="Shape 37"/>
-          <p:cNvSpPr/>
-          <p:nvPr/>
-        </p:nvSpPr>
-        <p:spPr>
-          <a:xfrm>
-            <a:off x="914400" y="3552444"/>
-            <a:ext cx="658368" cy="182880"/>
+              <a:t>중간</a:t>
+            </a:r>
+            <a:endParaRPr lang="en-US" sz="850" dirty="0"/>
+          </a:p>
+        </p:txBody>
+      </p:sp>
+      <p:sp>
+        <p:nvSpPr>
+          <p:cNvPr id="36" name="Shape 34"/>
+          <p:cNvSpPr/>
+          <p:nvPr/>
+        </p:nvSpPr>
+        <p:spPr>
+          <a:xfrm>
+            <a:off x="4974336" y="3657600"/>
+            <a:ext cx="3675888" cy="566928"/>
           </a:xfrm>
           <a:prstGeom prst="roundRect">
             <a:avLst>
-              <a:gd name="adj" fmla="val 20000"/>
+              <a:gd name="adj" fmla="val 11290"/>
             </a:avLst>
           </a:prstGeom>
           <a:solidFill>
-            <a:srgbClr val="FEF3C7"/>
-          </a:solidFill>
-          <a:ln w="6350">
-            <a:solidFill>
-              <a:srgbClr val="D97706"/>
-            </a:solidFill>
-            <a:prstDash val="solid"/>
-          </a:ln>
-        </p:spPr>
-      </p:sp>
-      <p:sp>
-        <p:nvSpPr>
-          <p:cNvPr id="40" name="Text 38"/>
-          <p:cNvSpPr/>
-          <p:nvPr/>
-        </p:nvSpPr>
-        <p:spPr>
-          <a:xfrm>
-            <a:off x="914400" y="3552444"/>
-            <a:ext cx="658368" cy="182880"/>
-          </a:xfrm>
-          <a:prstGeom prst="rect">
-            <a:avLst/>
-          </a:prstGeom>
-          <a:noFill/>
-          <a:ln/>
-        </p:spPr>
-        <p:txBody>
-          <a:bodyPr wrap="square" lIns="0" tIns="0" rIns="0" bIns="0" rtlCol="0" anchor="ctr"/>
-          <a:lstStyle/>
-          <a:p>
-            <a:pPr algn="ctr" indent="0" marL="0">
-              <a:buNone/>
-            </a:pPr>
-            <a:r>
-              <a:rPr lang="en-US" sz="650" b="1" dirty="0">
-                <a:solidFill>
-                  <a:srgbClr val="D97706"/>
-                </a:solidFill>
-                <a:latin typeface="Noto Sans KR" pitchFamily="34" charset="0"/>
-                <a:ea typeface="Noto Sans KR" pitchFamily="34" charset="-122"/>
-                <a:cs typeface="Noto Sans KR" pitchFamily="34" charset="-120"/>
-              </a:rPr>
-              <a:t>장비 설계</a:t>
-            </a:r>
-            <a:endParaRPr lang="en-US" sz="650" dirty="0"/>
-          </a:p>
-        </p:txBody>
-      </p:sp>
-      <p:sp>
-        <p:nvSpPr>
-          <p:cNvPr id="41" name="Text 39"/>
-          <p:cNvSpPr/>
-          <p:nvPr/>
-        </p:nvSpPr>
-        <p:spPr>
-          <a:xfrm>
-            <a:off x="914400" y="3753612"/>
-            <a:ext cx="4572000" cy="237744"/>
-          </a:xfrm>
-          <a:prstGeom prst="rect">
-            <a:avLst/>
-          </a:prstGeom>
-          <a:noFill/>
-          <a:ln/>
-        </p:spPr>
-        <p:txBody>
-          <a:bodyPr wrap="square" lIns="0" tIns="0" rIns="0" bIns="0" rtlCol="0" anchor="ctr"/>
-          <a:lstStyle/>
-          <a:p>
-            <a:pPr indent="0" marL="0">
-              <a:buNone/>
-            </a:pPr>
-            <a:r>
-              <a:rPr lang="en-US" sz="950" b="1" dirty="0">
-                <a:solidFill>
-                  <a:srgbClr val="1B2F5E"/>
-                </a:solidFill>
-                <a:latin typeface="Noto Sans KR" pitchFamily="34" charset="0"/>
-                <a:ea typeface="Noto Sans KR" pitchFamily="34" charset="-122"/>
-                <a:cs typeface="Noto Sans KR" pitchFamily="34" charset="-120"/>
-              </a:rPr>
-              <a:t>03항 가능 시 — 검사기 내부 지그 리턴 구조 추가</a:t>
-            </a:r>
-            <a:endParaRPr lang="en-US" sz="950" dirty="0"/>
-          </a:p>
-        </p:txBody>
-      </p:sp>
-      <p:sp>
-        <p:nvSpPr>
-          <p:cNvPr id="42" name="Text 40"/>
-          <p:cNvSpPr/>
-          <p:nvPr/>
-        </p:nvSpPr>
-        <p:spPr>
-          <a:xfrm>
-            <a:off x="914400" y="3973068"/>
-            <a:ext cx="4572000" cy="237744"/>
-          </a:xfrm>
-          <a:prstGeom prst="rect">
-            <a:avLst/>
-          </a:prstGeom>
-          <a:noFill/>
-          <a:ln/>
-        </p:spPr>
-        <p:txBody>
-          <a:bodyPr wrap="square" lIns="0" tIns="0" rIns="0" bIns="0" rtlCol="0" anchor="ctr"/>
-          <a:lstStyle/>
-          <a:p>
-            <a:pPr indent="0" marL="0">
-              <a:lnSpc>
-                <a:spcPct val="110000"/>
-              </a:lnSpc>
-              <a:buNone/>
-            </a:pPr>
-            <a:r>
-              <a:rPr lang="en-US" sz="750" dirty="0">
-                <a:solidFill>
-                  <a:srgbClr val="475569"/>
-                </a:solidFill>
-                <a:latin typeface="Noto Sans KR" pitchFamily="34" charset="0"/>
-                <a:ea typeface="Noto Sans KR" pitchFamily="34" charset="-122"/>
-                <a:cs typeface="Noto Sans KR" pitchFamily="34" charset="-120"/>
-              </a:rPr>
-              <a:t>다수 동시 안착이 가능하다면 검사기 내부에 지그 자동 리턴 구조를 설계에 포함합니다. 이 경우 장비 규모와 제작 기간·비용이 증가하므로 효용성을 함께 검토해야 합니다.</a:t>
-            </a:r>
-            <a:endParaRPr lang="en-US" sz="750" dirty="0"/>
-          </a:p>
-        </p:txBody>
-      </p:sp>
-      <p:sp>
-        <p:nvSpPr>
-          <p:cNvPr id="43" name="Shape 41"/>
-          <p:cNvSpPr/>
-          <p:nvPr/>
-        </p:nvSpPr>
-        <p:spPr>
-          <a:xfrm>
-            <a:off x="5943600" y="3534156"/>
-            <a:ext cx="2834640" cy="640080"/>
-          </a:xfrm>
-          <a:prstGeom prst="roundRect">
-            <a:avLst>
-              <a:gd name="adj" fmla="val 10000"/>
-            </a:avLst>
-          </a:prstGeom>
-          <a:solidFill>
-            <a:srgbClr val="FEF3C7"/>
+            <a:srgbClr val="EEF6F4"/>
           </a:solidFill>
           <a:ln w="12700">
             <a:solidFill>
-              <a:srgbClr val="FEF3C7"/>
+              <a:srgbClr val="EEF6F4"/>
             </a:solidFill>
             <a:prstDash val="solid"/>
           </a:ln>
@@ -6407,14 +6292,14 @@
       </p:sp>
       <p:sp>
         <p:nvSpPr>
-          <p:cNvPr id="44" name="Text 42"/>
-          <p:cNvSpPr/>
-          <p:nvPr/>
-        </p:nvSpPr>
-        <p:spPr>
-          <a:xfrm>
-            <a:off x="6035040" y="3570732"/>
-            <a:ext cx="2706624" cy="182880"/>
+          <p:cNvPr id="37" name="Text 35"/>
+          <p:cNvSpPr/>
+          <p:nvPr/>
+        </p:nvSpPr>
+        <p:spPr>
+          <a:xfrm>
+            <a:off x="5065776" y="3712464"/>
+            <a:ext cx="1828800" cy="219456"/>
           </a:xfrm>
           <a:prstGeom prst="rect">
             <a:avLst/>
@@ -6430,30 +6315,30 @@
               <a:buNone/>
             </a:pPr>
             <a:r>
-              <a:rPr lang="en-US" sz="750" b="1" dirty="0">
-                <a:solidFill>
-                  <a:srgbClr val="D97706"/>
-                </a:solidFill>
-                <a:latin typeface="Noto Sans KR" pitchFamily="34" charset="0"/>
-                <a:ea typeface="Noto Sans KR" pitchFamily="34" charset="-122"/>
-                <a:cs typeface="Noto Sans KR" pitchFamily="34" charset="-120"/>
-              </a:rPr>
-              <a:t>💬 협의 요청</a:t>
-            </a:r>
-            <a:endParaRPr lang="en-US" sz="750" dirty="0"/>
-          </a:p>
-        </p:txBody>
-      </p:sp>
-      <p:sp>
-        <p:nvSpPr>
-          <p:cNvPr id="45" name="Text 43"/>
-          <p:cNvSpPr/>
-          <p:nvPr/>
-        </p:nvSpPr>
-        <p:spPr>
-          <a:xfrm>
-            <a:off x="6035040" y="3753612"/>
-            <a:ext cx="2706624" cy="438912"/>
+              <a:rPr lang="en-US" sz="1050" b="1" dirty="0">
+                <a:solidFill>
+                  <a:srgbClr val="0F766E"/>
+                </a:solidFill>
+                <a:latin typeface="Noto Sans KR" pitchFamily="34" charset="0"/>
+                <a:ea typeface="Noto Sans KR" pitchFamily="34" charset="-122"/>
+                <a:cs typeface="Noto Sans KR" pitchFamily="34" charset="-120"/>
+              </a:rPr>
+              <a:t>양산 고급형</a:t>
+            </a:r>
+            <a:endParaRPr lang="en-US" sz="1050" dirty="0"/>
+          </a:p>
+        </p:txBody>
+      </p:sp>
+      <p:sp>
+        <p:nvSpPr>
+          <p:cNvPr id="38" name="Text 36"/>
+          <p:cNvSpPr/>
+          <p:nvPr/>
+        </p:nvSpPr>
+        <p:spPr>
+          <a:xfrm>
+            <a:off x="5065776" y="3931920"/>
+            <a:ext cx="2743200" cy="237744"/>
           </a:xfrm>
           <a:prstGeom prst="rect">
             <a:avLst/>
@@ -6466,48 +6351,111 @@
           <a:lstStyle/>
           <a:p>
             <a:pPr indent="0" marL="0">
-              <a:lnSpc>
-                <a:spcPct val="130000"/>
-              </a:lnSpc>
-              <a:buNone/>
-            </a:pPr>
-            <a:r>
-              <a:rPr lang="en-US" sz="800" dirty="0">
-                <a:solidFill>
-                  <a:srgbClr val="1E293B"/>
-                </a:solidFill>
-                <a:latin typeface="Noto Sans KR" pitchFamily="34" charset="0"/>
-                <a:ea typeface="Noto Sans KR" pitchFamily="34" charset="-122"/>
-                <a:cs typeface="Noto Sans KR" pitchFamily="34" charset="-120"/>
-              </a:rPr>
-              <a:t>리턴 구조 포함 여부 및 설치 공간·예산 범위 사전 협의</a:t>
-            </a:r>
-            <a:endParaRPr lang="en-US" sz="800" dirty="0"/>
-          </a:p>
-        </p:txBody>
-      </p:sp>
-      <p:sp>
-        <p:nvSpPr>
-          <p:cNvPr id="46" name="Shape 44"/>
-          <p:cNvSpPr/>
-          <p:nvPr/>
-        </p:nvSpPr>
-        <p:spPr>
-          <a:xfrm>
-            <a:off x="365760" y="4279392"/>
-            <a:ext cx="8412480" cy="749808"/>
+              <a:buNone/>
+            </a:pPr>
+            <a:r>
+              <a:rPr lang="en-US" sz="850" dirty="0">
+                <a:solidFill>
+                  <a:srgbClr val="475569"/>
+                </a:solidFill>
+                <a:latin typeface="Noto Sans KR" pitchFamily="34" charset="0"/>
+                <a:ea typeface="Noto Sans KR" pitchFamily="34" charset="-122"/>
+                <a:cs typeface="Noto Sans KR" pitchFamily="34" charset="-120"/>
+              </a:rPr>
+              <a:t>표준형 + NG 자동 분리 + MES 연동</a:t>
+            </a:r>
+            <a:endParaRPr lang="en-US" sz="850" dirty="0"/>
+          </a:p>
+        </p:txBody>
+      </p:sp>
+      <p:sp>
+        <p:nvSpPr>
+          <p:cNvPr id="39" name="Shape 37"/>
+          <p:cNvSpPr/>
+          <p:nvPr/>
+        </p:nvSpPr>
+        <p:spPr>
+          <a:xfrm>
+            <a:off x="7863840" y="3803904"/>
+            <a:ext cx="749808" cy="274320"/>
           </a:xfrm>
           <a:prstGeom prst="roundRect">
             <a:avLst>
-              <a:gd name="adj" fmla="val 8537"/>
+              <a:gd name="adj" fmla="val 13333"/>
             </a:avLst>
           </a:prstGeom>
           <a:solidFill>
-            <a:srgbClr val="FFFFFF"/>
+            <a:srgbClr val="DC2626"/>
           </a:solidFill>
           <a:ln w="12700">
             <a:solidFill>
-              <a:srgbClr val="059669"/>
+              <a:srgbClr val="DC2626"/>
+            </a:solidFill>
+            <a:prstDash val="solid"/>
+          </a:ln>
+        </p:spPr>
+      </p:sp>
+      <p:sp>
+        <p:nvSpPr>
+          <p:cNvPr id="40" name="Text 38"/>
+          <p:cNvSpPr/>
+          <p:nvPr/>
+        </p:nvSpPr>
+        <p:spPr>
+          <a:xfrm>
+            <a:off x="7863840" y="3803904"/>
+            <a:ext cx="749808" cy="274320"/>
+          </a:xfrm>
+          <a:prstGeom prst="rect">
+            <a:avLst/>
+          </a:prstGeom>
+          <a:noFill/>
+          <a:ln/>
+        </p:spPr>
+        <p:txBody>
+          <a:bodyPr wrap="square" lIns="0" tIns="0" rIns="0" bIns="0" rtlCol="0" anchor="ctr"/>
+          <a:lstStyle/>
+          <a:p>
+            <a:pPr algn="ctr" indent="0" marL="0">
+              <a:buNone/>
+            </a:pPr>
+            <a:r>
+              <a:rPr lang="en-US" sz="850" b="1" dirty="0">
+                <a:solidFill>
+                  <a:srgbClr val="FFFFFF"/>
+                </a:solidFill>
+                <a:latin typeface="Noto Sans KR" pitchFamily="34" charset="0"/>
+                <a:ea typeface="Noto Sans KR" pitchFamily="34" charset="-122"/>
+                <a:cs typeface="Noto Sans KR" pitchFamily="34" charset="-120"/>
+              </a:rPr>
+              <a:t>높음</a:t>
+            </a:r>
+            <a:endParaRPr lang="en-US" sz="850" dirty="0"/>
+          </a:p>
+        </p:txBody>
+      </p:sp>
+      <p:sp>
+        <p:nvSpPr>
+          <p:cNvPr id="41" name="Shape 39"/>
+          <p:cNvSpPr/>
+          <p:nvPr/>
+        </p:nvSpPr>
+        <p:spPr>
+          <a:xfrm>
+            <a:off x="365760" y="4572000"/>
+            <a:ext cx="8412480" cy="402336"/>
+          </a:xfrm>
+          <a:prstGeom prst="roundRect">
+            <a:avLst>
+              <a:gd name="adj" fmla="val 15909"/>
+            </a:avLst>
+          </a:prstGeom>
+          <a:solidFill>
+            <a:srgbClr val="1B2F5E"/>
+          </a:solidFill>
+          <a:ln w="12700">
+            <a:solidFill>
+              <a:srgbClr val="1B2F5E"/>
             </a:solidFill>
             <a:prstDash val="solid"/>
           </a:ln>
@@ -6522,41 +6470,14 @@
       </p:sp>
       <p:sp>
         <p:nvSpPr>
-          <p:cNvPr id="47" name="Shape 45"/>
-          <p:cNvSpPr/>
-          <p:nvPr/>
-        </p:nvSpPr>
-        <p:spPr>
-          <a:xfrm>
-            <a:off x="365760" y="4279392"/>
-            <a:ext cx="475488" cy="749808"/>
-          </a:xfrm>
-          <a:prstGeom prst="roundRect">
-            <a:avLst>
-              <a:gd name="adj" fmla="val 11538"/>
-            </a:avLst>
-          </a:prstGeom>
-          <a:solidFill>
-            <a:srgbClr val="059669"/>
-          </a:solidFill>
-          <a:ln w="12700">
-            <a:solidFill>
-              <a:srgbClr val="059669"/>
-            </a:solidFill>
-            <a:prstDash val="solid"/>
-          </a:ln>
-        </p:spPr>
-      </p:sp>
-      <p:sp>
-        <p:nvSpPr>
-          <p:cNvPr id="48" name="Text 46"/>
-          <p:cNvSpPr/>
-          <p:nvPr/>
-        </p:nvSpPr>
-        <p:spPr>
-          <a:xfrm>
-            <a:off x="365760" y="4279392"/>
-            <a:ext cx="475488" cy="749808"/>
+          <p:cNvPr id="42" name="Text 40"/>
+          <p:cNvSpPr/>
+          <p:nvPr/>
+        </p:nvSpPr>
+        <p:spPr>
+          <a:xfrm>
+            <a:off x="548640" y="4572000"/>
+            <a:ext cx="8046720" cy="402336"/>
           </a:xfrm>
           <a:prstGeom prst="rect">
             <a:avLst/>
@@ -6572,279 +6493,17 @@
               <a:buNone/>
             </a:pPr>
             <a:r>
-              <a:rPr lang="en-US" sz="1100" b="1" dirty="0">
-                <a:solidFill>
-                  <a:srgbClr val="FFFFFF"/>
-                </a:solidFill>
-                <a:latin typeface="Noto Sans KR" pitchFamily="34" charset="0"/>
-                <a:ea typeface="Noto Sans KR" pitchFamily="34" charset="-122"/>
-                <a:cs typeface="Noto Sans KR" pitchFamily="34" charset="-120"/>
-              </a:rPr>
-              <a:t>05</a:t>
-            </a:r>
-            <a:endParaRPr lang="en-US" sz="1100" dirty="0"/>
-          </a:p>
-        </p:txBody>
-      </p:sp>
-      <p:sp>
-        <p:nvSpPr>
-          <p:cNvPr id="49" name="Shape 47"/>
-          <p:cNvSpPr/>
-          <p:nvPr/>
-        </p:nvSpPr>
-        <p:spPr>
-          <a:xfrm>
-            <a:off x="914400" y="4352544"/>
-            <a:ext cx="658368" cy="182880"/>
-          </a:xfrm>
-          <a:prstGeom prst="roundRect">
-            <a:avLst>
-              <a:gd name="adj" fmla="val 20000"/>
-            </a:avLst>
-          </a:prstGeom>
-          <a:solidFill>
-            <a:srgbClr val="D1FAE5"/>
-          </a:solidFill>
-          <a:ln w="6350">
-            <a:solidFill>
-              <a:srgbClr val="059669"/>
-            </a:solidFill>
-            <a:prstDash val="solid"/>
-          </a:ln>
-        </p:spPr>
-      </p:sp>
-      <p:sp>
-        <p:nvSpPr>
-          <p:cNvPr id="50" name="Text 48"/>
-          <p:cNvSpPr/>
-          <p:nvPr/>
-        </p:nvSpPr>
-        <p:spPr>
-          <a:xfrm>
-            <a:off x="914400" y="4352544"/>
-            <a:ext cx="658368" cy="182880"/>
-          </a:xfrm>
-          <a:prstGeom prst="rect">
-            <a:avLst/>
-          </a:prstGeom>
-          <a:noFill/>
-          <a:ln/>
-        </p:spPr>
-        <p:txBody>
-          <a:bodyPr wrap="square" lIns="0" tIns="0" rIns="0" bIns="0" rtlCol="0" anchor="ctr"/>
-          <a:lstStyle/>
-          <a:p>
-            <a:pPr algn="ctr" indent="0" marL="0">
-              <a:buNone/>
-            </a:pPr>
-            <a:r>
-              <a:rPr lang="en-US" sz="650" b="1" dirty="0">
-                <a:solidFill>
-                  <a:srgbClr val="059669"/>
-                </a:solidFill>
-                <a:latin typeface="Noto Sans KR" pitchFamily="34" charset="0"/>
-                <a:ea typeface="Noto Sans KR" pitchFamily="34" charset="-122"/>
-                <a:cs typeface="Noto Sans KR" pitchFamily="34" charset="-120"/>
-              </a:rPr>
-              <a:t>데이터 협조</a:t>
-            </a:r>
-            <a:endParaRPr lang="en-US" sz="650" dirty="0"/>
-          </a:p>
-        </p:txBody>
-      </p:sp>
-      <p:sp>
-        <p:nvSpPr>
-          <p:cNvPr id="51" name="Text 49"/>
-          <p:cNvSpPr/>
-          <p:nvPr/>
-        </p:nvSpPr>
-        <p:spPr>
-          <a:xfrm>
-            <a:off x="914400" y="4553712"/>
-            <a:ext cx="4572000" cy="237744"/>
-          </a:xfrm>
-          <a:prstGeom prst="rect">
-            <a:avLst/>
-          </a:prstGeom>
-          <a:noFill/>
-          <a:ln/>
-        </p:spPr>
-        <p:txBody>
-          <a:bodyPr wrap="square" lIns="0" tIns="0" rIns="0" bIns="0" rtlCol="0" anchor="ctr"/>
-          <a:lstStyle/>
-          <a:p>
-            <a:pPr indent="0" marL="0">
-              <a:buNone/>
-            </a:pPr>
-            <a:r>
-              <a:rPr lang="en-US" sz="950" b="1" dirty="0">
-                <a:solidFill>
-                  <a:srgbClr val="1B2F5E"/>
-                </a:solidFill>
-                <a:latin typeface="Noto Sans KR" pitchFamily="34" charset="0"/>
-                <a:ea typeface="Noto Sans KR" pitchFamily="34" charset="-122"/>
-                <a:cs typeface="Noto Sans KR" pitchFamily="34" charset="-120"/>
-              </a:rPr>
-              <a:t>기존 육안검사 경험 데이터의 딥러닝 학습 적용</a:t>
-            </a:r>
-            <a:endParaRPr lang="en-US" sz="950" dirty="0"/>
-          </a:p>
-        </p:txBody>
-      </p:sp>
-      <p:sp>
-        <p:nvSpPr>
-          <p:cNvPr id="52" name="Text 50"/>
-          <p:cNvSpPr/>
-          <p:nvPr/>
-        </p:nvSpPr>
-        <p:spPr>
-          <a:xfrm>
-            <a:off x="914400" y="4773168"/>
-            <a:ext cx="4572000" cy="237744"/>
-          </a:xfrm>
-          <a:prstGeom prst="rect">
-            <a:avLst/>
-          </a:prstGeom>
-          <a:noFill/>
-          <a:ln/>
-        </p:spPr>
-        <p:txBody>
-          <a:bodyPr wrap="square" lIns="0" tIns="0" rIns="0" bIns="0" rtlCol="0" anchor="ctr"/>
-          <a:lstStyle/>
-          <a:p>
-            <a:pPr indent="0" marL="0">
-              <a:lnSpc>
-                <a:spcPct val="110000"/>
-              </a:lnSpc>
-              <a:buNone/>
-            </a:pPr>
-            <a:r>
-              <a:rPr lang="en-US" sz="750" dirty="0">
-                <a:solidFill>
-                  <a:srgbClr val="475569"/>
-                </a:solidFill>
-                <a:latin typeface="Noto Sans KR" pitchFamily="34" charset="0"/>
-                <a:ea typeface="Noto Sans KR" pitchFamily="34" charset="-122"/>
-                <a:cs typeface="Noto Sans KR" pitchFamily="34" charset="-120"/>
-              </a:rPr>
-              <a:t>비전검사기 도입 이전 검사원들이 육안으로 판별하며 축적한 불량 사례·판정 기준 데이터를 딥러닝 초기 학습에 활용하면 검출 정확도를 빠르게 높일 수 있습니다. 학습 데이터가 많을수록 도입 초기 성능이 향상됩니다.</a:t>
-            </a:r>
-            <a:endParaRPr lang="en-US" sz="750" dirty="0"/>
-          </a:p>
-        </p:txBody>
-      </p:sp>
-      <p:sp>
-        <p:nvSpPr>
-          <p:cNvPr id="53" name="Shape 51"/>
-          <p:cNvSpPr/>
-          <p:nvPr/>
-        </p:nvSpPr>
-        <p:spPr>
-          <a:xfrm>
-            <a:off x="5943600" y="4334256"/>
-            <a:ext cx="2834640" cy="640080"/>
-          </a:xfrm>
-          <a:prstGeom prst="roundRect">
-            <a:avLst>
-              <a:gd name="adj" fmla="val 10000"/>
-            </a:avLst>
-          </a:prstGeom>
-          <a:solidFill>
-            <a:srgbClr val="D1FAE5"/>
-          </a:solidFill>
-          <a:ln w="12700">
-            <a:solidFill>
-              <a:srgbClr val="D1FAE5"/>
-            </a:solidFill>
-            <a:prstDash val="solid"/>
-          </a:ln>
-          <a:effectLst>
-            <a:outerShdw sx="100000" sy="100000" kx="0" ky="0" algn="bl" rotWithShape="0" blurRad="50800" dist="25400" dir="16200000">
-              <a:srgbClr val="9CA3AF">
-                <a:alpha val="15000"/>
-              </a:srgbClr>
-            </a:outerShdw>
-          </a:effectLst>
-        </p:spPr>
-      </p:sp>
-      <p:sp>
-        <p:nvSpPr>
-          <p:cNvPr id="54" name="Text 52"/>
-          <p:cNvSpPr/>
-          <p:nvPr/>
-        </p:nvSpPr>
-        <p:spPr>
-          <a:xfrm>
-            <a:off x="6035040" y="4370832"/>
-            <a:ext cx="2706624" cy="182880"/>
-          </a:xfrm>
-          <a:prstGeom prst="rect">
-            <a:avLst/>
-          </a:prstGeom>
-          <a:noFill/>
-          <a:ln/>
-        </p:spPr>
-        <p:txBody>
-          <a:bodyPr wrap="square" lIns="0" tIns="0" rIns="0" bIns="0" rtlCol="0" anchor="ctr"/>
-          <a:lstStyle/>
-          <a:p>
-            <a:pPr indent="0" marL="0">
-              <a:buNone/>
-            </a:pPr>
-            <a:r>
-              <a:rPr lang="en-US" sz="750" b="1" dirty="0">
-                <a:solidFill>
-                  <a:srgbClr val="059669"/>
-                </a:solidFill>
-                <a:latin typeface="Noto Sans KR" pitchFamily="34" charset="0"/>
-                <a:ea typeface="Noto Sans KR" pitchFamily="34" charset="-122"/>
-                <a:cs typeface="Noto Sans KR" pitchFamily="34" charset="-120"/>
-              </a:rPr>
-              <a:t>💬 협의 요청</a:t>
-            </a:r>
-            <a:endParaRPr lang="en-US" sz="750" dirty="0"/>
-          </a:p>
-        </p:txBody>
-      </p:sp>
-      <p:sp>
-        <p:nvSpPr>
-          <p:cNvPr id="55" name="Text 53"/>
-          <p:cNvSpPr/>
-          <p:nvPr/>
-        </p:nvSpPr>
-        <p:spPr>
-          <a:xfrm>
-            <a:off x="6035040" y="4553712"/>
-            <a:ext cx="2706624" cy="438912"/>
-          </a:xfrm>
-          <a:prstGeom prst="rect">
-            <a:avLst/>
-          </a:prstGeom>
-          <a:noFill/>
-          <a:ln/>
-        </p:spPr>
-        <p:txBody>
-          <a:bodyPr wrap="square" lIns="0" tIns="0" rIns="0" bIns="0" rtlCol="0" anchor="ctr"/>
-          <a:lstStyle/>
-          <a:p>
-            <a:pPr indent="0" marL="0">
-              <a:lnSpc>
-                <a:spcPct val="130000"/>
-              </a:lnSpc>
-              <a:buNone/>
-            </a:pPr>
-            <a:r>
-              <a:rPr lang="en-US" sz="800" dirty="0">
-                <a:solidFill>
-                  <a:srgbClr val="1E293B"/>
-                </a:solidFill>
-                <a:latin typeface="Noto Sans KR" pitchFamily="34" charset="0"/>
-                <a:ea typeface="Noto Sans KR" pitchFamily="34" charset="-122"/>
-                <a:cs typeface="Noto Sans KR" pitchFamily="34" charset="-120"/>
-              </a:rPr>
-              <a:t>기존 불량 이미지·판정 이력 데이터 제공 여부 및 범위 협의</a:t>
-            </a:r>
-            <a:endParaRPr lang="en-US" sz="800" dirty="0"/>
+              <a:rPr lang="en-US" sz="1000" b="1" dirty="0">
+                <a:solidFill>
+                  <a:srgbClr val="A5C4F3"/>
+                </a:solidFill>
+                <a:latin typeface="Noto Sans KR" pitchFamily="34" charset="0"/>
+                <a:ea typeface="Noto Sans KR" pitchFamily="34" charset="-122"/>
+                <a:cs typeface="Noto Sans KR" pitchFamily="34" charset="-120"/>
+              </a:rPr>
+              <a:t>검증기로 부담 없이 시작  →  검증 후 필요한 기능만 선택하여 양산형으로 전환  →  기능 범위에 따라 임대료 조정</a:t>
+            </a:r>
+            <a:endParaRPr lang="en-US" sz="1000" dirty="0"/>
           </a:p>
         </p:txBody>
       </p:sp>
@@ -6888,6 +6547,1969 @@
             <a:avLst/>
           </a:prstGeom>
           <a:solidFill>
+            <a:srgbClr val="F8FAFC"/>
+          </a:solidFill>
+          <a:ln w="12700">
+            <a:solidFill>
+              <a:srgbClr val="F8FAFC"/>
+            </a:solidFill>
+            <a:prstDash val="solid"/>
+          </a:ln>
+        </p:spPr>
+      </p:sp>
+      <p:sp>
+        <p:nvSpPr>
+          <p:cNvPr id="3" name="Shape 1"/>
+          <p:cNvSpPr/>
+          <p:nvPr/>
+        </p:nvSpPr>
+        <p:spPr>
+          <a:xfrm>
+            <a:off x="0" y="0"/>
+            <a:ext cx="9144000" cy="1005840"/>
+          </a:xfrm>
+          <a:prstGeom prst="rect">
+            <a:avLst/>
+          </a:prstGeom>
+          <a:solidFill>
+            <a:srgbClr val="1B2F5E"/>
+          </a:solidFill>
+          <a:ln w="12700">
+            <a:solidFill>
+              <a:srgbClr val="1B2F5E"/>
+            </a:solidFill>
+            <a:prstDash val="solid"/>
+          </a:ln>
+        </p:spPr>
+      </p:sp>
+      <p:sp>
+        <p:nvSpPr>
+          <p:cNvPr id="4" name="Text 2"/>
+          <p:cNvSpPr/>
+          <p:nvPr/>
+        </p:nvSpPr>
+        <p:spPr>
+          <a:xfrm>
+            <a:off x="365760" y="237744"/>
+            <a:ext cx="8412480" cy="475488"/>
+          </a:xfrm>
+          <a:prstGeom prst="rect">
+            <a:avLst/>
+          </a:prstGeom>
+          <a:noFill/>
+          <a:ln/>
+        </p:spPr>
+        <p:txBody>
+          <a:bodyPr wrap="square" lIns="0" tIns="0" rIns="0" bIns="0" rtlCol="0" anchor="ctr"/>
+          <a:lstStyle/>
+          <a:p>
+            <a:pPr indent="0" marL="0">
+              <a:buNone/>
+            </a:pPr>
+            <a:r>
+              <a:rPr lang="en-US" sz="2200" b="1" dirty="0">
+                <a:solidFill>
+                  <a:srgbClr val="FFFFFF"/>
+                </a:solidFill>
+                <a:latin typeface="Noto Sans KR" pitchFamily="34" charset="0"/>
+                <a:ea typeface="Noto Sans KR" pitchFamily="34" charset="-122"/>
+                <a:cs typeface="Noto Sans KR" pitchFamily="34" charset="-120"/>
+              </a:rPr>
+              <a:t>예상 문제점 및 협의 사항</a:t>
+            </a:r>
+            <a:endParaRPr lang="en-US" sz="2200" dirty="0"/>
+          </a:p>
+        </p:txBody>
+      </p:sp>
+      <p:sp>
+        <p:nvSpPr>
+          <p:cNvPr id="5" name="Text 3"/>
+          <p:cNvSpPr/>
+          <p:nvPr/>
+        </p:nvSpPr>
+        <p:spPr>
+          <a:xfrm>
+            <a:off x="365760" y="713232"/>
+            <a:ext cx="8412480" cy="237744"/>
+          </a:xfrm>
+          <a:prstGeom prst="rect">
+            <a:avLst/>
+          </a:prstGeom>
+          <a:noFill/>
+          <a:ln/>
+        </p:spPr>
+        <p:txBody>
+          <a:bodyPr wrap="square" lIns="0" tIns="0" rIns="0" bIns="0" rtlCol="0" anchor="ctr"/>
+          <a:lstStyle/>
+          <a:p>
+            <a:pPr indent="0" marL="0">
+              <a:buNone/>
+            </a:pPr>
+            <a:r>
+              <a:rPr lang="en-US" sz="1050" dirty="0">
+                <a:solidFill>
+                  <a:srgbClr val="A5C4F3"/>
+                </a:solidFill>
+                <a:latin typeface="Noto Sans KR" pitchFamily="34" charset="0"/>
+                <a:ea typeface="Noto Sans KR" pitchFamily="34" charset="-122"/>
+                <a:cs typeface="Noto Sans KR" pitchFamily="34" charset="-120"/>
+              </a:rPr>
+              <a:t>현장 적용 전 사전 검토가 필요한 항목입니다</a:t>
+            </a:r>
+            <a:endParaRPr lang="en-US" sz="1050" dirty="0"/>
+          </a:p>
+        </p:txBody>
+      </p:sp>
+      <p:sp>
+        <p:nvSpPr>
+          <p:cNvPr id="6" name="Shape 4"/>
+          <p:cNvSpPr/>
+          <p:nvPr/>
+        </p:nvSpPr>
+        <p:spPr>
+          <a:xfrm>
+            <a:off x="365760" y="1078992"/>
+            <a:ext cx="8412480" cy="749808"/>
+          </a:xfrm>
+          <a:prstGeom prst="roundRect">
+            <a:avLst>
+              <a:gd name="adj" fmla="val 8537"/>
+            </a:avLst>
+          </a:prstGeom>
+          <a:solidFill>
+            <a:srgbClr val="FFFFFF"/>
+          </a:solidFill>
+          <a:ln w="12700">
+            <a:solidFill>
+              <a:srgbClr val="2563EB"/>
+            </a:solidFill>
+            <a:prstDash val="solid"/>
+          </a:ln>
+          <a:effectLst>
+            <a:outerShdw sx="100000" sy="100000" kx="0" ky="0" algn="bl" rotWithShape="0" blurRad="50800" dist="25400" dir="16200000">
+              <a:srgbClr val="9CA3AF">
+                <a:alpha val="15000"/>
+              </a:srgbClr>
+            </a:outerShdw>
+          </a:effectLst>
+        </p:spPr>
+      </p:sp>
+      <p:sp>
+        <p:nvSpPr>
+          <p:cNvPr id="7" name="Shape 5"/>
+          <p:cNvSpPr/>
+          <p:nvPr/>
+        </p:nvSpPr>
+        <p:spPr>
+          <a:xfrm>
+            <a:off x="365760" y="1078992"/>
+            <a:ext cx="475488" cy="749808"/>
+          </a:xfrm>
+          <a:prstGeom prst="roundRect">
+            <a:avLst>
+              <a:gd name="adj" fmla="val 11538"/>
+            </a:avLst>
+          </a:prstGeom>
+          <a:solidFill>
+            <a:srgbClr val="2563EB"/>
+          </a:solidFill>
+          <a:ln w="12700">
+            <a:solidFill>
+              <a:srgbClr val="2563EB"/>
+            </a:solidFill>
+            <a:prstDash val="solid"/>
+          </a:ln>
+        </p:spPr>
+      </p:sp>
+      <p:sp>
+        <p:nvSpPr>
+          <p:cNvPr id="8" name="Text 6"/>
+          <p:cNvSpPr/>
+          <p:nvPr/>
+        </p:nvSpPr>
+        <p:spPr>
+          <a:xfrm>
+            <a:off x="365760" y="1078992"/>
+            <a:ext cx="475488" cy="749808"/>
+          </a:xfrm>
+          <a:prstGeom prst="rect">
+            <a:avLst/>
+          </a:prstGeom>
+          <a:noFill/>
+          <a:ln/>
+        </p:spPr>
+        <p:txBody>
+          <a:bodyPr wrap="square" lIns="0" tIns="0" rIns="0" bIns="0" rtlCol="0" anchor="ctr"/>
+          <a:lstStyle/>
+          <a:p>
+            <a:pPr algn="ctr" indent="0" marL="0">
+              <a:buNone/>
+            </a:pPr>
+            <a:r>
+              <a:rPr lang="en-US" sz="1100" b="1" dirty="0">
+                <a:solidFill>
+                  <a:srgbClr val="FFFFFF"/>
+                </a:solidFill>
+                <a:latin typeface="Noto Sans KR" pitchFamily="34" charset="0"/>
+                <a:ea typeface="Noto Sans KR" pitchFamily="34" charset="-122"/>
+                <a:cs typeface="Noto Sans KR" pitchFamily="34" charset="-120"/>
+              </a:rPr>
+              <a:t>01</a:t>
+            </a:r>
+            <a:endParaRPr lang="en-US" sz="1100" dirty="0"/>
+          </a:p>
+        </p:txBody>
+      </p:sp>
+      <p:sp>
+        <p:nvSpPr>
+          <p:cNvPr id="9" name="Shape 7"/>
+          <p:cNvSpPr/>
+          <p:nvPr/>
+        </p:nvSpPr>
+        <p:spPr>
+          <a:xfrm>
+            <a:off x="914400" y="1152144"/>
+            <a:ext cx="658368" cy="182880"/>
+          </a:xfrm>
+          <a:prstGeom prst="roundRect">
+            <a:avLst>
+              <a:gd name="adj" fmla="val 20000"/>
+            </a:avLst>
+          </a:prstGeom>
+          <a:solidFill>
+            <a:srgbClr val="DBEAFE"/>
+          </a:solidFill>
+          <a:ln w="6350">
+            <a:solidFill>
+              <a:srgbClr val="2563EB"/>
+            </a:solidFill>
+            <a:prstDash val="solid"/>
+          </a:ln>
+        </p:spPr>
+      </p:sp>
+      <p:sp>
+        <p:nvSpPr>
+          <p:cNvPr id="10" name="Text 8"/>
+          <p:cNvSpPr/>
+          <p:nvPr/>
+        </p:nvSpPr>
+        <p:spPr>
+          <a:xfrm>
+            <a:off x="914400" y="1152144"/>
+            <a:ext cx="658368" cy="182880"/>
+          </a:xfrm>
+          <a:prstGeom prst="rect">
+            <a:avLst/>
+          </a:prstGeom>
+          <a:noFill/>
+          <a:ln/>
+        </p:spPr>
+        <p:txBody>
+          <a:bodyPr wrap="square" lIns="0" tIns="0" rIns="0" bIns="0" rtlCol="0" anchor="ctr"/>
+          <a:lstStyle/>
+          <a:p>
+            <a:pPr algn="ctr" indent="0" marL="0">
+              <a:buNone/>
+            </a:pPr>
+            <a:r>
+              <a:rPr lang="en-US" sz="650" b="1" dirty="0">
+                <a:solidFill>
+                  <a:srgbClr val="2563EB"/>
+                </a:solidFill>
+                <a:latin typeface="Noto Sans KR" pitchFamily="34" charset="0"/>
+                <a:ea typeface="Noto Sans KR" pitchFamily="34" charset="-122"/>
+                <a:cs typeface="Noto Sans KR" pitchFamily="34" charset="-120"/>
+              </a:rPr>
+              <a:t>기구·지그</a:t>
+            </a:r>
+            <a:endParaRPr lang="en-US" sz="650" dirty="0"/>
+          </a:p>
+        </p:txBody>
+      </p:sp>
+      <p:sp>
+        <p:nvSpPr>
+          <p:cNvPr id="11" name="Text 9"/>
+          <p:cNvSpPr/>
+          <p:nvPr/>
+        </p:nvSpPr>
+        <p:spPr>
+          <a:xfrm>
+            <a:off x="914400" y="1353312"/>
+            <a:ext cx="4572000" cy="237744"/>
+          </a:xfrm>
+          <a:prstGeom prst="rect">
+            <a:avLst/>
+          </a:prstGeom>
+          <a:noFill/>
+          <a:ln/>
+        </p:spPr>
+        <p:txBody>
+          <a:bodyPr wrap="square" lIns="0" tIns="0" rIns="0" bIns="0" rtlCol="0" anchor="ctr"/>
+          <a:lstStyle/>
+          <a:p>
+            <a:pPr indent="0" marL="0">
+              <a:buNone/>
+            </a:pPr>
+            <a:r>
+              <a:rPr lang="en-US" sz="950" b="1" dirty="0">
+                <a:solidFill>
+                  <a:srgbClr val="1B2F5E"/>
+                </a:solidFill>
+                <a:latin typeface="Noto Sans KR" pitchFamily="34" charset="0"/>
+                <a:ea typeface="Noto Sans KR" pitchFamily="34" charset="-122"/>
+                <a:cs typeface="Noto Sans KR" pitchFamily="34" charset="-120"/>
+              </a:rPr>
+              <a:t>PCB 연결 케이블 형태 균일화 및 바코드 위치 표준화</a:t>
+            </a:r>
+            <a:endParaRPr lang="en-US" sz="950" dirty="0"/>
+          </a:p>
+        </p:txBody>
+      </p:sp>
+      <p:sp>
+        <p:nvSpPr>
+          <p:cNvPr id="12" name="Text 10"/>
+          <p:cNvSpPr/>
+          <p:nvPr/>
+        </p:nvSpPr>
+        <p:spPr>
+          <a:xfrm>
+            <a:off x="914400" y="1572768"/>
+            <a:ext cx="4572000" cy="237744"/>
+          </a:xfrm>
+          <a:prstGeom prst="rect">
+            <a:avLst/>
+          </a:prstGeom>
+          <a:noFill/>
+          <a:ln/>
+        </p:spPr>
+        <p:txBody>
+          <a:bodyPr wrap="square" lIns="0" tIns="0" rIns="0" bIns="0" rtlCol="0" anchor="ctr"/>
+          <a:lstStyle/>
+          <a:p>
+            <a:pPr indent="0" marL="0">
+              <a:lnSpc>
+                <a:spcPct val="110000"/>
+              </a:lnSpc>
+              <a:buNone/>
+            </a:pPr>
+            <a:r>
+              <a:rPr lang="en-US" sz="750" dirty="0">
+                <a:solidFill>
+                  <a:srgbClr val="475569"/>
+                </a:solidFill>
+                <a:latin typeface="Noto Sans KR" pitchFamily="34" charset="0"/>
+                <a:ea typeface="Noto Sans KR" pitchFamily="34" charset="-122"/>
+                <a:cs typeface="Noto Sans KR" pitchFamily="34" charset="-120"/>
+              </a:rPr>
+              <a:t>케이블이 PCB와 연결된 상태에서 형태가 일정하지 않으면 지그 안착 불량 및 촬영 위치 오차가 발생할 수 있습니다. 또한 바코드 부착 위치가 개체마다 다를 경우 고정식 스캐너 인식률이 저하됩니다.</a:t>
+            </a:r>
+            <a:endParaRPr lang="en-US" sz="750" dirty="0"/>
+          </a:p>
+        </p:txBody>
+      </p:sp>
+      <p:sp>
+        <p:nvSpPr>
+          <p:cNvPr id="13" name="Shape 11"/>
+          <p:cNvSpPr/>
+          <p:nvPr/>
+        </p:nvSpPr>
+        <p:spPr>
+          <a:xfrm>
+            <a:off x="5943600" y="1133856"/>
+            <a:ext cx="2834640" cy="640080"/>
+          </a:xfrm>
+          <a:prstGeom prst="roundRect">
+            <a:avLst>
+              <a:gd name="adj" fmla="val 10000"/>
+            </a:avLst>
+          </a:prstGeom>
+          <a:solidFill>
+            <a:srgbClr val="DBEAFE"/>
+          </a:solidFill>
+          <a:ln w="12700">
+            <a:solidFill>
+              <a:srgbClr val="DBEAFE"/>
+            </a:solidFill>
+            <a:prstDash val="solid"/>
+          </a:ln>
+          <a:effectLst>
+            <a:outerShdw sx="100000" sy="100000" kx="0" ky="0" algn="bl" rotWithShape="0" blurRad="50800" dist="25400" dir="16200000">
+              <a:srgbClr val="9CA3AF">
+                <a:alpha val="15000"/>
+              </a:srgbClr>
+            </a:outerShdw>
+          </a:effectLst>
+        </p:spPr>
+      </p:sp>
+      <p:sp>
+        <p:nvSpPr>
+          <p:cNvPr id="14" name="Text 12"/>
+          <p:cNvSpPr/>
+          <p:nvPr/>
+        </p:nvSpPr>
+        <p:spPr>
+          <a:xfrm>
+            <a:off x="6035040" y="1170432"/>
+            <a:ext cx="2706624" cy="182880"/>
+          </a:xfrm>
+          <a:prstGeom prst="rect">
+            <a:avLst/>
+          </a:prstGeom>
+          <a:noFill/>
+          <a:ln/>
+        </p:spPr>
+        <p:txBody>
+          <a:bodyPr wrap="square" lIns="0" tIns="0" rIns="0" bIns="0" rtlCol="0" anchor="ctr"/>
+          <a:lstStyle/>
+          <a:p>
+            <a:pPr indent="0" marL="0">
+              <a:buNone/>
+            </a:pPr>
+            <a:r>
+              <a:rPr lang="en-US" sz="750" b="1" dirty="0">
+                <a:solidFill>
+                  <a:srgbClr val="2563EB"/>
+                </a:solidFill>
+                <a:latin typeface="Noto Sans KR" pitchFamily="34" charset="0"/>
+                <a:ea typeface="Noto Sans KR" pitchFamily="34" charset="-122"/>
+                <a:cs typeface="Noto Sans KR" pitchFamily="34" charset="-120"/>
+              </a:rPr>
+              <a:t>💬 협의 요청</a:t>
+            </a:r>
+            <a:endParaRPr lang="en-US" sz="750" dirty="0"/>
+          </a:p>
+        </p:txBody>
+      </p:sp>
+      <p:sp>
+        <p:nvSpPr>
+          <p:cNvPr id="15" name="Text 13"/>
+          <p:cNvSpPr/>
+          <p:nvPr/>
+        </p:nvSpPr>
+        <p:spPr>
+          <a:xfrm>
+            <a:off x="6035040" y="1353312"/>
+            <a:ext cx="2706624" cy="438912"/>
+          </a:xfrm>
+          <a:prstGeom prst="rect">
+            <a:avLst/>
+          </a:prstGeom>
+          <a:noFill/>
+          <a:ln/>
+        </p:spPr>
+        <p:txBody>
+          <a:bodyPr wrap="square" lIns="0" tIns="0" rIns="0" bIns="0" rtlCol="0" anchor="ctr"/>
+          <a:lstStyle/>
+          <a:p>
+            <a:pPr indent="0" marL="0">
+              <a:lnSpc>
+                <a:spcPct val="130000"/>
+              </a:lnSpc>
+              <a:buNone/>
+            </a:pPr>
+            <a:r>
+              <a:rPr lang="en-US" sz="800" dirty="0">
+                <a:solidFill>
+                  <a:srgbClr val="1E293B"/>
+                </a:solidFill>
+                <a:latin typeface="Noto Sans KR" pitchFamily="34" charset="0"/>
+                <a:ea typeface="Noto Sans KR" pitchFamily="34" charset="-122"/>
+                <a:cs typeface="Noto Sans KR" pitchFamily="34" charset="-120"/>
+              </a:rPr>
+              <a:t>케이블 정형화 가능 여부 및 바코드 부착 위치 표준화 협의</a:t>
+            </a:r>
+            <a:endParaRPr lang="en-US" sz="800" dirty="0"/>
+          </a:p>
+        </p:txBody>
+      </p:sp>
+      <p:sp>
+        <p:nvSpPr>
+          <p:cNvPr id="16" name="Shape 14"/>
+          <p:cNvSpPr/>
+          <p:nvPr/>
+        </p:nvSpPr>
+        <p:spPr>
+          <a:xfrm>
+            <a:off x="365760" y="1879092"/>
+            <a:ext cx="8412480" cy="749808"/>
+          </a:xfrm>
+          <a:prstGeom prst="roundRect">
+            <a:avLst>
+              <a:gd name="adj" fmla="val 8537"/>
+            </a:avLst>
+          </a:prstGeom>
+          <a:solidFill>
+            <a:srgbClr val="FFFFFF"/>
+          </a:solidFill>
+          <a:ln w="12700">
+            <a:solidFill>
+              <a:srgbClr val="7C3AED"/>
+            </a:solidFill>
+            <a:prstDash val="solid"/>
+          </a:ln>
+          <a:effectLst>
+            <a:outerShdw sx="100000" sy="100000" kx="0" ky="0" algn="bl" rotWithShape="0" blurRad="50800" dist="25400" dir="16200000">
+              <a:srgbClr val="9CA3AF">
+                <a:alpha val="15000"/>
+              </a:srgbClr>
+            </a:outerShdw>
+          </a:effectLst>
+        </p:spPr>
+      </p:sp>
+      <p:sp>
+        <p:nvSpPr>
+          <p:cNvPr id="17" name="Shape 15"/>
+          <p:cNvSpPr/>
+          <p:nvPr/>
+        </p:nvSpPr>
+        <p:spPr>
+          <a:xfrm>
+            <a:off x="365760" y="1879092"/>
+            <a:ext cx="475488" cy="749808"/>
+          </a:xfrm>
+          <a:prstGeom prst="roundRect">
+            <a:avLst>
+              <a:gd name="adj" fmla="val 11538"/>
+            </a:avLst>
+          </a:prstGeom>
+          <a:solidFill>
+            <a:srgbClr val="7C3AED"/>
+          </a:solidFill>
+          <a:ln w="12700">
+            <a:solidFill>
+              <a:srgbClr val="7C3AED"/>
+            </a:solidFill>
+            <a:prstDash val="solid"/>
+          </a:ln>
+        </p:spPr>
+      </p:sp>
+      <p:sp>
+        <p:nvSpPr>
+          <p:cNvPr id="18" name="Text 16"/>
+          <p:cNvSpPr/>
+          <p:nvPr/>
+        </p:nvSpPr>
+        <p:spPr>
+          <a:xfrm>
+            <a:off x="365760" y="1879092"/>
+            <a:ext cx="475488" cy="749808"/>
+          </a:xfrm>
+          <a:prstGeom prst="rect">
+            <a:avLst/>
+          </a:prstGeom>
+          <a:noFill/>
+          <a:ln/>
+        </p:spPr>
+        <p:txBody>
+          <a:bodyPr wrap="square" lIns="0" tIns="0" rIns="0" bIns="0" rtlCol="0" anchor="ctr"/>
+          <a:lstStyle/>
+          <a:p>
+            <a:pPr algn="ctr" indent="0" marL="0">
+              <a:buNone/>
+            </a:pPr>
+            <a:r>
+              <a:rPr lang="en-US" sz="1100" b="1" dirty="0">
+                <a:solidFill>
+                  <a:srgbClr val="FFFFFF"/>
+                </a:solidFill>
+                <a:latin typeface="Noto Sans KR" pitchFamily="34" charset="0"/>
+                <a:ea typeface="Noto Sans KR" pitchFamily="34" charset="-122"/>
+                <a:cs typeface="Noto Sans KR" pitchFamily="34" charset="-120"/>
+              </a:rPr>
+              <a:t>02</a:t>
+            </a:r>
+            <a:endParaRPr lang="en-US" sz="1100" dirty="0"/>
+          </a:p>
+        </p:txBody>
+      </p:sp>
+      <p:sp>
+        <p:nvSpPr>
+          <p:cNvPr id="19" name="Shape 17"/>
+          <p:cNvSpPr/>
+          <p:nvPr/>
+        </p:nvSpPr>
+        <p:spPr>
+          <a:xfrm>
+            <a:off x="914400" y="1952244"/>
+            <a:ext cx="658368" cy="182880"/>
+          </a:xfrm>
+          <a:prstGeom prst="roundRect">
+            <a:avLst>
+              <a:gd name="adj" fmla="val 20000"/>
+            </a:avLst>
+          </a:prstGeom>
+          <a:solidFill>
+            <a:srgbClr val="EDE9FE"/>
+          </a:solidFill>
+          <a:ln w="6350">
+            <a:solidFill>
+              <a:srgbClr val="7C3AED"/>
+            </a:solidFill>
+            <a:prstDash val="solid"/>
+          </a:ln>
+        </p:spPr>
+      </p:sp>
+      <p:sp>
+        <p:nvSpPr>
+          <p:cNvPr id="20" name="Text 18"/>
+          <p:cNvSpPr/>
+          <p:nvPr/>
+        </p:nvSpPr>
+        <p:spPr>
+          <a:xfrm>
+            <a:off x="914400" y="1952244"/>
+            <a:ext cx="658368" cy="182880"/>
+          </a:xfrm>
+          <a:prstGeom prst="rect">
+            <a:avLst/>
+          </a:prstGeom>
+          <a:noFill/>
+          <a:ln/>
+        </p:spPr>
+        <p:txBody>
+          <a:bodyPr wrap="square" lIns="0" tIns="0" rIns="0" bIns="0" rtlCol="0" anchor="ctr"/>
+          <a:lstStyle/>
+          <a:p>
+            <a:pPr algn="ctr" indent="0" marL="0">
+              <a:buNone/>
+            </a:pPr>
+            <a:r>
+              <a:rPr lang="en-US" sz="650" b="1" dirty="0">
+                <a:solidFill>
+                  <a:srgbClr val="7C3AED"/>
+                </a:solidFill>
+                <a:latin typeface="Noto Sans KR" pitchFamily="34" charset="0"/>
+                <a:ea typeface="Noto Sans KR" pitchFamily="34" charset="-122"/>
+                <a:cs typeface="Noto Sans KR" pitchFamily="34" charset="-120"/>
+              </a:rPr>
+              <a:t>지그 운용</a:t>
+            </a:r>
+            <a:endParaRPr lang="en-US" sz="650" dirty="0"/>
+          </a:p>
+        </p:txBody>
+      </p:sp>
+      <p:sp>
+        <p:nvSpPr>
+          <p:cNvPr id="21" name="Text 19"/>
+          <p:cNvSpPr/>
+          <p:nvPr/>
+        </p:nvSpPr>
+        <p:spPr>
+          <a:xfrm>
+            <a:off x="914400" y="2153412"/>
+            <a:ext cx="4572000" cy="237744"/>
+          </a:xfrm>
+          <a:prstGeom prst="rect">
+            <a:avLst/>
+          </a:prstGeom>
+          <a:noFill/>
+          <a:ln/>
+        </p:spPr>
+        <p:txBody>
+          <a:bodyPr wrap="square" lIns="0" tIns="0" rIns="0" bIns="0" rtlCol="0" anchor="ctr"/>
+          <a:lstStyle/>
+          <a:p>
+            <a:pPr indent="0" marL="0">
+              <a:buNone/>
+            </a:pPr>
+            <a:r>
+              <a:rPr lang="en-US" sz="950" b="1" dirty="0">
+                <a:solidFill>
+                  <a:srgbClr val="1B2F5E"/>
+                </a:solidFill>
+                <a:latin typeface="Noto Sans KR" pitchFamily="34" charset="0"/>
+                <a:ea typeface="Noto Sans KR" pitchFamily="34" charset="-122"/>
+                <a:cs typeface="Noto Sans KR" pitchFamily="34" charset="-120"/>
+              </a:rPr>
+              <a:t>흐름 라인에서 안착 지그 회수 방법</a:t>
+            </a:r>
+            <a:endParaRPr lang="en-US" sz="950" dirty="0"/>
+          </a:p>
+        </p:txBody>
+      </p:sp>
+      <p:sp>
+        <p:nvSpPr>
+          <p:cNvPr id="22" name="Text 20"/>
+          <p:cNvSpPr/>
+          <p:nvPr/>
+        </p:nvSpPr>
+        <p:spPr>
+          <a:xfrm>
+            <a:off x="914400" y="2372868"/>
+            <a:ext cx="4572000" cy="237744"/>
+          </a:xfrm>
+          <a:prstGeom prst="rect">
+            <a:avLst/>
+          </a:prstGeom>
+          <a:noFill/>
+          <a:ln/>
+        </p:spPr>
+        <p:txBody>
+          <a:bodyPr wrap="square" lIns="0" tIns="0" rIns="0" bIns="0" rtlCol="0" anchor="ctr"/>
+          <a:lstStyle/>
+          <a:p>
+            <a:pPr indent="0" marL="0">
+              <a:lnSpc>
+                <a:spcPct val="110000"/>
+              </a:lnSpc>
+              <a:buNone/>
+            </a:pPr>
+            <a:r>
+              <a:rPr lang="en-US" sz="750" dirty="0">
+                <a:solidFill>
+                  <a:srgbClr val="475569"/>
+                </a:solidFill>
+                <a:latin typeface="Noto Sans KR" pitchFamily="34" charset="0"/>
+                <a:ea typeface="Noto Sans KR" pitchFamily="34" charset="-122"/>
+                <a:cs typeface="Noto Sans KR" pitchFamily="34" charset="-120"/>
+              </a:rPr>
+              <a:t>컨베어 타입 흐름 라인에 지그를 투입할 경우 검사 완료 후 지그를 투입 위치로 회수하는 방법이 필요합니다. 지그 미회수 시 라인 정체 및 추가 지그 소요 비용이 발생합니다.</a:t>
+            </a:r>
+            <a:endParaRPr lang="en-US" sz="750" dirty="0"/>
+          </a:p>
+        </p:txBody>
+      </p:sp>
+      <p:sp>
+        <p:nvSpPr>
+          <p:cNvPr id="23" name="Shape 21"/>
+          <p:cNvSpPr/>
+          <p:nvPr/>
+        </p:nvSpPr>
+        <p:spPr>
+          <a:xfrm>
+            <a:off x="5943600" y="1933956"/>
+            <a:ext cx="2834640" cy="640080"/>
+          </a:xfrm>
+          <a:prstGeom prst="roundRect">
+            <a:avLst>
+              <a:gd name="adj" fmla="val 10000"/>
+            </a:avLst>
+          </a:prstGeom>
+          <a:solidFill>
+            <a:srgbClr val="EDE9FE"/>
+          </a:solidFill>
+          <a:ln w="12700">
+            <a:solidFill>
+              <a:srgbClr val="EDE9FE"/>
+            </a:solidFill>
+            <a:prstDash val="solid"/>
+          </a:ln>
+          <a:effectLst>
+            <a:outerShdw sx="100000" sy="100000" kx="0" ky="0" algn="bl" rotWithShape="0" blurRad="50800" dist="25400" dir="16200000">
+              <a:srgbClr val="9CA3AF">
+                <a:alpha val="15000"/>
+              </a:srgbClr>
+            </a:outerShdw>
+          </a:effectLst>
+        </p:spPr>
+      </p:sp>
+      <p:sp>
+        <p:nvSpPr>
+          <p:cNvPr id="24" name="Text 22"/>
+          <p:cNvSpPr/>
+          <p:nvPr/>
+        </p:nvSpPr>
+        <p:spPr>
+          <a:xfrm>
+            <a:off x="6035040" y="1970532"/>
+            <a:ext cx="2706624" cy="182880"/>
+          </a:xfrm>
+          <a:prstGeom prst="rect">
+            <a:avLst/>
+          </a:prstGeom>
+          <a:noFill/>
+          <a:ln/>
+        </p:spPr>
+        <p:txBody>
+          <a:bodyPr wrap="square" lIns="0" tIns="0" rIns="0" bIns="0" rtlCol="0" anchor="ctr"/>
+          <a:lstStyle/>
+          <a:p>
+            <a:pPr indent="0" marL="0">
+              <a:buNone/>
+            </a:pPr>
+            <a:r>
+              <a:rPr lang="en-US" sz="750" b="1" dirty="0">
+                <a:solidFill>
+                  <a:srgbClr val="7C3AED"/>
+                </a:solidFill>
+                <a:latin typeface="Noto Sans KR" pitchFamily="34" charset="0"/>
+                <a:ea typeface="Noto Sans KR" pitchFamily="34" charset="-122"/>
+                <a:cs typeface="Noto Sans KR" pitchFamily="34" charset="-120"/>
+              </a:rPr>
+              <a:t>💬 협의 요청</a:t>
+            </a:r>
+            <a:endParaRPr lang="en-US" sz="750" dirty="0"/>
+          </a:p>
+        </p:txBody>
+      </p:sp>
+      <p:sp>
+        <p:nvSpPr>
+          <p:cNvPr id="25" name="Text 23"/>
+          <p:cNvSpPr/>
+          <p:nvPr/>
+        </p:nvSpPr>
+        <p:spPr>
+          <a:xfrm>
+            <a:off x="6035040" y="2153412"/>
+            <a:ext cx="2706624" cy="438912"/>
+          </a:xfrm>
+          <a:prstGeom prst="rect">
+            <a:avLst/>
+          </a:prstGeom>
+          <a:noFill/>
+          <a:ln/>
+        </p:spPr>
+        <p:txBody>
+          <a:bodyPr wrap="square" lIns="0" tIns="0" rIns="0" bIns="0" rtlCol="0" anchor="ctr"/>
+          <a:lstStyle/>
+          <a:p>
+            <a:pPr indent="0" marL="0">
+              <a:lnSpc>
+                <a:spcPct val="130000"/>
+              </a:lnSpc>
+              <a:buNone/>
+            </a:pPr>
+            <a:r>
+              <a:rPr lang="en-US" sz="800" dirty="0">
+                <a:solidFill>
+                  <a:srgbClr val="1E293B"/>
+                </a:solidFill>
+                <a:latin typeface="Noto Sans KR" pitchFamily="34" charset="0"/>
+                <a:ea typeface="Noto Sans KR" pitchFamily="34" charset="-122"/>
+                <a:cs typeface="Noto Sans KR" pitchFamily="34" charset="-120"/>
+              </a:rPr>
+              <a:t>지그 회수 방식(수동 회수 / 자동 리턴 구조) 및 지그 수량 협의</a:t>
+            </a:r>
+            <a:endParaRPr lang="en-US" sz="800" dirty="0"/>
+          </a:p>
+        </p:txBody>
+      </p:sp>
+      <p:sp>
+        <p:nvSpPr>
+          <p:cNvPr id="26" name="Shape 24"/>
+          <p:cNvSpPr/>
+          <p:nvPr/>
+        </p:nvSpPr>
+        <p:spPr>
+          <a:xfrm>
+            <a:off x="365760" y="2679192"/>
+            <a:ext cx="8412480" cy="749808"/>
+          </a:xfrm>
+          <a:prstGeom prst="roundRect">
+            <a:avLst>
+              <a:gd name="adj" fmla="val 8537"/>
+            </a:avLst>
+          </a:prstGeom>
+          <a:solidFill>
+            <a:srgbClr val="FFFFFF"/>
+          </a:solidFill>
+          <a:ln w="12700">
+            <a:solidFill>
+              <a:srgbClr val="0D9488"/>
+            </a:solidFill>
+            <a:prstDash val="solid"/>
+          </a:ln>
+          <a:effectLst>
+            <a:outerShdw sx="100000" sy="100000" kx="0" ky="0" algn="bl" rotWithShape="0" blurRad="50800" dist="25400" dir="16200000">
+              <a:srgbClr val="9CA3AF">
+                <a:alpha val="15000"/>
+              </a:srgbClr>
+            </a:outerShdw>
+          </a:effectLst>
+        </p:spPr>
+      </p:sp>
+      <p:sp>
+        <p:nvSpPr>
+          <p:cNvPr id="27" name="Shape 25"/>
+          <p:cNvSpPr/>
+          <p:nvPr/>
+        </p:nvSpPr>
+        <p:spPr>
+          <a:xfrm>
+            <a:off x="365760" y="2679192"/>
+            <a:ext cx="475488" cy="749808"/>
+          </a:xfrm>
+          <a:prstGeom prst="roundRect">
+            <a:avLst>
+              <a:gd name="adj" fmla="val 11538"/>
+            </a:avLst>
+          </a:prstGeom>
+          <a:solidFill>
+            <a:srgbClr val="0D9488"/>
+          </a:solidFill>
+          <a:ln w="12700">
+            <a:solidFill>
+              <a:srgbClr val="0D9488"/>
+            </a:solidFill>
+            <a:prstDash val="solid"/>
+          </a:ln>
+        </p:spPr>
+      </p:sp>
+      <p:sp>
+        <p:nvSpPr>
+          <p:cNvPr id="28" name="Text 26"/>
+          <p:cNvSpPr/>
+          <p:nvPr/>
+        </p:nvSpPr>
+        <p:spPr>
+          <a:xfrm>
+            <a:off x="365760" y="2679192"/>
+            <a:ext cx="475488" cy="749808"/>
+          </a:xfrm>
+          <a:prstGeom prst="rect">
+            <a:avLst/>
+          </a:prstGeom>
+          <a:noFill/>
+          <a:ln/>
+        </p:spPr>
+        <p:txBody>
+          <a:bodyPr wrap="square" lIns="0" tIns="0" rIns="0" bIns="0" rtlCol="0" anchor="ctr"/>
+          <a:lstStyle/>
+          <a:p>
+            <a:pPr algn="ctr" indent="0" marL="0">
+              <a:buNone/>
+            </a:pPr>
+            <a:r>
+              <a:rPr lang="en-US" sz="1100" b="1" dirty="0">
+                <a:solidFill>
+                  <a:srgbClr val="FFFFFF"/>
+                </a:solidFill>
+                <a:latin typeface="Noto Sans KR" pitchFamily="34" charset="0"/>
+                <a:ea typeface="Noto Sans KR" pitchFamily="34" charset="-122"/>
+                <a:cs typeface="Noto Sans KR" pitchFamily="34" charset="-120"/>
+              </a:rPr>
+              <a:t>03</a:t>
+            </a:r>
+            <a:endParaRPr lang="en-US" sz="1100" dirty="0"/>
+          </a:p>
+        </p:txBody>
+      </p:sp>
+      <p:sp>
+        <p:nvSpPr>
+          <p:cNvPr id="29" name="Shape 27"/>
+          <p:cNvSpPr/>
+          <p:nvPr/>
+        </p:nvSpPr>
+        <p:spPr>
+          <a:xfrm>
+            <a:off x="914400" y="2752344"/>
+            <a:ext cx="658368" cy="182880"/>
+          </a:xfrm>
+          <a:prstGeom prst="roundRect">
+            <a:avLst>
+              <a:gd name="adj" fmla="val 20000"/>
+            </a:avLst>
+          </a:prstGeom>
+          <a:solidFill>
+            <a:srgbClr val="CCFBF1"/>
+          </a:solidFill>
+          <a:ln w="6350">
+            <a:solidFill>
+              <a:srgbClr val="0D9488"/>
+            </a:solidFill>
+            <a:prstDash val="solid"/>
+          </a:ln>
+        </p:spPr>
+      </p:sp>
+      <p:sp>
+        <p:nvSpPr>
+          <p:cNvPr id="30" name="Text 28"/>
+          <p:cNvSpPr/>
+          <p:nvPr/>
+        </p:nvSpPr>
+        <p:spPr>
+          <a:xfrm>
+            <a:off x="914400" y="2752344"/>
+            <a:ext cx="658368" cy="182880"/>
+          </a:xfrm>
+          <a:prstGeom prst="rect">
+            <a:avLst/>
+          </a:prstGeom>
+          <a:noFill/>
+          <a:ln/>
+        </p:spPr>
+        <p:txBody>
+          <a:bodyPr wrap="square" lIns="0" tIns="0" rIns="0" bIns="0" rtlCol="0" anchor="ctr"/>
+          <a:lstStyle/>
+          <a:p>
+            <a:pPr algn="ctr" indent="0" marL="0">
+              <a:buNone/>
+            </a:pPr>
+            <a:r>
+              <a:rPr lang="en-US" sz="650" b="1" dirty="0">
+                <a:solidFill>
+                  <a:srgbClr val="0D9488"/>
+                </a:solidFill>
+                <a:latin typeface="Noto Sans KR" pitchFamily="34" charset="0"/>
+                <a:ea typeface="Noto Sans KR" pitchFamily="34" charset="-122"/>
+                <a:cs typeface="Noto Sans KR" pitchFamily="34" charset="-120"/>
+              </a:rPr>
+              <a:t>처리량</a:t>
+            </a:r>
+            <a:endParaRPr lang="en-US" sz="650" dirty="0"/>
+          </a:p>
+        </p:txBody>
+      </p:sp>
+      <p:sp>
+        <p:nvSpPr>
+          <p:cNvPr id="31" name="Text 29"/>
+          <p:cNvSpPr/>
+          <p:nvPr/>
+        </p:nvSpPr>
+        <p:spPr>
+          <a:xfrm>
+            <a:off x="914400" y="2953512"/>
+            <a:ext cx="4572000" cy="237744"/>
+          </a:xfrm>
+          <a:prstGeom prst="rect">
+            <a:avLst/>
+          </a:prstGeom>
+          <a:noFill/>
+          <a:ln/>
+        </p:spPr>
+        <p:txBody>
+          <a:bodyPr wrap="square" lIns="0" tIns="0" rIns="0" bIns="0" rtlCol="0" anchor="ctr"/>
+          <a:lstStyle/>
+          <a:p>
+            <a:pPr indent="0" marL="0">
+              <a:buNone/>
+            </a:pPr>
+            <a:r>
+              <a:rPr lang="en-US" sz="950" b="1" dirty="0">
+                <a:solidFill>
+                  <a:srgbClr val="1B2F5E"/>
+                </a:solidFill>
+                <a:latin typeface="Noto Sans KR" pitchFamily="34" charset="0"/>
+                <a:ea typeface="Noto Sans KR" pitchFamily="34" charset="-122"/>
+                <a:cs typeface="Noto Sans KR" pitchFamily="34" charset="-120"/>
+              </a:rPr>
+              <a:t>다수 검사품 동시 안착 가능 여부</a:t>
+            </a:r>
+            <a:endParaRPr lang="en-US" sz="950" dirty="0"/>
+          </a:p>
+        </p:txBody>
+      </p:sp>
+      <p:sp>
+        <p:nvSpPr>
+          <p:cNvPr id="32" name="Text 30"/>
+          <p:cNvSpPr/>
+          <p:nvPr/>
+        </p:nvSpPr>
+        <p:spPr>
+          <a:xfrm>
+            <a:off x="914400" y="3172968"/>
+            <a:ext cx="4572000" cy="237744"/>
+          </a:xfrm>
+          <a:prstGeom prst="rect">
+            <a:avLst/>
+          </a:prstGeom>
+          <a:noFill/>
+          <a:ln/>
+        </p:spPr>
+        <p:txBody>
+          <a:bodyPr wrap="square" lIns="0" tIns="0" rIns="0" bIns="0" rtlCol="0" anchor="ctr"/>
+          <a:lstStyle/>
+          <a:p>
+            <a:pPr indent="0" marL="0">
+              <a:lnSpc>
+                <a:spcPct val="110000"/>
+              </a:lnSpc>
+              <a:buNone/>
+            </a:pPr>
+            <a:r>
+              <a:rPr lang="en-US" sz="750" dirty="0">
+                <a:solidFill>
+                  <a:srgbClr val="475569"/>
+                </a:solidFill>
+                <a:latin typeface="Noto Sans KR" pitchFamily="34" charset="0"/>
+                <a:ea typeface="Noto Sans KR" pitchFamily="34" charset="-122"/>
+                <a:cs typeface="Noto Sans KR" pitchFamily="34" charset="-120"/>
+              </a:rPr>
+              <a:t>02항의 지그 회수 방식에 따라 복수의 검사품을 동시에 지그에 올려두는 멀티 안착 구조가 가능한지 검토가 필요합니다. 동시 처리 수량에 따라 검사기 설계 규모와 S/T가 결정됩니다.</a:t>
+            </a:r>
+            <a:endParaRPr lang="en-US" sz="750" dirty="0"/>
+          </a:p>
+        </p:txBody>
+      </p:sp>
+      <p:sp>
+        <p:nvSpPr>
+          <p:cNvPr id="33" name="Shape 31"/>
+          <p:cNvSpPr/>
+          <p:nvPr/>
+        </p:nvSpPr>
+        <p:spPr>
+          <a:xfrm>
+            <a:off x="5943600" y="2734056"/>
+            <a:ext cx="2834640" cy="640080"/>
+          </a:xfrm>
+          <a:prstGeom prst="roundRect">
+            <a:avLst>
+              <a:gd name="adj" fmla="val 10000"/>
+            </a:avLst>
+          </a:prstGeom>
+          <a:solidFill>
+            <a:srgbClr val="CCFBF1"/>
+          </a:solidFill>
+          <a:ln w="12700">
+            <a:solidFill>
+              <a:srgbClr val="CCFBF1"/>
+            </a:solidFill>
+            <a:prstDash val="solid"/>
+          </a:ln>
+          <a:effectLst>
+            <a:outerShdw sx="100000" sy="100000" kx="0" ky="0" algn="bl" rotWithShape="0" blurRad="50800" dist="25400" dir="16200000">
+              <a:srgbClr val="9CA3AF">
+                <a:alpha val="15000"/>
+              </a:srgbClr>
+            </a:outerShdw>
+          </a:effectLst>
+        </p:spPr>
+      </p:sp>
+      <p:sp>
+        <p:nvSpPr>
+          <p:cNvPr id="34" name="Text 32"/>
+          <p:cNvSpPr/>
+          <p:nvPr/>
+        </p:nvSpPr>
+        <p:spPr>
+          <a:xfrm>
+            <a:off x="6035040" y="2770632"/>
+            <a:ext cx="2706624" cy="182880"/>
+          </a:xfrm>
+          <a:prstGeom prst="rect">
+            <a:avLst/>
+          </a:prstGeom>
+          <a:noFill/>
+          <a:ln/>
+        </p:spPr>
+        <p:txBody>
+          <a:bodyPr wrap="square" lIns="0" tIns="0" rIns="0" bIns="0" rtlCol="0" anchor="ctr"/>
+          <a:lstStyle/>
+          <a:p>
+            <a:pPr indent="0" marL="0">
+              <a:buNone/>
+            </a:pPr>
+            <a:r>
+              <a:rPr lang="en-US" sz="750" b="1" dirty="0">
+                <a:solidFill>
+                  <a:srgbClr val="0D9488"/>
+                </a:solidFill>
+                <a:latin typeface="Noto Sans KR" pitchFamily="34" charset="0"/>
+                <a:ea typeface="Noto Sans KR" pitchFamily="34" charset="-122"/>
+                <a:cs typeface="Noto Sans KR" pitchFamily="34" charset="-120"/>
+              </a:rPr>
+              <a:t>💬 협의 요청</a:t>
+            </a:r>
+            <a:endParaRPr lang="en-US" sz="750" dirty="0"/>
+          </a:p>
+        </p:txBody>
+      </p:sp>
+      <p:sp>
+        <p:nvSpPr>
+          <p:cNvPr id="35" name="Text 33"/>
+          <p:cNvSpPr/>
+          <p:nvPr/>
+        </p:nvSpPr>
+        <p:spPr>
+          <a:xfrm>
+            <a:off x="6035040" y="2953512"/>
+            <a:ext cx="2706624" cy="438912"/>
+          </a:xfrm>
+          <a:prstGeom prst="rect">
+            <a:avLst/>
+          </a:prstGeom>
+          <a:noFill/>
+          <a:ln/>
+        </p:spPr>
+        <p:txBody>
+          <a:bodyPr wrap="square" lIns="0" tIns="0" rIns="0" bIns="0" rtlCol="0" anchor="ctr"/>
+          <a:lstStyle/>
+          <a:p>
+            <a:pPr indent="0" marL="0">
+              <a:lnSpc>
+                <a:spcPct val="130000"/>
+              </a:lnSpc>
+              <a:buNone/>
+            </a:pPr>
+            <a:r>
+              <a:rPr lang="en-US" sz="800" dirty="0">
+                <a:solidFill>
+                  <a:srgbClr val="1E293B"/>
+                </a:solidFill>
+                <a:latin typeface="Noto Sans KR" pitchFamily="34" charset="0"/>
+                <a:ea typeface="Noto Sans KR" pitchFamily="34" charset="-122"/>
+                <a:cs typeface="Noto Sans KR" pitchFamily="34" charset="-120"/>
+              </a:rPr>
+              <a:t>라인 생산 속도 및 동시 처리 목표 수량 공유 요청</a:t>
+            </a:r>
+            <a:endParaRPr lang="en-US" sz="800" dirty="0"/>
+          </a:p>
+        </p:txBody>
+      </p:sp>
+      <p:sp>
+        <p:nvSpPr>
+          <p:cNvPr id="36" name="Shape 34"/>
+          <p:cNvSpPr/>
+          <p:nvPr/>
+        </p:nvSpPr>
+        <p:spPr>
+          <a:xfrm>
+            <a:off x="365760" y="3479292"/>
+            <a:ext cx="8412480" cy="749808"/>
+          </a:xfrm>
+          <a:prstGeom prst="roundRect">
+            <a:avLst>
+              <a:gd name="adj" fmla="val 8537"/>
+            </a:avLst>
+          </a:prstGeom>
+          <a:solidFill>
+            <a:srgbClr val="FFFFFF"/>
+          </a:solidFill>
+          <a:ln w="12700">
+            <a:solidFill>
+              <a:srgbClr val="D97706"/>
+            </a:solidFill>
+            <a:prstDash val="solid"/>
+          </a:ln>
+          <a:effectLst>
+            <a:outerShdw sx="100000" sy="100000" kx="0" ky="0" algn="bl" rotWithShape="0" blurRad="50800" dist="25400" dir="16200000">
+              <a:srgbClr val="9CA3AF">
+                <a:alpha val="15000"/>
+              </a:srgbClr>
+            </a:outerShdw>
+          </a:effectLst>
+        </p:spPr>
+      </p:sp>
+      <p:sp>
+        <p:nvSpPr>
+          <p:cNvPr id="37" name="Shape 35"/>
+          <p:cNvSpPr/>
+          <p:nvPr/>
+        </p:nvSpPr>
+        <p:spPr>
+          <a:xfrm>
+            <a:off x="365760" y="3479292"/>
+            <a:ext cx="475488" cy="749808"/>
+          </a:xfrm>
+          <a:prstGeom prst="roundRect">
+            <a:avLst>
+              <a:gd name="adj" fmla="val 11538"/>
+            </a:avLst>
+          </a:prstGeom>
+          <a:solidFill>
+            <a:srgbClr val="D97706"/>
+          </a:solidFill>
+          <a:ln w="12700">
+            <a:solidFill>
+              <a:srgbClr val="D97706"/>
+            </a:solidFill>
+            <a:prstDash val="solid"/>
+          </a:ln>
+        </p:spPr>
+      </p:sp>
+      <p:sp>
+        <p:nvSpPr>
+          <p:cNvPr id="38" name="Text 36"/>
+          <p:cNvSpPr/>
+          <p:nvPr/>
+        </p:nvSpPr>
+        <p:spPr>
+          <a:xfrm>
+            <a:off x="365760" y="3479292"/>
+            <a:ext cx="475488" cy="749808"/>
+          </a:xfrm>
+          <a:prstGeom prst="rect">
+            <a:avLst/>
+          </a:prstGeom>
+          <a:noFill/>
+          <a:ln/>
+        </p:spPr>
+        <p:txBody>
+          <a:bodyPr wrap="square" lIns="0" tIns="0" rIns="0" bIns="0" rtlCol="0" anchor="ctr"/>
+          <a:lstStyle/>
+          <a:p>
+            <a:pPr algn="ctr" indent="0" marL="0">
+              <a:buNone/>
+            </a:pPr>
+            <a:r>
+              <a:rPr lang="en-US" sz="1100" b="1" dirty="0">
+                <a:solidFill>
+                  <a:srgbClr val="FFFFFF"/>
+                </a:solidFill>
+                <a:latin typeface="Noto Sans KR" pitchFamily="34" charset="0"/>
+                <a:ea typeface="Noto Sans KR" pitchFamily="34" charset="-122"/>
+                <a:cs typeface="Noto Sans KR" pitchFamily="34" charset="-120"/>
+              </a:rPr>
+              <a:t>04</a:t>
+            </a:r>
+            <a:endParaRPr lang="en-US" sz="1100" dirty="0"/>
+          </a:p>
+        </p:txBody>
+      </p:sp>
+      <p:sp>
+        <p:nvSpPr>
+          <p:cNvPr id="39" name="Shape 37"/>
+          <p:cNvSpPr/>
+          <p:nvPr/>
+        </p:nvSpPr>
+        <p:spPr>
+          <a:xfrm>
+            <a:off x="914400" y="3552444"/>
+            <a:ext cx="658368" cy="182880"/>
+          </a:xfrm>
+          <a:prstGeom prst="roundRect">
+            <a:avLst>
+              <a:gd name="adj" fmla="val 20000"/>
+            </a:avLst>
+          </a:prstGeom>
+          <a:solidFill>
+            <a:srgbClr val="FEF3C7"/>
+          </a:solidFill>
+          <a:ln w="6350">
+            <a:solidFill>
+              <a:srgbClr val="D97706"/>
+            </a:solidFill>
+            <a:prstDash val="solid"/>
+          </a:ln>
+        </p:spPr>
+      </p:sp>
+      <p:sp>
+        <p:nvSpPr>
+          <p:cNvPr id="40" name="Text 38"/>
+          <p:cNvSpPr/>
+          <p:nvPr/>
+        </p:nvSpPr>
+        <p:spPr>
+          <a:xfrm>
+            <a:off x="914400" y="3552444"/>
+            <a:ext cx="658368" cy="182880"/>
+          </a:xfrm>
+          <a:prstGeom prst="rect">
+            <a:avLst/>
+          </a:prstGeom>
+          <a:noFill/>
+          <a:ln/>
+        </p:spPr>
+        <p:txBody>
+          <a:bodyPr wrap="square" lIns="0" tIns="0" rIns="0" bIns="0" rtlCol="0" anchor="ctr"/>
+          <a:lstStyle/>
+          <a:p>
+            <a:pPr algn="ctr" indent="0" marL="0">
+              <a:buNone/>
+            </a:pPr>
+            <a:r>
+              <a:rPr lang="en-US" sz="650" b="1" dirty="0">
+                <a:solidFill>
+                  <a:srgbClr val="D97706"/>
+                </a:solidFill>
+                <a:latin typeface="Noto Sans KR" pitchFamily="34" charset="0"/>
+                <a:ea typeface="Noto Sans KR" pitchFamily="34" charset="-122"/>
+                <a:cs typeface="Noto Sans KR" pitchFamily="34" charset="-120"/>
+              </a:rPr>
+              <a:t>장비 설계</a:t>
+            </a:r>
+            <a:endParaRPr lang="en-US" sz="650" dirty="0"/>
+          </a:p>
+        </p:txBody>
+      </p:sp>
+      <p:sp>
+        <p:nvSpPr>
+          <p:cNvPr id="41" name="Text 39"/>
+          <p:cNvSpPr/>
+          <p:nvPr/>
+        </p:nvSpPr>
+        <p:spPr>
+          <a:xfrm>
+            <a:off x="914400" y="3753612"/>
+            <a:ext cx="4572000" cy="237744"/>
+          </a:xfrm>
+          <a:prstGeom prst="rect">
+            <a:avLst/>
+          </a:prstGeom>
+          <a:noFill/>
+          <a:ln/>
+        </p:spPr>
+        <p:txBody>
+          <a:bodyPr wrap="square" lIns="0" tIns="0" rIns="0" bIns="0" rtlCol="0" anchor="ctr"/>
+          <a:lstStyle/>
+          <a:p>
+            <a:pPr indent="0" marL="0">
+              <a:buNone/>
+            </a:pPr>
+            <a:r>
+              <a:rPr lang="en-US" sz="950" b="1" dirty="0">
+                <a:solidFill>
+                  <a:srgbClr val="1B2F5E"/>
+                </a:solidFill>
+                <a:latin typeface="Noto Sans KR" pitchFamily="34" charset="0"/>
+                <a:ea typeface="Noto Sans KR" pitchFamily="34" charset="-122"/>
+                <a:cs typeface="Noto Sans KR" pitchFamily="34" charset="-120"/>
+              </a:rPr>
+              <a:t>03항 가능 시 — 검사기 내부 지그 리턴 구조 추가</a:t>
+            </a:r>
+            <a:endParaRPr lang="en-US" sz="950" dirty="0"/>
+          </a:p>
+        </p:txBody>
+      </p:sp>
+      <p:sp>
+        <p:nvSpPr>
+          <p:cNvPr id="42" name="Text 40"/>
+          <p:cNvSpPr/>
+          <p:nvPr/>
+        </p:nvSpPr>
+        <p:spPr>
+          <a:xfrm>
+            <a:off x="914400" y="3973068"/>
+            <a:ext cx="4572000" cy="237744"/>
+          </a:xfrm>
+          <a:prstGeom prst="rect">
+            <a:avLst/>
+          </a:prstGeom>
+          <a:noFill/>
+          <a:ln/>
+        </p:spPr>
+        <p:txBody>
+          <a:bodyPr wrap="square" lIns="0" tIns="0" rIns="0" bIns="0" rtlCol="0" anchor="ctr"/>
+          <a:lstStyle/>
+          <a:p>
+            <a:pPr indent="0" marL="0">
+              <a:lnSpc>
+                <a:spcPct val="110000"/>
+              </a:lnSpc>
+              <a:buNone/>
+            </a:pPr>
+            <a:r>
+              <a:rPr lang="en-US" sz="750" dirty="0">
+                <a:solidFill>
+                  <a:srgbClr val="475569"/>
+                </a:solidFill>
+                <a:latin typeface="Noto Sans KR" pitchFamily="34" charset="0"/>
+                <a:ea typeface="Noto Sans KR" pitchFamily="34" charset="-122"/>
+                <a:cs typeface="Noto Sans KR" pitchFamily="34" charset="-120"/>
+              </a:rPr>
+              <a:t>다수 동시 안착이 가능하다면 검사기 내부에 지그 자동 리턴 구조를 설계에 포함합니다. 이 경우 장비 규모와 제작 기간·비용이 증가하므로 효용성을 함께 검토해야 합니다.</a:t>
+            </a:r>
+            <a:endParaRPr lang="en-US" sz="750" dirty="0"/>
+          </a:p>
+        </p:txBody>
+      </p:sp>
+      <p:sp>
+        <p:nvSpPr>
+          <p:cNvPr id="43" name="Shape 41"/>
+          <p:cNvSpPr/>
+          <p:nvPr/>
+        </p:nvSpPr>
+        <p:spPr>
+          <a:xfrm>
+            <a:off x="5943600" y="3534156"/>
+            <a:ext cx="2834640" cy="640080"/>
+          </a:xfrm>
+          <a:prstGeom prst="roundRect">
+            <a:avLst>
+              <a:gd name="adj" fmla="val 10000"/>
+            </a:avLst>
+          </a:prstGeom>
+          <a:solidFill>
+            <a:srgbClr val="FEF3C7"/>
+          </a:solidFill>
+          <a:ln w="12700">
+            <a:solidFill>
+              <a:srgbClr val="FEF3C7"/>
+            </a:solidFill>
+            <a:prstDash val="solid"/>
+          </a:ln>
+          <a:effectLst>
+            <a:outerShdw sx="100000" sy="100000" kx="0" ky="0" algn="bl" rotWithShape="0" blurRad="50800" dist="25400" dir="16200000">
+              <a:srgbClr val="9CA3AF">
+                <a:alpha val="15000"/>
+              </a:srgbClr>
+            </a:outerShdw>
+          </a:effectLst>
+        </p:spPr>
+      </p:sp>
+      <p:sp>
+        <p:nvSpPr>
+          <p:cNvPr id="44" name="Text 42"/>
+          <p:cNvSpPr/>
+          <p:nvPr/>
+        </p:nvSpPr>
+        <p:spPr>
+          <a:xfrm>
+            <a:off x="6035040" y="3570732"/>
+            <a:ext cx="2706624" cy="182880"/>
+          </a:xfrm>
+          <a:prstGeom prst="rect">
+            <a:avLst/>
+          </a:prstGeom>
+          <a:noFill/>
+          <a:ln/>
+        </p:spPr>
+        <p:txBody>
+          <a:bodyPr wrap="square" lIns="0" tIns="0" rIns="0" bIns="0" rtlCol="0" anchor="ctr"/>
+          <a:lstStyle/>
+          <a:p>
+            <a:pPr indent="0" marL="0">
+              <a:buNone/>
+            </a:pPr>
+            <a:r>
+              <a:rPr lang="en-US" sz="750" b="1" dirty="0">
+                <a:solidFill>
+                  <a:srgbClr val="D97706"/>
+                </a:solidFill>
+                <a:latin typeface="Noto Sans KR" pitchFamily="34" charset="0"/>
+                <a:ea typeface="Noto Sans KR" pitchFamily="34" charset="-122"/>
+                <a:cs typeface="Noto Sans KR" pitchFamily="34" charset="-120"/>
+              </a:rPr>
+              <a:t>💬 협의 요청</a:t>
+            </a:r>
+            <a:endParaRPr lang="en-US" sz="750" dirty="0"/>
+          </a:p>
+        </p:txBody>
+      </p:sp>
+      <p:sp>
+        <p:nvSpPr>
+          <p:cNvPr id="45" name="Text 43"/>
+          <p:cNvSpPr/>
+          <p:nvPr/>
+        </p:nvSpPr>
+        <p:spPr>
+          <a:xfrm>
+            <a:off x="6035040" y="3753612"/>
+            <a:ext cx="2706624" cy="438912"/>
+          </a:xfrm>
+          <a:prstGeom prst="rect">
+            <a:avLst/>
+          </a:prstGeom>
+          <a:noFill/>
+          <a:ln/>
+        </p:spPr>
+        <p:txBody>
+          <a:bodyPr wrap="square" lIns="0" tIns="0" rIns="0" bIns="0" rtlCol="0" anchor="ctr"/>
+          <a:lstStyle/>
+          <a:p>
+            <a:pPr indent="0" marL="0">
+              <a:lnSpc>
+                <a:spcPct val="130000"/>
+              </a:lnSpc>
+              <a:buNone/>
+            </a:pPr>
+            <a:r>
+              <a:rPr lang="en-US" sz="800" dirty="0">
+                <a:solidFill>
+                  <a:srgbClr val="1E293B"/>
+                </a:solidFill>
+                <a:latin typeface="Noto Sans KR" pitchFamily="34" charset="0"/>
+                <a:ea typeface="Noto Sans KR" pitchFamily="34" charset="-122"/>
+                <a:cs typeface="Noto Sans KR" pitchFamily="34" charset="-120"/>
+              </a:rPr>
+              <a:t>리턴 구조 포함 여부 및 설치 공간·예산 범위 사전 협의</a:t>
+            </a:r>
+            <a:endParaRPr lang="en-US" sz="800" dirty="0"/>
+          </a:p>
+        </p:txBody>
+      </p:sp>
+      <p:sp>
+        <p:nvSpPr>
+          <p:cNvPr id="46" name="Shape 44"/>
+          <p:cNvSpPr/>
+          <p:nvPr/>
+        </p:nvSpPr>
+        <p:spPr>
+          <a:xfrm>
+            <a:off x="365760" y="4279392"/>
+            <a:ext cx="8412480" cy="749808"/>
+          </a:xfrm>
+          <a:prstGeom prst="roundRect">
+            <a:avLst>
+              <a:gd name="adj" fmla="val 8537"/>
+            </a:avLst>
+          </a:prstGeom>
+          <a:solidFill>
+            <a:srgbClr val="FFFFFF"/>
+          </a:solidFill>
+          <a:ln w="12700">
+            <a:solidFill>
+              <a:srgbClr val="059669"/>
+            </a:solidFill>
+            <a:prstDash val="solid"/>
+          </a:ln>
+          <a:effectLst>
+            <a:outerShdw sx="100000" sy="100000" kx="0" ky="0" algn="bl" rotWithShape="0" blurRad="50800" dist="25400" dir="16200000">
+              <a:srgbClr val="9CA3AF">
+                <a:alpha val="15000"/>
+              </a:srgbClr>
+            </a:outerShdw>
+          </a:effectLst>
+        </p:spPr>
+      </p:sp>
+      <p:sp>
+        <p:nvSpPr>
+          <p:cNvPr id="47" name="Shape 45"/>
+          <p:cNvSpPr/>
+          <p:nvPr/>
+        </p:nvSpPr>
+        <p:spPr>
+          <a:xfrm>
+            <a:off x="365760" y="4279392"/>
+            <a:ext cx="475488" cy="749808"/>
+          </a:xfrm>
+          <a:prstGeom prst="roundRect">
+            <a:avLst>
+              <a:gd name="adj" fmla="val 11538"/>
+            </a:avLst>
+          </a:prstGeom>
+          <a:solidFill>
+            <a:srgbClr val="059669"/>
+          </a:solidFill>
+          <a:ln w="12700">
+            <a:solidFill>
+              <a:srgbClr val="059669"/>
+            </a:solidFill>
+            <a:prstDash val="solid"/>
+          </a:ln>
+        </p:spPr>
+      </p:sp>
+      <p:sp>
+        <p:nvSpPr>
+          <p:cNvPr id="48" name="Text 46"/>
+          <p:cNvSpPr/>
+          <p:nvPr/>
+        </p:nvSpPr>
+        <p:spPr>
+          <a:xfrm>
+            <a:off x="365760" y="4279392"/>
+            <a:ext cx="475488" cy="749808"/>
+          </a:xfrm>
+          <a:prstGeom prst="rect">
+            <a:avLst/>
+          </a:prstGeom>
+          <a:noFill/>
+          <a:ln/>
+        </p:spPr>
+        <p:txBody>
+          <a:bodyPr wrap="square" lIns="0" tIns="0" rIns="0" bIns="0" rtlCol="0" anchor="ctr"/>
+          <a:lstStyle/>
+          <a:p>
+            <a:pPr algn="ctr" indent="0" marL="0">
+              <a:buNone/>
+            </a:pPr>
+            <a:r>
+              <a:rPr lang="en-US" sz="1100" b="1" dirty="0">
+                <a:solidFill>
+                  <a:srgbClr val="FFFFFF"/>
+                </a:solidFill>
+                <a:latin typeface="Noto Sans KR" pitchFamily="34" charset="0"/>
+                <a:ea typeface="Noto Sans KR" pitchFamily="34" charset="-122"/>
+                <a:cs typeface="Noto Sans KR" pitchFamily="34" charset="-120"/>
+              </a:rPr>
+              <a:t>05</a:t>
+            </a:r>
+            <a:endParaRPr lang="en-US" sz="1100" dirty="0"/>
+          </a:p>
+        </p:txBody>
+      </p:sp>
+      <p:sp>
+        <p:nvSpPr>
+          <p:cNvPr id="49" name="Shape 47"/>
+          <p:cNvSpPr/>
+          <p:nvPr/>
+        </p:nvSpPr>
+        <p:spPr>
+          <a:xfrm>
+            <a:off x="914400" y="4352544"/>
+            <a:ext cx="658368" cy="182880"/>
+          </a:xfrm>
+          <a:prstGeom prst="roundRect">
+            <a:avLst>
+              <a:gd name="adj" fmla="val 20000"/>
+            </a:avLst>
+          </a:prstGeom>
+          <a:solidFill>
+            <a:srgbClr val="D1FAE5"/>
+          </a:solidFill>
+          <a:ln w="6350">
+            <a:solidFill>
+              <a:srgbClr val="059669"/>
+            </a:solidFill>
+            <a:prstDash val="solid"/>
+          </a:ln>
+        </p:spPr>
+      </p:sp>
+      <p:sp>
+        <p:nvSpPr>
+          <p:cNvPr id="50" name="Text 48"/>
+          <p:cNvSpPr/>
+          <p:nvPr/>
+        </p:nvSpPr>
+        <p:spPr>
+          <a:xfrm>
+            <a:off x="914400" y="4352544"/>
+            <a:ext cx="658368" cy="182880"/>
+          </a:xfrm>
+          <a:prstGeom prst="rect">
+            <a:avLst/>
+          </a:prstGeom>
+          <a:noFill/>
+          <a:ln/>
+        </p:spPr>
+        <p:txBody>
+          <a:bodyPr wrap="square" lIns="0" tIns="0" rIns="0" bIns="0" rtlCol="0" anchor="ctr"/>
+          <a:lstStyle/>
+          <a:p>
+            <a:pPr algn="ctr" indent="0" marL="0">
+              <a:buNone/>
+            </a:pPr>
+            <a:r>
+              <a:rPr lang="en-US" sz="650" b="1" dirty="0">
+                <a:solidFill>
+                  <a:srgbClr val="059669"/>
+                </a:solidFill>
+                <a:latin typeface="Noto Sans KR" pitchFamily="34" charset="0"/>
+                <a:ea typeface="Noto Sans KR" pitchFamily="34" charset="-122"/>
+                <a:cs typeface="Noto Sans KR" pitchFamily="34" charset="-120"/>
+              </a:rPr>
+              <a:t>데이터 협조</a:t>
+            </a:r>
+            <a:endParaRPr lang="en-US" sz="650" dirty="0"/>
+          </a:p>
+        </p:txBody>
+      </p:sp>
+      <p:sp>
+        <p:nvSpPr>
+          <p:cNvPr id="51" name="Text 49"/>
+          <p:cNvSpPr/>
+          <p:nvPr/>
+        </p:nvSpPr>
+        <p:spPr>
+          <a:xfrm>
+            <a:off x="914400" y="4553712"/>
+            <a:ext cx="4572000" cy="237744"/>
+          </a:xfrm>
+          <a:prstGeom prst="rect">
+            <a:avLst/>
+          </a:prstGeom>
+          <a:noFill/>
+          <a:ln/>
+        </p:spPr>
+        <p:txBody>
+          <a:bodyPr wrap="square" lIns="0" tIns="0" rIns="0" bIns="0" rtlCol="0" anchor="ctr"/>
+          <a:lstStyle/>
+          <a:p>
+            <a:pPr indent="0" marL="0">
+              <a:buNone/>
+            </a:pPr>
+            <a:r>
+              <a:rPr lang="en-US" sz="950" b="1" dirty="0">
+                <a:solidFill>
+                  <a:srgbClr val="1B2F5E"/>
+                </a:solidFill>
+                <a:latin typeface="Noto Sans KR" pitchFamily="34" charset="0"/>
+                <a:ea typeface="Noto Sans KR" pitchFamily="34" charset="-122"/>
+                <a:cs typeface="Noto Sans KR" pitchFamily="34" charset="-120"/>
+              </a:rPr>
+              <a:t>기존 육안검사 경험 데이터의 딥러닝 학습 적용</a:t>
+            </a:r>
+            <a:endParaRPr lang="en-US" sz="950" dirty="0"/>
+          </a:p>
+        </p:txBody>
+      </p:sp>
+      <p:sp>
+        <p:nvSpPr>
+          <p:cNvPr id="52" name="Text 50"/>
+          <p:cNvSpPr/>
+          <p:nvPr/>
+        </p:nvSpPr>
+        <p:spPr>
+          <a:xfrm>
+            <a:off x="914400" y="4773168"/>
+            <a:ext cx="4572000" cy="237744"/>
+          </a:xfrm>
+          <a:prstGeom prst="rect">
+            <a:avLst/>
+          </a:prstGeom>
+          <a:noFill/>
+          <a:ln/>
+        </p:spPr>
+        <p:txBody>
+          <a:bodyPr wrap="square" lIns="0" tIns="0" rIns="0" bIns="0" rtlCol="0" anchor="ctr"/>
+          <a:lstStyle/>
+          <a:p>
+            <a:pPr indent="0" marL="0">
+              <a:lnSpc>
+                <a:spcPct val="110000"/>
+              </a:lnSpc>
+              <a:buNone/>
+            </a:pPr>
+            <a:r>
+              <a:rPr lang="en-US" sz="750" dirty="0">
+                <a:solidFill>
+                  <a:srgbClr val="475569"/>
+                </a:solidFill>
+                <a:latin typeface="Noto Sans KR" pitchFamily="34" charset="0"/>
+                <a:ea typeface="Noto Sans KR" pitchFamily="34" charset="-122"/>
+                <a:cs typeface="Noto Sans KR" pitchFamily="34" charset="-120"/>
+              </a:rPr>
+              <a:t>비전검사기 도입 이전 검사원들이 육안으로 판별하며 축적한 불량 사례·판정 기준 데이터를 딥러닝 초기 학습에 활용하면 검출 정확도를 빠르게 높일 수 있습니다. 학습 데이터가 많을수록 도입 초기 성능이 향상됩니다.</a:t>
+            </a:r>
+            <a:endParaRPr lang="en-US" sz="750" dirty="0"/>
+          </a:p>
+        </p:txBody>
+      </p:sp>
+      <p:sp>
+        <p:nvSpPr>
+          <p:cNvPr id="53" name="Shape 51"/>
+          <p:cNvSpPr/>
+          <p:nvPr/>
+        </p:nvSpPr>
+        <p:spPr>
+          <a:xfrm>
+            <a:off x="5943600" y="4334256"/>
+            <a:ext cx="2834640" cy="640080"/>
+          </a:xfrm>
+          <a:prstGeom prst="roundRect">
+            <a:avLst>
+              <a:gd name="adj" fmla="val 10000"/>
+            </a:avLst>
+          </a:prstGeom>
+          <a:solidFill>
+            <a:srgbClr val="D1FAE5"/>
+          </a:solidFill>
+          <a:ln w="12700">
+            <a:solidFill>
+              <a:srgbClr val="D1FAE5"/>
+            </a:solidFill>
+            <a:prstDash val="solid"/>
+          </a:ln>
+          <a:effectLst>
+            <a:outerShdw sx="100000" sy="100000" kx="0" ky="0" algn="bl" rotWithShape="0" blurRad="50800" dist="25400" dir="16200000">
+              <a:srgbClr val="9CA3AF">
+                <a:alpha val="15000"/>
+              </a:srgbClr>
+            </a:outerShdw>
+          </a:effectLst>
+        </p:spPr>
+      </p:sp>
+      <p:sp>
+        <p:nvSpPr>
+          <p:cNvPr id="54" name="Text 52"/>
+          <p:cNvSpPr/>
+          <p:nvPr/>
+        </p:nvSpPr>
+        <p:spPr>
+          <a:xfrm>
+            <a:off x="6035040" y="4370832"/>
+            <a:ext cx="2706624" cy="182880"/>
+          </a:xfrm>
+          <a:prstGeom prst="rect">
+            <a:avLst/>
+          </a:prstGeom>
+          <a:noFill/>
+          <a:ln/>
+        </p:spPr>
+        <p:txBody>
+          <a:bodyPr wrap="square" lIns="0" tIns="0" rIns="0" bIns="0" rtlCol="0" anchor="ctr"/>
+          <a:lstStyle/>
+          <a:p>
+            <a:pPr indent="0" marL="0">
+              <a:buNone/>
+            </a:pPr>
+            <a:r>
+              <a:rPr lang="en-US" sz="750" b="1" dirty="0">
+                <a:solidFill>
+                  <a:srgbClr val="059669"/>
+                </a:solidFill>
+                <a:latin typeface="Noto Sans KR" pitchFamily="34" charset="0"/>
+                <a:ea typeface="Noto Sans KR" pitchFamily="34" charset="-122"/>
+                <a:cs typeface="Noto Sans KR" pitchFamily="34" charset="-120"/>
+              </a:rPr>
+              <a:t>💬 협의 요청</a:t>
+            </a:r>
+            <a:endParaRPr lang="en-US" sz="750" dirty="0"/>
+          </a:p>
+        </p:txBody>
+      </p:sp>
+      <p:sp>
+        <p:nvSpPr>
+          <p:cNvPr id="55" name="Text 53"/>
+          <p:cNvSpPr/>
+          <p:nvPr/>
+        </p:nvSpPr>
+        <p:spPr>
+          <a:xfrm>
+            <a:off x="6035040" y="4553712"/>
+            <a:ext cx="2706624" cy="438912"/>
+          </a:xfrm>
+          <a:prstGeom prst="rect">
+            <a:avLst/>
+          </a:prstGeom>
+          <a:noFill/>
+          <a:ln/>
+        </p:spPr>
+        <p:txBody>
+          <a:bodyPr wrap="square" lIns="0" tIns="0" rIns="0" bIns="0" rtlCol="0" anchor="ctr"/>
+          <a:lstStyle/>
+          <a:p>
+            <a:pPr indent="0" marL="0">
+              <a:lnSpc>
+                <a:spcPct val="130000"/>
+              </a:lnSpc>
+              <a:buNone/>
+            </a:pPr>
+            <a:r>
+              <a:rPr lang="en-US" sz="800" dirty="0">
+                <a:solidFill>
+                  <a:srgbClr val="1E293B"/>
+                </a:solidFill>
+                <a:latin typeface="Noto Sans KR" pitchFamily="34" charset="0"/>
+                <a:ea typeface="Noto Sans KR" pitchFamily="34" charset="-122"/>
+                <a:cs typeface="Noto Sans KR" pitchFamily="34" charset="-120"/>
+              </a:rPr>
+              <a:t>기존 불량 이미지·판정 이력 데이터 제공 여부 및 범위 협의</a:t>
+            </a:r>
+            <a:endParaRPr lang="en-US" sz="800" dirty="0"/>
+          </a:p>
+        </p:txBody>
+      </p:sp>
+    </p:spTree>
+  </p:cSld>
+  <p:clrMapOvr>
+    <a:masterClrMapping/>
+  </p:clrMapOvr>
+</p:sld>
+</file>
+
+<file path=ppt/slides/slide13.xml><?xml version="1.0" encoding="utf-8"?>
+<p:sld xmlns:a="http://schemas.openxmlformats.org/drawingml/2006/main" xmlns:r="http://schemas.openxmlformats.org/officeDocument/2006/relationships" xmlns:p="http://schemas.openxmlformats.org/presentationml/2006/main">
+  <p:cSld name="Slide 13">
+    <p:spTree>
+      <p:nvGrpSpPr>
+        <p:cNvPr id="1" name=""/>
+        <p:cNvGrpSpPr/>
+        <p:nvPr/>
+      </p:nvGrpSpPr>
+      <p:grpSpPr>
+        <a:xfrm>
+          <a:off x="0" y="0"/>
+          <a:ext cx="0" cy="0"/>
+          <a:chOff x="0" y="0"/>
+          <a:chExt cx="0" cy="0"/>
+        </a:xfrm>
+      </p:grpSpPr>
+      <p:sp>
+        <p:nvSpPr>
+          <p:cNvPr id="2" name="Shape 0"/>
+          <p:cNvSpPr/>
+          <p:nvPr/>
+        </p:nvSpPr>
+        <p:spPr>
+          <a:xfrm>
+            <a:off x="0" y="0"/>
+            <a:ext cx="9144000" cy="5143500"/>
+          </a:xfrm>
+          <a:prstGeom prst="rect">
+            <a:avLst/>
+          </a:prstGeom>
+          <a:solidFill>
             <a:srgbClr val="1B2F5E"/>
           </a:solidFill>
           <a:ln w="12700">
@@ -8779,7 +10401,7 @@
                 <a:ea typeface="Noto Sans KR" pitchFamily="34" charset="-122"/>
                 <a:cs typeface="Noto Sans KR" pitchFamily="34" charset="-120"/>
               </a:rPr>
-              <a:t>예상 문제점 및 협의 사항</a:t>
+              <a:t>사업 모델 — 임대 방식</a:t>
             </a:r>
             <a:endParaRPr lang="en-US" sz="1150" dirty="0"/>
           </a:p>
@@ -8867,6 +10489,118 @@
         <p:spPr>
           <a:xfrm>
             <a:off x="5120640" y="3227832"/>
+            <a:ext cx="3547872" cy="256032"/>
+          </a:xfrm>
+          <a:prstGeom prst="rect">
+            <a:avLst/>
+          </a:prstGeom>
+          <a:noFill/>
+          <a:ln/>
+        </p:spPr>
+        <p:txBody>
+          <a:bodyPr wrap="square" lIns="0" tIns="0" rIns="0" bIns="0" rtlCol="0" anchor="ctr"/>
+          <a:lstStyle/>
+          <a:p>
+            <a:pPr indent="0" marL="0">
+              <a:buNone/>
+            </a:pPr>
+            <a:r>
+              <a:rPr lang="en-US" sz="1150" dirty="0">
+                <a:solidFill>
+                  <a:srgbClr val="1E293B"/>
+                </a:solidFill>
+                <a:latin typeface="Noto Sans KR" pitchFamily="34" charset="0"/>
+                <a:ea typeface="Noto Sans KR" pitchFamily="34" charset="-122"/>
+                <a:cs typeface="Noto Sans KR" pitchFamily="34" charset="-120"/>
+              </a:rPr>
+              <a:t>예상 문제점 및 협의 사항</a:t>
+            </a:r>
+            <a:endParaRPr lang="en-US" sz="1150" dirty="0"/>
+          </a:p>
+        </p:txBody>
+      </p:sp>
+      <p:sp>
+        <p:nvSpPr>
+          <p:cNvPr id="36" name="Shape 34"/>
+          <p:cNvSpPr/>
+          <p:nvPr/>
+        </p:nvSpPr>
+        <p:spPr>
+          <a:xfrm>
+            <a:off x="365760" y="3657600"/>
+            <a:ext cx="4114800" cy="420624"/>
+          </a:xfrm>
+          <a:prstGeom prst="roundRect">
+            <a:avLst>
+              <a:gd name="adj" fmla="val 15217"/>
+            </a:avLst>
+          </a:prstGeom>
+          <a:solidFill>
+            <a:srgbClr val="FFFFFF"/>
+          </a:solidFill>
+          <a:ln w="12700">
+            <a:solidFill>
+              <a:srgbClr val="E2E8F0"/>
+            </a:solidFill>
+            <a:prstDash val="solid"/>
+          </a:ln>
+          <a:effectLst>
+            <a:outerShdw sx="100000" sy="100000" kx="0" ky="0" algn="bl" rotWithShape="0" blurRad="50800" dist="25400" dir="16200000">
+              <a:srgbClr val="9CA3AF">
+                <a:alpha val="15000"/>
+              </a:srgbClr>
+            </a:outerShdw>
+          </a:effectLst>
+        </p:spPr>
+      </p:sp>
+      <p:sp>
+        <p:nvSpPr>
+          <p:cNvPr id="37" name="Text 35"/>
+          <p:cNvSpPr/>
+          <p:nvPr/>
+        </p:nvSpPr>
+        <p:spPr>
+          <a:xfrm>
+            <a:off x="475488" y="3739896"/>
+            <a:ext cx="329184" cy="256032"/>
+          </a:xfrm>
+          <a:prstGeom prst="rect">
+            <a:avLst/>
+          </a:prstGeom>
+          <a:noFill/>
+          <a:ln/>
+        </p:spPr>
+        <p:txBody>
+          <a:bodyPr wrap="square" lIns="0" tIns="0" rIns="0" bIns="0" rtlCol="0" anchor="ctr"/>
+          <a:lstStyle/>
+          <a:p>
+            <a:pPr indent="0" marL="0">
+              <a:buNone/>
+            </a:pPr>
+            <a:r>
+              <a:rPr lang="en-US" sz="1200" b="1" dirty="0">
+                <a:solidFill>
+                  <a:srgbClr val="2563EB"/>
+                </a:solidFill>
+                <a:latin typeface="Noto Sans KR" pitchFamily="34" charset="0"/>
+                <a:ea typeface="Noto Sans KR" pitchFamily="34" charset="-122"/>
+                <a:cs typeface="Noto Sans KR" pitchFamily="34" charset="-120"/>
+              </a:rPr>
+              <a:t>11</a:t>
+            </a:r>
+            <a:endParaRPr lang="en-US" sz="1200" dirty="0"/>
+          </a:p>
+        </p:txBody>
+      </p:sp>
+      <p:sp>
+        <p:nvSpPr>
+          <p:cNvPr id="38" name="Text 36"/>
+          <p:cNvSpPr/>
+          <p:nvPr/>
+        </p:nvSpPr>
+        <p:spPr>
+          <a:xfrm>
+            <a:off x="822960" y="3739896"/>
             <a:ext cx="3547872" cy="256032"/>
           </a:xfrm>
           <a:prstGeom prst="rect">
@@ -9044,7 +10778,7 @@
                 <a:ea typeface="Noto Sans KR" pitchFamily="34" charset="-122"/>
                 <a:cs typeface="Noto Sans KR" pitchFamily="34" charset="-120"/>
               </a:rPr>
-              <a:t>왜 지금 딥러닝 비전검사인가?</a:t>
+              <a:t>왜 지금, 왜 인시스인가?</a:t>
             </a:r>
             <a:endParaRPr lang="en-US" sz="1050" dirty="0"/>
           </a:p>
@@ -9142,7 +10876,7 @@
                 <a:ea typeface="Noto Sans KR" pitchFamily="34" charset="-122"/>
                 <a:cs typeface="Noto Sans KR" pitchFamily="34" charset="-120"/>
               </a:rPr>
-              <a:t>📌</a:t>
+              <a:t>🔍</a:t>
             </a:r>
             <a:endParaRPr lang="en-US" sz="1400" dirty="0"/>
           </a:p>
@@ -9181,7 +10915,7 @@
                 <a:ea typeface="Noto Sans KR" pitchFamily="34" charset="-122"/>
                 <a:cs typeface="Noto Sans KR" pitchFamily="34" charset="-120"/>
               </a:rPr>
-              <a:t>품질 일관성 확보</a:t>
+              <a:t>검출력 안정화가 관건</a:t>
             </a:r>
             <a:endParaRPr lang="en-US" sz="1200" dirty="0"/>
           </a:p>
@@ -9223,7 +10957,7 @@
                 <a:ea typeface="Noto Sans KR" pitchFamily="34" charset="-122"/>
                 <a:cs typeface="Noto Sans KR" pitchFamily="34" charset="-120"/>
               </a:rPr>
-              <a:t>사람의 판단에 의존하는 검사는</a:t>
+              <a:t>딥러닝 검사는 방향은 분명하나</a:t>
             </a:r>
             <a:endParaRPr lang="en-US" sz="1050" dirty="0"/>
           </a:p>
@@ -9243,7 +10977,7 @@
                 <a:ea typeface="Noto Sans KR" pitchFamily="34" charset="-122"/>
                 <a:cs typeface="Noto Sans KR" pitchFamily="34" charset="-120"/>
               </a:rPr>
-              <a:t>컨디션·환경에 따라 결과가 달라질 수 있습니다.</a:t>
+              <a:t>학습·검출력 안정화 과정이 성패를 가릅니다.</a:t>
             </a:r>
             <a:endParaRPr lang="en-US" sz="1050" dirty="0"/>
           </a:p>
@@ -9341,7 +11075,7 @@
                 <a:ea typeface="Noto Sans KR" pitchFamily="34" charset="-122"/>
                 <a:cs typeface="Noto Sans KR" pitchFamily="34" charset="-120"/>
               </a:rPr>
-              <a:t>📊</a:t>
+              <a:t>🤝</a:t>
             </a:r>
             <a:endParaRPr lang="en-US" sz="1400" dirty="0"/>
           </a:p>
@@ -9380,7 +11114,7 @@
                 <a:ea typeface="Noto Sans KR" pitchFamily="34" charset="-122"/>
                 <a:cs typeface="Noto Sans KR" pitchFamily="34" charset="-120"/>
               </a:rPr>
-              <a:t>데이터 기반 품질관리</a:t>
+              <a:t>검증된 파트너십</a:t>
             </a:r>
             <a:endParaRPr lang="en-US" sz="1200" dirty="0"/>
           </a:p>
@@ -9422,7 +11156,7 @@
                 <a:ea typeface="Noto Sans KR" pitchFamily="34" charset="-122"/>
                 <a:cs typeface="Noto Sans KR" pitchFamily="34" charset="-120"/>
               </a:rPr>
-              <a:t>불량 데이터가 체계적으로 축적되지 않으면</a:t>
+              <a:t>양산 검사기 개발·납품 실적을 보유한</a:t>
             </a:r>
             <a:endParaRPr lang="en-US" sz="1050" dirty="0"/>
           </a:p>
@@ -9442,7 +11176,7 @@
                 <a:ea typeface="Noto Sans KR" pitchFamily="34" charset="-122"/>
                 <a:cs typeface="Noto Sans KR" pitchFamily="34" charset="-120"/>
               </a:rPr>
-              <a:t>공정 개선과 클레임 대응이 어렵습니다.</a:t>
+              <a:t>핵심 엔지니어사와 전략적 협약을 맺고 있습니다.</a:t>
             </a:r>
             <a:endParaRPr lang="en-US" sz="1050" dirty="0"/>
           </a:p>
@@ -9540,7 +11274,7 @@
                 <a:ea typeface="Noto Sans KR" pitchFamily="34" charset="-122"/>
                 <a:cs typeface="Noto Sans KR" pitchFamily="34" charset="-120"/>
               </a:rPr>
-              <a:t>🤖</a:t>
+              <a:t>⚡</a:t>
             </a:r>
             <a:endParaRPr lang="en-US" sz="1400" dirty="0"/>
           </a:p>
@@ -9579,7 +11313,7 @@
                 <a:ea typeface="Noto Sans KR" pitchFamily="34" charset="-122"/>
                 <a:cs typeface="Noto Sans KR" pitchFamily="34" charset="-120"/>
               </a:rPr>
-              <a:t>딥러닝 자동화</a:t>
+              <a:t>더 빠른 결과</a:t>
             </a:r>
             <a:endParaRPr lang="en-US" sz="1200" dirty="0"/>
           </a:p>
@@ -9621,7 +11355,7 @@
                 <a:ea typeface="Noto Sans KR" pitchFamily="34" charset="-122"/>
                 <a:cs typeface="Noto Sans KR" pitchFamily="34" charset="-120"/>
               </a:rPr>
-              <a:t>일관된 기준으로 동일한 품질의 검사를</a:t>
+              <a:t>검증된 노하우로 시행착오를 줄여</a:t>
             </a:r>
             <a:endParaRPr lang="en-US" sz="1050" dirty="0"/>
           </a:p>
@@ -9641,7 +11375,7 @@
                 <a:ea typeface="Noto Sans KR" pitchFamily="34" charset="-122"/>
                 <a:cs typeface="Noto Sans KR" pitchFamily="34" charset="-120"/>
               </a:rPr>
-              <a:t>수행하며 모든 데이터를 자동 누적합니다.</a:t>
+              <a:t>안정적 검출력을 조기에 확보합니다.</a:t>
             </a:r>
             <a:endParaRPr lang="en-US" sz="1050" dirty="0"/>
           </a:p>

</xml_diff>

<commit_message>
Update winnercom.pptx - 검증장비 context, R&D to 인시스
</commit_message>
<xml_diff>
--- a/winnercom.pptx
+++ b/winnercom.pptx
@@ -2404,7 +2404,7 @@
                 <a:ea typeface="Noto Sans KR" pitchFamily="34" charset="-122"/>
                 <a:cs typeface="Noto Sans KR" pitchFamily="34" charset="-120"/>
               </a:rPr>
-              <a:t>1호기는 딥러닝 검출력 검증에 집중, 자동화 기능은 효과 확인 후 협의</a:t>
+              <a:t>검증 장비로 딥러닝 검출력을 먼저 확인, 양산 검사기는 고객 요구사항 반영 제작</a:t>
             </a:r>
             <a:endParaRPr lang="en-US" sz="1050" dirty="0"/>
           </a:p>
@@ -2477,7 +2477,7 @@
                 <a:ea typeface="Noto Sans KR" pitchFamily="34" charset="-122"/>
                 <a:cs typeface="Noto Sans KR" pitchFamily="34" charset="-120"/>
               </a:rPr>
-              <a:t>💡  상호 비용·시간 부담을 최소화하고 빠른 효과 검증을 위해, 1호기는 딥러닝 양불 판정 검증 전용으로 제작합니다.</a:t>
+              <a:t>💡  상호 비용·시간 부담을 최소화하고 빠른 효과 검증을 위해, 검증 장비는 딥러닝 양불 판정 검증 전용으로 제작합니다.</a:t>
             </a:r>
             <a:endParaRPr lang="en-US" sz="950" dirty="0"/>
           </a:p>
@@ -2577,7 +2577,7 @@
                 <a:ea typeface="Noto Sans KR" pitchFamily="34" charset="-122"/>
                 <a:cs typeface="Noto Sans KR" pitchFamily="34" charset="-120"/>
               </a:rPr>
-              <a:t>STEP 1  —  1호기 (검증 전용)</a:t>
+              <a:t>STEP 1  —  검증 장비 (검출력 검증)</a:t>
             </a:r>
             <a:endParaRPr lang="en-US" sz="1100" dirty="0"/>
           </a:p>
@@ -4968,7 +4968,7 @@
                 <a:ea typeface="Noto Sans KR" pitchFamily="34" charset="-122"/>
                 <a:cs typeface="Noto Sans KR" pitchFamily="34" charset="-120"/>
               </a:rPr>
-              <a:t>1호기 제작 기간 약 3~4주  ·  시범 적용 후 검출력 검증  →  결과 기반으로 자동화 확장 여부 결정</a:t>
+              <a:t>검증 장비 제작 약 3~4주  ·  검출력 검증 후  →  고객 요구사항 반영한 양산 검사기 제작·제공</a:t>
             </a:r>
             <a:endParaRPr lang="en-US" sz="1000" dirty="0"/>
           </a:p>
@@ -8791,7 +8791,7 @@
                 <a:ea typeface="Noto Sans KR" pitchFamily="34" charset="-122"/>
                 <a:cs typeface="Noto Sans KR" pitchFamily="34" charset="-120"/>
               </a:rPr>
-              <a:t>양품 샘플을 R&amp;D센터로 제공</a:t>
+              <a:t>양품 샘플을 인시스로 제공</a:t>
             </a:r>
             <a:endParaRPr lang="en-US" sz="950" dirty="0"/>
           </a:p>
@@ -8903,7 +8903,7 @@
                 <a:ea typeface="Noto Sans KR" pitchFamily="34" charset="-122"/>
                 <a:cs typeface="Noto Sans KR" pitchFamily="34" charset="-120"/>
               </a:rPr>
-              <a:t>검토 리포트 수령</a:t>
+              <a:t>검증 장비 제작·검증</a:t>
             </a:r>
             <a:endParaRPr lang="en-US" sz="1200" dirty="0"/>
           </a:p>
@@ -8945,7 +8945,7 @@
                 <a:ea typeface="Noto Sans KR" pitchFamily="34" charset="-122"/>
                 <a:cs typeface="Noto Sans KR" pitchFamily="34" charset="-120"/>
               </a:rPr>
-              <a:t>샘플 분석 후 1~2주 이내</a:t>
+              <a:t>딥러닝 검증 장비 제작 후</a:t>
             </a:r>
             <a:endParaRPr lang="en-US" sz="950" dirty="0"/>
           </a:p>
@@ -8965,7 +8965,7 @@
                 <a:ea typeface="Noto Sans KR" pitchFamily="34" charset="-122"/>
                 <a:cs typeface="Noto Sans KR" pitchFamily="34" charset="-120"/>
               </a:rPr>
-              <a:t>불량 유형 검토 리포트 제출</a:t>
+              <a:t>검사원 대비 검출력 검증</a:t>
             </a:r>
             <a:endParaRPr lang="en-US" sz="950" dirty="0"/>
           </a:p>
@@ -9077,7 +9077,7 @@
                 <a:ea typeface="Noto Sans KR" pitchFamily="34" charset="-122"/>
                 <a:cs typeface="Noto Sans KR" pitchFamily="34" charset="-120"/>
               </a:rPr>
-              <a:t>현장 실사 &amp; 사양 확정</a:t>
+              <a:t>양산 검사기 제공</a:t>
             </a:r>
             <a:endParaRPr lang="en-US" sz="1200" dirty="0"/>
           </a:p>
@@ -9119,7 +9119,7 @@
                 <a:ea typeface="Noto Sans KR" pitchFamily="34" charset="-122"/>
                 <a:cs typeface="Noto Sans KR" pitchFamily="34" charset="-120"/>
               </a:rPr>
-              <a:t>현장 방문 후 맞춤 사양 확정</a:t>
+              <a:t>검증 완료 후 고객 요구사항을</a:t>
             </a:r>
             <a:endParaRPr lang="en-US" sz="950" dirty="0"/>
           </a:p>
@@ -9139,7 +9139,7 @@
                 <a:ea typeface="Noto Sans KR" pitchFamily="34" charset="-122"/>
                 <a:cs typeface="Noto Sans KR" pitchFamily="34" charset="-120"/>
               </a:rPr>
-              <a:t>개발 착수</a:t>
+              <a:t>반영한 양산 검사기 제작·제공</a:t>
             </a:r>
             <a:endParaRPr lang="en-US" sz="950" dirty="0"/>
           </a:p>
@@ -20722,7 +20722,7 @@
                 <a:ea typeface="Noto Sans KR" pitchFamily="34" charset="-122"/>
                 <a:cs typeface="Noto Sans KR" pitchFamily="34" charset="-120"/>
               </a:rPr>
-              <a:t>1호기 도입 후 데이터 자산이 확장의 토대가 됩니다</a:t>
+              <a:t>첫 검사기 도입 후 데이터 자산이 확장의 토대가 됩니다</a:t>
             </a:r>
             <a:endParaRPr lang="en-US" sz="1050" dirty="0"/>
           </a:p>
@@ -20791,7 +20791,7 @@
                 <a:ea typeface="Noto Sans KR" pitchFamily="34" charset="-122"/>
                 <a:cs typeface="Noto Sans KR" pitchFamily="34" charset="-120"/>
               </a:rPr>
-              <a:t>1호기</a:t>
+              <a:t>검증 장비</a:t>
             </a:r>
             <a:endParaRPr lang="en-US" sz="1100" dirty="0"/>
           </a:p>
@@ -21748,7 +21748,7 @@
                 <a:ea typeface="Noto Sans KR" pitchFamily="34" charset="-122"/>
                 <a:cs typeface="Noto Sans KR" pitchFamily="34" charset="-120"/>
               </a:rPr>
-              <a:t>1호기 학습 데이터를 추가 호기에 즉시 적용</a:t>
+              <a:t>축적 학습 데이터를 추가 호기에 즉시 적용</a:t>
             </a:r>
             <a:endParaRPr lang="en-US" sz="900" dirty="0"/>
           </a:p>
@@ -22242,7 +22242,7 @@
                 <a:ea typeface="Noto Sans KR" pitchFamily="34" charset="-122"/>
                 <a:cs typeface="Noto Sans KR" pitchFamily="34" charset="-120"/>
               </a:rPr>
-              <a:t>1호기 도입 후 효과 확인  →  학습 데이터 자산 활용  →  추가 라인 도입 시 개발·학습 기간 단축 및 비용 절감</a:t>
+              <a:t>검사기 도입 후 효과 확인  →  학습 데이터 자산 활용  →  추가 라인 도입 시 개발·학습 기간 단축 및 비용 절감</a:t>
             </a:r>
             <a:endParaRPr lang="en-US" sz="1100" dirty="0"/>
           </a:p>

</xml_diff>

<commit_message>
Update winnercom.pptx - slide6 two concept images
</commit_message>
<xml_diff>
--- a/winnercom.pptx
+++ b/winnercom.pptx
@@ -9841,7 +9841,7 @@
                 <a:ea typeface="Noto Sans KR" pitchFamily="34" charset="-122"/>
                 <a:cs typeface="Noto Sans KR" pitchFamily="34" charset="-120"/>
               </a:rPr>
-              <a:t>설비 컨셉트 이미지 (독립 검사기 예시)</a:t>
+              <a:t>설비 컨셉트 이미지 (검사기 예시 2종)</a:t>
             </a:r>
             <a:endParaRPr lang="en-US" sz="1150" dirty="0"/>
           </a:p>
@@ -16051,7 +16051,7 @@
                 <a:ea typeface="Noto Sans KR" pitchFamily="34" charset="-122"/>
                 <a:cs typeface="Noto Sans KR" pitchFamily="34" charset="-120"/>
               </a:rPr>
-              <a:t>설비 컨셉트 이미지  —  독립적인 검사기 예시</a:t>
+              <a:t>설비 컨셉트 이미지  —  독립형 / 작업대형 검사기 예시</a:t>
             </a:r>
             <a:endParaRPr lang="en-US" sz="1800" dirty="0"/>
           </a:p>
@@ -16073,14 +16073,184 @@
         </p:blipFill>
         <p:spPr>
           <a:xfrm>
-            <a:off x="1812707" y="438912"/>
-            <a:ext cx="5518678" cy="4686300"/>
+            <a:off x="274320" y="850392"/>
+            <a:ext cx="4206240" cy="3571646"/>
           </a:xfrm>
           <a:prstGeom prst="rect">
             <a:avLst/>
           </a:prstGeom>
         </p:spPr>
       </p:pic>
+      <p:sp>
+        <p:nvSpPr>
+          <p:cNvPr id="6" name="Shape 3"/>
+          <p:cNvSpPr/>
+          <p:nvPr/>
+        </p:nvSpPr>
+        <p:spPr>
+          <a:xfrm>
+            <a:off x="274320" y="4498848"/>
+            <a:ext cx="4206240" cy="310896"/>
+          </a:xfrm>
+          <a:prstGeom prst="roundRect">
+            <a:avLst>
+              <a:gd name="adj" fmla="val 20588"/>
+            </a:avLst>
+          </a:prstGeom>
+          <a:solidFill>
+            <a:srgbClr val="12233F"/>
+          </a:solidFill>
+          <a:ln w="12700">
+            <a:solidFill>
+              <a:srgbClr val="2E5EA8"/>
+            </a:solidFill>
+            <a:prstDash val="solid"/>
+          </a:ln>
+          <a:effectLst>
+            <a:outerShdw sx="100000" sy="100000" kx="0" ky="0" algn="bl" rotWithShape="0" blurRad="50800" dist="25400" dir="16200000">
+              <a:srgbClr val="9CA3AF">
+                <a:alpha val="15000"/>
+              </a:srgbClr>
+            </a:outerShdw>
+          </a:effectLst>
+        </p:spPr>
+      </p:sp>
+      <p:sp>
+        <p:nvSpPr>
+          <p:cNvPr id="7" name="Text 4"/>
+          <p:cNvSpPr/>
+          <p:nvPr/>
+        </p:nvSpPr>
+        <p:spPr>
+          <a:xfrm>
+            <a:off x="274320" y="4498848"/>
+            <a:ext cx="4206240" cy="310896"/>
+          </a:xfrm>
+          <a:prstGeom prst="rect">
+            <a:avLst/>
+          </a:prstGeom>
+          <a:noFill/>
+          <a:ln/>
+        </p:spPr>
+        <p:txBody>
+          <a:bodyPr wrap="square" lIns="0" tIns="0" rIns="0" bIns="0" rtlCol="0" anchor="ctr"/>
+          <a:lstStyle/>
+          <a:p>
+            <a:pPr algn="ctr" indent="0" marL="0">
+              <a:buNone/>
+            </a:pPr>
+            <a:r>
+              <a:rPr lang="en-US" sz="1000" b="1" dirty="0">
+                <a:solidFill>
+                  <a:srgbClr val="A5C4F3"/>
+                </a:solidFill>
+                <a:latin typeface="Noto Sans KR" pitchFamily="34" charset="0"/>
+                <a:ea typeface="Noto Sans KR" pitchFamily="34" charset="-122"/>
+                <a:cs typeface="Noto Sans KR" pitchFamily="34" charset="-120"/>
+              </a:rPr>
+              <a:t>① 독립형 검사기 (스탠드 일체형)</a:t>
+            </a:r>
+            <a:endParaRPr lang="en-US" sz="1000" dirty="0"/>
+          </a:p>
+        </p:txBody>
+      </p:sp>
+      <p:pic>
+        <p:nvPicPr>
+          <p:cNvPr id="8" name="Image 1" descr="preencoded.png">    </p:cNvPr>
+          <p:cNvPicPr>
+            <a:picLocks noChangeAspect="1"/>
+          </p:cNvPicPr>
+          <p:nvPr/>
+        </p:nvPicPr>
+        <p:blipFill>
+          <a:blip r:embed="rId2"/>
+          <a:stretch>
+            <a:fillRect/>
+          </a:stretch>
+        </p:blipFill>
+        <p:spPr>
+          <a:xfrm>
+            <a:off x="4663440" y="1234440"/>
+            <a:ext cx="4206240" cy="2808122"/>
+          </a:xfrm>
+          <a:prstGeom prst="rect">
+            <a:avLst/>
+          </a:prstGeom>
+        </p:spPr>
+      </p:pic>
+      <p:sp>
+        <p:nvSpPr>
+          <p:cNvPr id="9" name="Shape 5"/>
+          <p:cNvSpPr/>
+          <p:nvPr/>
+        </p:nvSpPr>
+        <p:spPr>
+          <a:xfrm>
+            <a:off x="4663440" y="4498848"/>
+            <a:ext cx="4206240" cy="310896"/>
+          </a:xfrm>
+          <a:prstGeom prst="roundRect">
+            <a:avLst>
+              <a:gd name="adj" fmla="val 20588"/>
+            </a:avLst>
+          </a:prstGeom>
+          <a:solidFill>
+            <a:srgbClr val="12233F"/>
+          </a:solidFill>
+          <a:ln w="12700">
+            <a:solidFill>
+              <a:srgbClr val="2E5EA8"/>
+            </a:solidFill>
+            <a:prstDash val="solid"/>
+          </a:ln>
+          <a:effectLst>
+            <a:outerShdw sx="100000" sy="100000" kx="0" ky="0" algn="bl" rotWithShape="0" blurRad="50800" dist="25400" dir="16200000">
+              <a:srgbClr val="9CA3AF">
+                <a:alpha val="15000"/>
+              </a:srgbClr>
+            </a:outerShdw>
+          </a:effectLst>
+        </p:spPr>
+      </p:sp>
+      <p:sp>
+        <p:nvSpPr>
+          <p:cNvPr id="10" name="Text 6"/>
+          <p:cNvSpPr/>
+          <p:nvPr/>
+        </p:nvSpPr>
+        <p:spPr>
+          <a:xfrm>
+            <a:off x="4663440" y="4498848"/>
+            <a:ext cx="4206240" cy="310896"/>
+          </a:xfrm>
+          <a:prstGeom prst="rect">
+            <a:avLst/>
+          </a:prstGeom>
+          <a:noFill/>
+          <a:ln/>
+        </p:spPr>
+        <p:txBody>
+          <a:bodyPr wrap="square" lIns="0" tIns="0" rIns="0" bIns="0" rtlCol="0" anchor="ctr"/>
+          <a:lstStyle/>
+          <a:p>
+            <a:pPr algn="ctr" indent="0" marL="0">
+              <a:buNone/>
+            </a:pPr>
+            <a:r>
+              <a:rPr lang="en-US" sz="1000" b="1" dirty="0">
+                <a:solidFill>
+                  <a:srgbClr val="A5C4F3"/>
+                </a:solidFill>
+                <a:latin typeface="Noto Sans KR" pitchFamily="34" charset="0"/>
+                <a:ea typeface="Noto Sans KR" pitchFamily="34" charset="-122"/>
+                <a:cs typeface="Noto Sans KR" pitchFamily="34" charset="-120"/>
+              </a:rPr>
+              <a:t>② 작업대형 검사기 (검사부 + 작업대 분리)</a:t>
+            </a:r>
+            <a:endParaRPr lang="en-US" sz="1000" dirty="0"/>
+          </a:p>
+        </p:txBody>
+      </p:sp>
     </p:spTree>
   </p:cSld>
   <p:clrMapOvr>

</xml_diff>